<commit_message>
Force & Moment Function v2.0
- High fidelity forces and moments model, waiting for the 1st iteration of the “plug-in” functions (rotor, fuselage, empennage and system/structure models).

- More accurate force and moment diagrams.
</commit_message>
<xml_diff>
--- a/HER05/01 - Mathematical Modeling/Sketch/Forces and Moments Sketch.pptx
+++ b/HER05/01 - Mathematical Modeling/Sketch/Forces and Moments Sketch.pptx
@@ -132,7 +132,7 @@
   <pc:docChgLst>
     <pc:chgData name="Li, Hanchen F" userId="3aee791e-6a2d-4da7-a77b-fbdf7bf15886" providerId="ADAL" clId="{CDC5B0EF-6BEB-4658-A9FF-CB66F6FA6C1E}"/>
     <pc:docChg chg="undo redo custSel addSld delSld modSld modMainMaster modNotesMaster">
-      <pc:chgData name="Li, Hanchen F" userId="3aee791e-6a2d-4da7-a77b-fbdf7bf15886" providerId="ADAL" clId="{CDC5B0EF-6BEB-4658-A9FF-CB66F6FA6C1E}" dt="2025-05-24T01:05:10.287" v="8733" actId="20577"/>
+      <pc:chgData name="Li, Hanchen F" userId="3aee791e-6a2d-4da7-a77b-fbdf7bf15886" providerId="ADAL" clId="{CDC5B0EF-6BEB-4658-A9FF-CB66F6FA6C1E}" dt="2025-05-24T18:05:08.571" v="8746" actId="20577"/>
       <pc:docMkLst>
         <pc:docMk/>
       </pc:docMkLst>
@@ -1712,7 +1712,7 @@
         </pc:cxnChg>
       </pc:sldChg>
       <pc:sldChg chg="addSp delSp modSp add mod">
-        <pc:chgData name="Li, Hanchen F" userId="3aee791e-6a2d-4da7-a77b-fbdf7bf15886" providerId="ADAL" clId="{CDC5B0EF-6BEB-4658-A9FF-CB66F6FA6C1E}" dt="2025-05-24T01:05:10.287" v="8733" actId="20577"/>
+        <pc:chgData name="Li, Hanchen F" userId="3aee791e-6a2d-4da7-a77b-fbdf7bf15886" providerId="ADAL" clId="{CDC5B0EF-6BEB-4658-A9FF-CB66F6FA6C1E}" dt="2025-05-24T18:02:17.886" v="8740" actId="20577"/>
         <pc:sldMkLst>
           <pc:docMk/>
           <pc:sldMk cId="3137520481" sldId="257"/>
@@ -1854,7 +1854,7 @@
           </ac:spMkLst>
         </pc:spChg>
         <pc:spChg chg="add mod">
-          <ac:chgData name="Li, Hanchen F" userId="3aee791e-6a2d-4da7-a77b-fbdf7bf15886" providerId="ADAL" clId="{CDC5B0EF-6BEB-4658-A9FF-CB66F6FA6C1E}" dt="2025-05-24T01:05:08.206" v="8732" actId="20577"/>
+          <ac:chgData name="Li, Hanchen F" userId="3aee791e-6a2d-4da7-a77b-fbdf7bf15886" providerId="ADAL" clId="{CDC5B0EF-6BEB-4658-A9FF-CB66F6FA6C1E}" dt="2025-05-24T18:02:17.886" v="8740" actId="20577"/>
           <ac:spMkLst>
             <pc:docMk/>
             <pc:sldMk cId="3137520481" sldId="257"/>
@@ -1862,7 +1862,7 @@
           </ac:spMkLst>
         </pc:spChg>
         <pc:spChg chg="add mod">
-          <ac:chgData name="Li, Hanchen F" userId="3aee791e-6a2d-4da7-a77b-fbdf7bf15886" providerId="ADAL" clId="{CDC5B0EF-6BEB-4658-A9FF-CB66F6FA6C1E}" dt="2025-05-24T01:05:10.287" v="8733" actId="20577"/>
+          <ac:chgData name="Li, Hanchen F" userId="3aee791e-6a2d-4da7-a77b-fbdf7bf15886" providerId="ADAL" clId="{CDC5B0EF-6BEB-4658-A9FF-CB66F6FA6C1E}" dt="2025-05-24T18:02:13.505" v="8736" actId="20577"/>
           <ac:spMkLst>
             <pc:docMk/>
             <pc:sldMk cId="3137520481" sldId="257"/>
@@ -2797,7 +2797,7 @@
         </pc:cxnChg>
       </pc:sldChg>
       <pc:sldChg chg="addSp delSp modSp add mod">
-        <pc:chgData name="Li, Hanchen F" userId="3aee791e-6a2d-4da7-a77b-fbdf7bf15886" providerId="ADAL" clId="{CDC5B0EF-6BEB-4658-A9FF-CB66F6FA6C1E}" dt="2025-05-24T00:38:25.595" v="8353" actId="1076"/>
+        <pc:chgData name="Li, Hanchen F" userId="3aee791e-6a2d-4da7-a77b-fbdf7bf15886" providerId="ADAL" clId="{CDC5B0EF-6BEB-4658-A9FF-CB66F6FA6C1E}" dt="2025-05-24T18:05:08.571" v="8746" actId="20577"/>
         <pc:sldMkLst>
           <pc:docMk/>
           <pc:sldMk cId="3652000193" sldId="259"/>
@@ -2811,7 +2811,7 @@
           </ac:spMkLst>
         </pc:spChg>
         <pc:spChg chg="add mod">
-          <ac:chgData name="Li, Hanchen F" userId="3aee791e-6a2d-4da7-a77b-fbdf7bf15886" providerId="ADAL" clId="{CDC5B0EF-6BEB-4658-A9FF-CB66F6FA6C1E}" dt="2025-05-24T00:38:25.595" v="8353" actId="1076"/>
+          <ac:chgData name="Li, Hanchen F" userId="3aee791e-6a2d-4da7-a77b-fbdf7bf15886" providerId="ADAL" clId="{CDC5B0EF-6BEB-4658-A9FF-CB66F6FA6C1E}" dt="2025-05-24T18:05:08.571" v="8746" actId="20577"/>
           <ac:spMkLst>
             <pc:docMk/>
             <pc:sldMk cId="3652000193" sldId="259"/>
@@ -2923,7 +2923,7 @@
           </ac:spMkLst>
         </pc:spChg>
         <pc:spChg chg="add mod">
-          <ac:chgData name="Li, Hanchen F" userId="3aee791e-6a2d-4da7-a77b-fbdf7bf15886" providerId="ADAL" clId="{CDC5B0EF-6BEB-4658-A9FF-CB66F6FA6C1E}" dt="2025-05-24T00:37:56.522" v="8337" actId="947"/>
+          <ac:chgData name="Li, Hanchen F" userId="3aee791e-6a2d-4da7-a77b-fbdf7bf15886" providerId="ADAL" clId="{CDC5B0EF-6BEB-4658-A9FF-CB66F6FA6C1E}" dt="2025-05-24T18:05:06.600" v="8745" actId="20577"/>
           <ac:spMkLst>
             <pc:docMk/>
             <pc:sldMk cId="3652000193" sldId="259"/>
@@ -10888,7 +10888,7 @@
         <p:spPr>
           <a:xfrm>
             <a:off x="8168427" y="2119692"/>
-            <a:ext cx="492443" cy="338554"/>
+            <a:ext cx="516488" cy="338554"/>
           </a:xfrm>
           <a:prstGeom prst="rect">
             <a:avLst/>
@@ -10935,7 +10935,7 @@
                 <a:ea typeface="等线" panose="02010600030101010101" pitchFamily="2" charset="-122"/>
                 <a:cs typeface="Times New Roman" panose="02020603050405020304" pitchFamily="18" charset="0"/>
               </a:rPr>
-              <a:t>LR</a:t>
+              <a:t>UR</a:t>
             </a:r>
             <a:endParaRPr lang="zh-CN" altLang="en-US" sz="1600" i="1" baseline="-25000" dirty="0">
               <a:solidFill>
@@ -11722,7 +11722,7 @@
         <p:spPr>
           <a:xfrm>
             <a:off x="5386540" y="2063207"/>
-            <a:ext cx="516488" cy="338554"/>
+            <a:ext cx="492443" cy="338554"/>
           </a:xfrm>
           <a:prstGeom prst="rect">
             <a:avLst/>
@@ -11769,7 +11769,7 @@
                 <a:ea typeface="等线" panose="02010600030101010101" pitchFamily="2" charset="-122"/>
                 <a:cs typeface="Times New Roman" panose="02020603050405020304" pitchFamily="18" charset="0"/>
               </a:rPr>
-              <a:t>UR</a:t>
+              <a:t>LR</a:t>
             </a:r>
             <a:endParaRPr lang="zh-CN" altLang="en-US" sz="1600" i="1" baseline="-25000" dirty="0">
               <a:solidFill>
@@ -22732,7 +22732,7 @@
                 <a:latin typeface="Times New Roman" panose="02020603050405020304" pitchFamily="18" charset="0"/>
                 <a:cs typeface="Times New Roman" panose="02020603050405020304" pitchFamily="18" charset="0"/>
               </a:rPr>
-              <a:t>UR</a:t>
+              <a:t>LR</a:t>
             </a:r>
           </a:p>
           <a:p>
@@ -22802,7 +22802,7 @@
                 <a:latin typeface="Times New Roman" panose="02020603050405020304" pitchFamily="18" charset="0"/>
                 <a:cs typeface="Times New Roman" panose="02020603050405020304" pitchFamily="18" charset="0"/>
               </a:rPr>
-              <a:t>LR</a:t>
+              <a:t>UR</a:t>
             </a:r>
           </a:p>
           <a:p>

</xml_diff>

<commit_message>
Forces & Moments Function v2.0
- High fidelity forces and moments model, waiting for the 1st iteration of the “plug-in” functions (rotor, fuselage, empennage and system/structure models).

- More accurate force and moment diagrams.
</commit_message>
<xml_diff>
--- a/HER05/01 - Mathematical Modeling/Sketch/Forces and Moments Sketch.pptx
+++ b/HER05/01 - Mathematical Modeling/Sketch/Forces and Moments Sketch.pptx
@@ -132,7 +132,7 @@
   <pc:docChgLst>
     <pc:chgData name="Li, Hanchen F" userId="3aee791e-6a2d-4da7-a77b-fbdf7bf15886" providerId="ADAL" clId="{CDC5B0EF-6BEB-4658-A9FF-CB66F6FA6C1E}"/>
     <pc:docChg chg="undo redo custSel addSld delSld modSld modMainMaster modNotesMaster">
-      <pc:chgData name="Li, Hanchen F" userId="3aee791e-6a2d-4da7-a77b-fbdf7bf15886" providerId="ADAL" clId="{CDC5B0EF-6BEB-4658-A9FF-CB66F6FA6C1E}" dt="2025-05-24T01:05:10.287" v="8733" actId="20577"/>
+      <pc:chgData name="Li, Hanchen F" userId="3aee791e-6a2d-4da7-a77b-fbdf7bf15886" providerId="ADAL" clId="{CDC5B0EF-6BEB-4658-A9FF-CB66F6FA6C1E}" dt="2025-05-24T18:05:08.571" v="8746" actId="20577"/>
       <pc:docMkLst>
         <pc:docMk/>
       </pc:docMkLst>
@@ -1712,7 +1712,7 @@
         </pc:cxnChg>
       </pc:sldChg>
       <pc:sldChg chg="addSp delSp modSp add mod">
-        <pc:chgData name="Li, Hanchen F" userId="3aee791e-6a2d-4da7-a77b-fbdf7bf15886" providerId="ADAL" clId="{CDC5B0EF-6BEB-4658-A9FF-CB66F6FA6C1E}" dt="2025-05-24T01:05:10.287" v="8733" actId="20577"/>
+        <pc:chgData name="Li, Hanchen F" userId="3aee791e-6a2d-4da7-a77b-fbdf7bf15886" providerId="ADAL" clId="{CDC5B0EF-6BEB-4658-A9FF-CB66F6FA6C1E}" dt="2025-05-24T18:02:17.886" v="8740" actId="20577"/>
         <pc:sldMkLst>
           <pc:docMk/>
           <pc:sldMk cId="3137520481" sldId="257"/>
@@ -1854,7 +1854,7 @@
           </ac:spMkLst>
         </pc:spChg>
         <pc:spChg chg="add mod">
-          <ac:chgData name="Li, Hanchen F" userId="3aee791e-6a2d-4da7-a77b-fbdf7bf15886" providerId="ADAL" clId="{CDC5B0EF-6BEB-4658-A9FF-CB66F6FA6C1E}" dt="2025-05-24T01:05:08.206" v="8732" actId="20577"/>
+          <ac:chgData name="Li, Hanchen F" userId="3aee791e-6a2d-4da7-a77b-fbdf7bf15886" providerId="ADAL" clId="{CDC5B0EF-6BEB-4658-A9FF-CB66F6FA6C1E}" dt="2025-05-24T18:02:17.886" v="8740" actId="20577"/>
           <ac:spMkLst>
             <pc:docMk/>
             <pc:sldMk cId="3137520481" sldId="257"/>
@@ -1862,7 +1862,7 @@
           </ac:spMkLst>
         </pc:spChg>
         <pc:spChg chg="add mod">
-          <ac:chgData name="Li, Hanchen F" userId="3aee791e-6a2d-4da7-a77b-fbdf7bf15886" providerId="ADAL" clId="{CDC5B0EF-6BEB-4658-A9FF-CB66F6FA6C1E}" dt="2025-05-24T01:05:10.287" v="8733" actId="20577"/>
+          <ac:chgData name="Li, Hanchen F" userId="3aee791e-6a2d-4da7-a77b-fbdf7bf15886" providerId="ADAL" clId="{CDC5B0EF-6BEB-4658-A9FF-CB66F6FA6C1E}" dt="2025-05-24T18:02:13.505" v="8736" actId="20577"/>
           <ac:spMkLst>
             <pc:docMk/>
             <pc:sldMk cId="3137520481" sldId="257"/>
@@ -2797,7 +2797,7 @@
         </pc:cxnChg>
       </pc:sldChg>
       <pc:sldChg chg="addSp delSp modSp add mod">
-        <pc:chgData name="Li, Hanchen F" userId="3aee791e-6a2d-4da7-a77b-fbdf7bf15886" providerId="ADAL" clId="{CDC5B0EF-6BEB-4658-A9FF-CB66F6FA6C1E}" dt="2025-05-24T00:38:25.595" v="8353" actId="1076"/>
+        <pc:chgData name="Li, Hanchen F" userId="3aee791e-6a2d-4da7-a77b-fbdf7bf15886" providerId="ADAL" clId="{CDC5B0EF-6BEB-4658-A9FF-CB66F6FA6C1E}" dt="2025-05-24T18:05:08.571" v="8746" actId="20577"/>
         <pc:sldMkLst>
           <pc:docMk/>
           <pc:sldMk cId="3652000193" sldId="259"/>
@@ -2811,7 +2811,7 @@
           </ac:spMkLst>
         </pc:spChg>
         <pc:spChg chg="add mod">
-          <ac:chgData name="Li, Hanchen F" userId="3aee791e-6a2d-4da7-a77b-fbdf7bf15886" providerId="ADAL" clId="{CDC5B0EF-6BEB-4658-A9FF-CB66F6FA6C1E}" dt="2025-05-24T00:38:25.595" v="8353" actId="1076"/>
+          <ac:chgData name="Li, Hanchen F" userId="3aee791e-6a2d-4da7-a77b-fbdf7bf15886" providerId="ADAL" clId="{CDC5B0EF-6BEB-4658-A9FF-CB66F6FA6C1E}" dt="2025-05-24T18:05:08.571" v="8746" actId="20577"/>
           <ac:spMkLst>
             <pc:docMk/>
             <pc:sldMk cId="3652000193" sldId="259"/>
@@ -2923,7 +2923,7 @@
           </ac:spMkLst>
         </pc:spChg>
         <pc:spChg chg="add mod">
-          <ac:chgData name="Li, Hanchen F" userId="3aee791e-6a2d-4da7-a77b-fbdf7bf15886" providerId="ADAL" clId="{CDC5B0EF-6BEB-4658-A9FF-CB66F6FA6C1E}" dt="2025-05-24T00:37:56.522" v="8337" actId="947"/>
+          <ac:chgData name="Li, Hanchen F" userId="3aee791e-6a2d-4da7-a77b-fbdf7bf15886" providerId="ADAL" clId="{CDC5B0EF-6BEB-4658-A9FF-CB66F6FA6C1E}" dt="2025-05-24T18:05:06.600" v="8745" actId="20577"/>
           <ac:spMkLst>
             <pc:docMk/>
             <pc:sldMk cId="3652000193" sldId="259"/>
@@ -10888,7 +10888,7 @@
         <p:spPr>
           <a:xfrm>
             <a:off x="8168427" y="2119692"/>
-            <a:ext cx="492443" cy="338554"/>
+            <a:ext cx="516488" cy="338554"/>
           </a:xfrm>
           <a:prstGeom prst="rect">
             <a:avLst/>
@@ -10935,7 +10935,7 @@
                 <a:ea typeface="等线" panose="02010600030101010101" pitchFamily="2" charset="-122"/>
                 <a:cs typeface="Times New Roman" panose="02020603050405020304" pitchFamily="18" charset="0"/>
               </a:rPr>
-              <a:t>LR</a:t>
+              <a:t>UR</a:t>
             </a:r>
             <a:endParaRPr lang="zh-CN" altLang="en-US" sz="1600" i="1" baseline="-25000" dirty="0">
               <a:solidFill>
@@ -11722,7 +11722,7 @@
         <p:spPr>
           <a:xfrm>
             <a:off x="5386540" y="2063207"/>
-            <a:ext cx="516488" cy="338554"/>
+            <a:ext cx="492443" cy="338554"/>
           </a:xfrm>
           <a:prstGeom prst="rect">
             <a:avLst/>
@@ -11769,7 +11769,7 @@
                 <a:ea typeface="等线" panose="02010600030101010101" pitchFamily="2" charset="-122"/>
                 <a:cs typeface="Times New Roman" panose="02020603050405020304" pitchFamily="18" charset="0"/>
               </a:rPr>
-              <a:t>UR</a:t>
+              <a:t>LR</a:t>
             </a:r>
             <a:endParaRPr lang="zh-CN" altLang="en-US" sz="1600" i="1" baseline="-25000" dirty="0">
               <a:solidFill>
@@ -22732,7 +22732,7 @@
                 <a:latin typeface="Times New Roman" panose="02020603050405020304" pitchFamily="18" charset="0"/>
                 <a:cs typeface="Times New Roman" panose="02020603050405020304" pitchFamily="18" charset="0"/>
               </a:rPr>
-              <a:t>UR</a:t>
+              <a:t>LR</a:t>
             </a:r>
           </a:p>
           <a:p>
@@ -22802,7 +22802,7 @@
                 <a:latin typeface="Times New Roman" panose="02020603050405020304" pitchFamily="18" charset="0"/>
                 <a:cs typeface="Times New Roman" panose="02020603050405020304" pitchFamily="18" charset="0"/>
               </a:rPr>
-              <a:t>LR</a:t>
+              <a:t>UR</a:t>
             </a:r>
           </a:p>
           <a:p>

</xml_diff>

<commit_message>
Force & Moment Function v3.1
- Slightly change of everything based on new model
</commit_message>
<xml_diff>
--- a/HER05/01 - Mathematical Modeling/Sketch/Forces and Moments Sketch.pptx
+++ b/HER05/01 - Mathematical Modeling/Sketch/Forces and Moments Sketch.pptx
@@ -122,7 +122,7 @@
 <file path=ppt/revisionInfo.xml><?xml version="1.0" encoding="utf-8"?>
 <p1510:revInfo xmlns:a="http://schemas.openxmlformats.org/drawingml/2006/main" xmlns:r="http://schemas.openxmlformats.org/officeDocument/2006/relationships" xmlns:p1510="http://schemas.microsoft.com/office/powerpoint/2015/10/main">
   <p1510:revLst>
-    <p1510:client id="{CDC5B0EF-6BEB-4658-A9FF-CB66F6FA6C1E}" v="422" dt="2025-05-26T23:53:54.292"/>
+    <p1510:client id="{CDC5B0EF-6BEB-4658-A9FF-CB66F6FA6C1E}" v="427" dt="2025-05-30T23:12:18.535"/>
   </p1510:revLst>
 </p1510:revInfo>
 </file>
@@ -132,12 +132,12 @@
   <pc:docChgLst>
     <pc:chgData name="Li, Hanchen F" userId="3aee791e-6a2d-4da7-a77b-fbdf7bf15886" providerId="ADAL" clId="{CDC5B0EF-6BEB-4658-A9FF-CB66F6FA6C1E}"/>
     <pc:docChg chg="undo redo custSel addSld delSld modSld modMainMaster modNotesMaster">
-      <pc:chgData name="Li, Hanchen F" userId="3aee791e-6a2d-4da7-a77b-fbdf7bf15886" providerId="ADAL" clId="{CDC5B0EF-6BEB-4658-A9FF-CB66F6FA6C1E}" dt="2025-05-26T23:57:00.737" v="8871" actId="20577"/>
+      <pc:chgData name="Li, Hanchen F" userId="3aee791e-6a2d-4da7-a77b-fbdf7bf15886" providerId="ADAL" clId="{CDC5B0EF-6BEB-4658-A9FF-CB66F6FA6C1E}" dt="2025-05-30T23:13:44.554" v="9565" actId="207"/>
       <pc:docMkLst>
         <pc:docMk/>
       </pc:docMkLst>
       <pc:sldChg chg="addSp delSp modSp new mod">
-        <pc:chgData name="Li, Hanchen F" userId="3aee791e-6a2d-4da7-a77b-fbdf7bf15886" providerId="ADAL" clId="{CDC5B0EF-6BEB-4658-A9FF-CB66F6FA6C1E}" dt="2025-05-26T23:54:02.443" v="8826" actId="1076"/>
+        <pc:chgData name="Li, Hanchen F" userId="3aee791e-6a2d-4da7-a77b-fbdf7bf15886" providerId="ADAL" clId="{CDC5B0EF-6BEB-4658-A9FF-CB66F6FA6C1E}" dt="2025-05-30T23:13:44.554" v="9565" actId="207"/>
         <pc:sldMkLst>
           <pc:docMk/>
           <pc:sldMk cId="2152317508" sldId="256"/>
@@ -167,7 +167,7 @@
           </ac:spMkLst>
         </pc:spChg>
         <pc:spChg chg="add mod">
-          <ac:chgData name="Li, Hanchen F" userId="3aee791e-6a2d-4da7-a77b-fbdf7bf15886" providerId="ADAL" clId="{CDC5B0EF-6BEB-4658-A9FF-CB66F6FA6C1E}" dt="2025-05-23T14:36:17.401" v="6689" actId="1076"/>
+          <ac:chgData name="Li, Hanchen F" userId="3aee791e-6a2d-4da7-a77b-fbdf7bf15886" providerId="ADAL" clId="{CDC5B0EF-6BEB-4658-A9FF-CB66F6FA6C1E}" dt="2025-05-30T23:12:28.017" v="9277" actId="1076"/>
           <ac:spMkLst>
             <pc:docMk/>
             <pc:sldMk cId="2152317508" sldId="256"/>
@@ -215,7 +215,7 @@
           </ac:spMkLst>
         </pc:spChg>
         <pc:spChg chg="add mod">
-          <ac:chgData name="Li, Hanchen F" userId="3aee791e-6a2d-4da7-a77b-fbdf7bf15886" providerId="ADAL" clId="{CDC5B0EF-6BEB-4658-A9FF-CB66F6FA6C1E}" dt="2025-05-26T23:53:05.165" v="8803" actId="1076"/>
+          <ac:chgData name="Li, Hanchen F" userId="3aee791e-6a2d-4da7-a77b-fbdf7bf15886" providerId="ADAL" clId="{CDC5B0EF-6BEB-4658-A9FF-CB66F6FA6C1E}" dt="2025-05-30T23:13:44.554" v="9565" actId="207"/>
           <ac:spMkLst>
             <pc:docMk/>
             <pc:sldMk cId="2152317508" sldId="256"/>
@@ -246,8 +246,16 @@
             <ac:spMk id="16" creationId="{145E91E2-0567-B454-6E6B-0DC473E2A4D0}"/>
           </ac:spMkLst>
         </pc:spChg>
+        <pc:spChg chg="add mod">
+          <ac:chgData name="Li, Hanchen F" userId="3aee791e-6a2d-4da7-a77b-fbdf7bf15886" providerId="ADAL" clId="{CDC5B0EF-6BEB-4658-A9FF-CB66F6FA6C1E}" dt="2025-05-30T22:38:19.093" v="9043" actId="1076"/>
+          <ac:spMkLst>
+            <pc:docMk/>
+            <pc:sldMk cId="2152317508" sldId="256"/>
+            <ac:spMk id="17" creationId="{61D3D5D1-4304-8A52-B7F5-CDFD12DD61BD}"/>
+          </ac:spMkLst>
+        </pc:spChg>
         <pc:spChg chg="add mod topLvl">
-          <ac:chgData name="Li, Hanchen F" userId="3aee791e-6a2d-4da7-a77b-fbdf7bf15886" providerId="ADAL" clId="{CDC5B0EF-6BEB-4658-A9FF-CB66F6FA6C1E}" dt="2025-05-22T23:17:33.494" v="3248" actId="14826"/>
+          <ac:chgData name="Li, Hanchen F" userId="3aee791e-6a2d-4da7-a77b-fbdf7bf15886" providerId="ADAL" clId="{CDC5B0EF-6BEB-4658-A9FF-CB66F6FA6C1E}" dt="2025-05-30T22:35:23.784" v="8872" actId="14826"/>
           <ac:spMkLst>
             <pc:docMk/>
             <pc:sldMk cId="2152317508" sldId="256"/>
@@ -255,7 +263,7 @@
           </ac:spMkLst>
         </pc:spChg>
         <pc:spChg chg="add mod ord topLvl">
-          <ac:chgData name="Li, Hanchen F" userId="3aee791e-6a2d-4da7-a77b-fbdf7bf15886" providerId="ADAL" clId="{CDC5B0EF-6BEB-4658-A9FF-CB66F6FA6C1E}" dt="2025-05-22T23:17:33.494" v="3248" actId="14826"/>
+          <ac:chgData name="Li, Hanchen F" userId="3aee791e-6a2d-4da7-a77b-fbdf7bf15886" providerId="ADAL" clId="{CDC5B0EF-6BEB-4658-A9FF-CB66F6FA6C1E}" dt="2025-05-30T22:35:23.784" v="8872" actId="14826"/>
           <ac:spMkLst>
             <pc:docMk/>
             <pc:sldMk cId="2152317508" sldId="256"/>
@@ -263,7 +271,7 @@
           </ac:spMkLst>
         </pc:spChg>
         <pc:spChg chg="add mod ord topLvl">
-          <ac:chgData name="Li, Hanchen F" userId="3aee791e-6a2d-4da7-a77b-fbdf7bf15886" providerId="ADAL" clId="{CDC5B0EF-6BEB-4658-A9FF-CB66F6FA6C1E}" dt="2025-05-22T23:17:33.494" v="3248" actId="14826"/>
+          <ac:chgData name="Li, Hanchen F" userId="3aee791e-6a2d-4da7-a77b-fbdf7bf15886" providerId="ADAL" clId="{CDC5B0EF-6BEB-4658-A9FF-CB66F6FA6C1E}" dt="2025-05-30T22:35:23.784" v="8872" actId="14826"/>
           <ac:spMkLst>
             <pc:docMk/>
             <pc:sldMk cId="2152317508" sldId="256"/>
@@ -271,7 +279,7 @@
           </ac:spMkLst>
         </pc:spChg>
         <pc:spChg chg="add mod ord topLvl">
-          <ac:chgData name="Li, Hanchen F" userId="3aee791e-6a2d-4da7-a77b-fbdf7bf15886" providerId="ADAL" clId="{CDC5B0EF-6BEB-4658-A9FF-CB66F6FA6C1E}" dt="2025-05-22T23:17:33.494" v="3248" actId="14826"/>
+          <ac:chgData name="Li, Hanchen F" userId="3aee791e-6a2d-4da7-a77b-fbdf7bf15886" providerId="ADAL" clId="{CDC5B0EF-6BEB-4658-A9FF-CB66F6FA6C1E}" dt="2025-05-30T22:35:23.784" v="8872" actId="14826"/>
           <ac:spMkLst>
             <pc:docMk/>
             <pc:sldMk cId="2152317508" sldId="256"/>
@@ -279,7 +287,7 @@
           </ac:spMkLst>
         </pc:spChg>
         <pc:spChg chg="add mod ord topLvl">
-          <ac:chgData name="Li, Hanchen F" userId="3aee791e-6a2d-4da7-a77b-fbdf7bf15886" providerId="ADAL" clId="{CDC5B0EF-6BEB-4658-A9FF-CB66F6FA6C1E}" dt="2025-05-22T23:17:33.494" v="3248" actId="14826"/>
+          <ac:chgData name="Li, Hanchen F" userId="3aee791e-6a2d-4da7-a77b-fbdf7bf15886" providerId="ADAL" clId="{CDC5B0EF-6BEB-4658-A9FF-CB66F6FA6C1E}" dt="2025-05-30T22:35:23.784" v="8872" actId="14826"/>
           <ac:spMkLst>
             <pc:docMk/>
             <pc:sldMk cId="2152317508" sldId="256"/>
@@ -287,7 +295,7 @@
           </ac:spMkLst>
         </pc:spChg>
         <pc:spChg chg="add mod ord topLvl">
-          <ac:chgData name="Li, Hanchen F" userId="3aee791e-6a2d-4da7-a77b-fbdf7bf15886" providerId="ADAL" clId="{CDC5B0EF-6BEB-4658-A9FF-CB66F6FA6C1E}" dt="2025-05-22T23:17:33.494" v="3248" actId="14826"/>
+          <ac:chgData name="Li, Hanchen F" userId="3aee791e-6a2d-4da7-a77b-fbdf7bf15886" providerId="ADAL" clId="{CDC5B0EF-6BEB-4658-A9FF-CB66F6FA6C1E}" dt="2025-05-30T22:35:23.784" v="8872" actId="14826"/>
           <ac:spMkLst>
             <pc:docMk/>
             <pc:sldMk cId="2152317508" sldId="256"/>
@@ -295,7 +303,7 @@
           </ac:spMkLst>
         </pc:spChg>
         <pc:spChg chg="add mod ord topLvl">
-          <ac:chgData name="Li, Hanchen F" userId="3aee791e-6a2d-4da7-a77b-fbdf7bf15886" providerId="ADAL" clId="{CDC5B0EF-6BEB-4658-A9FF-CB66F6FA6C1E}" dt="2025-05-22T23:17:33.494" v="3248" actId="14826"/>
+          <ac:chgData name="Li, Hanchen F" userId="3aee791e-6a2d-4da7-a77b-fbdf7bf15886" providerId="ADAL" clId="{CDC5B0EF-6BEB-4658-A9FF-CB66F6FA6C1E}" dt="2025-05-30T22:35:23.784" v="8872" actId="14826"/>
           <ac:spMkLst>
             <pc:docMk/>
             <pc:sldMk cId="2152317508" sldId="256"/>
@@ -303,7 +311,7 @@
           </ac:spMkLst>
         </pc:spChg>
         <pc:spChg chg="add mod ord topLvl">
-          <ac:chgData name="Li, Hanchen F" userId="3aee791e-6a2d-4da7-a77b-fbdf7bf15886" providerId="ADAL" clId="{CDC5B0EF-6BEB-4658-A9FF-CB66F6FA6C1E}" dt="2025-05-22T23:18:22.360" v="3254" actId="14826"/>
+          <ac:chgData name="Li, Hanchen F" userId="3aee791e-6a2d-4da7-a77b-fbdf7bf15886" providerId="ADAL" clId="{CDC5B0EF-6BEB-4658-A9FF-CB66F6FA6C1E}" dt="2025-05-30T22:47:14.691" v="9166" actId="14826"/>
           <ac:spMkLst>
             <pc:docMk/>
             <pc:sldMk cId="2152317508" sldId="256"/>
@@ -311,7 +319,7 @@
           </ac:spMkLst>
         </pc:spChg>
         <pc:spChg chg="add mod ord topLvl">
-          <ac:chgData name="Li, Hanchen F" userId="3aee791e-6a2d-4da7-a77b-fbdf7bf15886" providerId="ADAL" clId="{CDC5B0EF-6BEB-4658-A9FF-CB66F6FA6C1E}" dt="2025-05-22T23:18:22.360" v="3254" actId="14826"/>
+          <ac:chgData name="Li, Hanchen F" userId="3aee791e-6a2d-4da7-a77b-fbdf7bf15886" providerId="ADAL" clId="{CDC5B0EF-6BEB-4658-A9FF-CB66F6FA6C1E}" dt="2025-05-30T22:47:14.691" v="9166" actId="14826"/>
           <ac:spMkLst>
             <pc:docMk/>
             <pc:sldMk cId="2152317508" sldId="256"/>
@@ -319,7 +327,7 @@
           </ac:spMkLst>
         </pc:spChg>
         <pc:spChg chg="add mod topLvl">
-          <ac:chgData name="Li, Hanchen F" userId="3aee791e-6a2d-4da7-a77b-fbdf7bf15886" providerId="ADAL" clId="{CDC5B0EF-6BEB-4658-A9FF-CB66F6FA6C1E}" dt="2025-05-22T23:18:22.360" v="3254" actId="14826"/>
+          <ac:chgData name="Li, Hanchen F" userId="3aee791e-6a2d-4da7-a77b-fbdf7bf15886" providerId="ADAL" clId="{CDC5B0EF-6BEB-4658-A9FF-CB66F6FA6C1E}" dt="2025-05-30T22:47:14.691" v="9166" actId="14826"/>
           <ac:spMkLst>
             <pc:docMk/>
             <pc:sldMk cId="2152317508" sldId="256"/>
@@ -327,7 +335,7 @@
           </ac:spMkLst>
         </pc:spChg>
         <pc:spChg chg="add mod ord topLvl">
-          <ac:chgData name="Li, Hanchen F" userId="3aee791e-6a2d-4da7-a77b-fbdf7bf15886" providerId="ADAL" clId="{CDC5B0EF-6BEB-4658-A9FF-CB66F6FA6C1E}" dt="2025-05-22T23:18:22.360" v="3254" actId="14826"/>
+          <ac:chgData name="Li, Hanchen F" userId="3aee791e-6a2d-4da7-a77b-fbdf7bf15886" providerId="ADAL" clId="{CDC5B0EF-6BEB-4658-A9FF-CB66F6FA6C1E}" dt="2025-05-30T22:47:14.691" v="9166" actId="14826"/>
           <ac:spMkLst>
             <pc:docMk/>
             <pc:sldMk cId="2152317508" sldId="256"/>
@@ -335,7 +343,7 @@
           </ac:spMkLst>
         </pc:spChg>
         <pc:spChg chg="add mod ord topLvl">
-          <ac:chgData name="Li, Hanchen F" userId="3aee791e-6a2d-4da7-a77b-fbdf7bf15886" providerId="ADAL" clId="{CDC5B0EF-6BEB-4658-A9FF-CB66F6FA6C1E}" dt="2025-05-22T23:18:22.360" v="3254" actId="14826"/>
+          <ac:chgData name="Li, Hanchen F" userId="3aee791e-6a2d-4da7-a77b-fbdf7bf15886" providerId="ADAL" clId="{CDC5B0EF-6BEB-4658-A9FF-CB66F6FA6C1E}" dt="2025-05-30T22:47:14.691" v="9166" actId="14826"/>
           <ac:spMkLst>
             <pc:docMk/>
             <pc:sldMk cId="2152317508" sldId="256"/>
@@ -343,7 +351,7 @@
           </ac:spMkLst>
         </pc:spChg>
         <pc:spChg chg="add mod ord topLvl">
-          <ac:chgData name="Li, Hanchen F" userId="3aee791e-6a2d-4da7-a77b-fbdf7bf15886" providerId="ADAL" clId="{CDC5B0EF-6BEB-4658-A9FF-CB66F6FA6C1E}" dt="2025-05-22T23:18:22.360" v="3254" actId="14826"/>
+          <ac:chgData name="Li, Hanchen F" userId="3aee791e-6a2d-4da7-a77b-fbdf7bf15886" providerId="ADAL" clId="{CDC5B0EF-6BEB-4658-A9FF-CB66F6FA6C1E}" dt="2025-05-30T22:47:14.691" v="9166" actId="14826"/>
           <ac:spMkLst>
             <pc:docMk/>
             <pc:sldMk cId="2152317508" sldId="256"/>
@@ -351,7 +359,7 @@
           </ac:spMkLst>
         </pc:spChg>
         <pc:spChg chg="add mod ord topLvl">
-          <ac:chgData name="Li, Hanchen F" userId="3aee791e-6a2d-4da7-a77b-fbdf7bf15886" providerId="ADAL" clId="{CDC5B0EF-6BEB-4658-A9FF-CB66F6FA6C1E}" dt="2025-05-22T23:18:22.360" v="3254" actId="14826"/>
+          <ac:chgData name="Li, Hanchen F" userId="3aee791e-6a2d-4da7-a77b-fbdf7bf15886" providerId="ADAL" clId="{CDC5B0EF-6BEB-4658-A9FF-CB66F6FA6C1E}" dt="2025-05-30T22:47:14.691" v="9166" actId="14826"/>
           <ac:spMkLst>
             <pc:docMk/>
             <pc:sldMk cId="2152317508" sldId="256"/>
@@ -878,28 +886,12 @@
             <ac:spMk id="669" creationId="{A123FB79-41B3-6095-12D2-8997AD6F70A2}"/>
           </ac:spMkLst>
         </pc:spChg>
-        <pc:spChg chg="add del mod">
-          <ac:chgData name="Li, Hanchen F" userId="3aee791e-6a2d-4da7-a77b-fbdf7bf15886" providerId="ADAL" clId="{CDC5B0EF-6BEB-4658-A9FF-CB66F6FA6C1E}" dt="2025-05-26T23:51:13.039" v="8761" actId="478"/>
-          <ac:spMkLst>
-            <pc:docMk/>
-            <pc:sldMk cId="2152317508" sldId="256"/>
-            <ac:spMk id="671" creationId="{48721D70-ADC2-65F2-CF96-A9148310688B}"/>
-          </ac:spMkLst>
-        </pc:spChg>
         <pc:spChg chg="add mod">
           <ac:chgData name="Li, Hanchen F" userId="3aee791e-6a2d-4da7-a77b-fbdf7bf15886" providerId="ADAL" clId="{CDC5B0EF-6BEB-4658-A9FF-CB66F6FA6C1E}" dt="2025-05-22T23:30:03.370" v="3495" actId="1076"/>
           <ac:spMkLst>
             <pc:docMk/>
             <pc:sldMk cId="2152317508" sldId="256"/>
             <ac:spMk id="672" creationId="{C94978E5-38D3-C72E-4BC7-EA21E8DEA92A}"/>
-          </ac:spMkLst>
-        </pc:spChg>
-        <pc:spChg chg="add del mod">
-          <ac:chgData name="Li, Hanchen F" userId="3aee791e-6a2d-4da7-a77b-fbdf7bf15886" providerId="ADAL" clId="{CDC5B0EF-6BEB-4658-A9FF-CB66F6FA6C1E}" dt="2025-05-26T23:50:53.609" v="8755" actId="478"/>
-          <ac:spMkLst>
-            <pc:docMk/>
-            <pc:sldMk cId="2152317508" sldId="256"/>
-            <ac:spMk id="673" creationId="{5A7B8730-BD7F-1D04-4A62-5FA63DD009A6}"/>
           </ac:spMkLst>
         </pc:spChg>
         <pc:spChg chg="add mod">
@@ -935,7 +927,7 @@
           </ac:spMkLst>
         </pc:spChg>
         <pc:spChg chg="add mod">
-          <ac:chgData name="Li, Hanchen F" userId="3aee791e-6a2d-4da7-a77b-fbdf7bf15886" providerId="ADAL" clId="{CDC5B0EF-6BEB-4658-A9FF-CB66F6FA6C1E}" dt="2025-05-22T23:34:04.617" v="3598" actId="1036"/>
+          <ac:chgData name="Li, Hanchen F" userId="3aee791e-6a2d-4da7-a77b-fbdf7bf15886" providerId="ADAL" clId="{CDC5B0EF-6BEB-4658-A9FF-CB66F6FA6C1E}" dt="2025-05-30T22:40:08.226" v="9065" actId="1076"/>
           <ac:spMkLst>
             <pc:docMk/>
             <pc:sldMk cId="2152317508" sldId="256"/>
@@ -943,7 +935,7 @@
           </ac:spMkLst>
         </pc:spChg>
         <pc:spChg chg="add mod">
-          <ac:chgData name="Li, Hanchen F" userId="3aee791e-6a2d-4da7-a77b-fbdf7bf15886" providerId="ADAL" clId="{CDC5B0EF-6BEB-4658-A9FF-CB66F6FA6C1E}" dt="2025-05-22T23:34:07.702" v="3601" actId="1035"/>
+          <ac:chgData name="Li, Hanchen F" userId="3aee791e-6a2d-4da7-a77b-fbdf7bf15886" providerId="ADAL" clId="{CDC5B0EF-6BEB-4658-A9FF-CB66F6FA6C1E}" dt="2025-05-30T22:40:11.499" v="9066" actId="1076"/>
           <ac:spMkLst>
             <pc:docMk/>
             <pc:sldMk cId="2152317508" sldId="256"/>
@@ -1006,8 +998,8 @@
             <ac:spMk id="691" creationId="{38987C34-3EF9-7FF9-A322-6AC7EAF3701F}"/>
           </ac:spMkLst>
         </pc:spChg>
-        <pc:spChg chg="add mod">
-          <ac:chgData name="Li, Hanchen F" userId="3aee791e-6a2d-4da7-a77b-fbdf7bf15886" providerId="ADAL" clId="{CDC5B0EF-6BEB-4658-A9FF-CB66F6FA6C1E}" dt="2025-05-22T23:39:38.538" v="3765" actId="1076"/>
+        <pc:spChg chg="add del mod">
+          <ac:chgData name="Li, Hanchen F" userId="3aee791e-6a2d-4da7-a77b-fbdf7bf15886" providerId="ADAL" clId="{CDC5B0EF-6BEB-4658-A9FF-CB66F6FA6C1E}" dt="2025-05-30T22:37:43.005" v="9028" actId="478"/>
           <ac:spMkLst>
             <pc:docMk/>
             <pc:sldMk cId="2152317508" sldId="256"/>
@@ -1015,15 +1007,15 @@
           </ac:spMkLst>
         </pc:spChg>
         <pc:spChg chg="add mod">
-          <ac:chgData name="Li, Hanchen F" userId="3aee791e-6a2d-4da7-a77b-fbdf7bf15886" providerId="ADAL" clId="{CDC5B0EF-6BEB-4658-A9FF-CB66F6FA6C1E}" dt="2025-05-22T23:39:52.981" v="3772" actId="1076"/>
+          <ac:chgData name="Li, Hanchen F" userId="3aee791e-6a2d-4da7-a77b-fbdf7bf15886" providerId="ADAL" clId="{CDC5B0EF-6BEB-4658-A9FF-CB66F6FA6C1E}" dt="2025-05-30T22:37:53.628" v="9033" actId="1076"/>
           <ac:spMkLst>
             <pc:docMk/>
             <pc:sldMk cId="2152317508" sldId="256"/>
             <ac:spMk id="694" creationId="{0B589E19-DFFC-1E39-CEEC-5F6428DEC4B7}"/>
           </ac:spMkLst>
         </pc:spChg>
-        <pc:spChg chg="add mod">
-          <ac:chgData name="Li, Hanchen F" userId="3aee791e-6a2d-4da7-a77b-fbdf7bf15886" providerId="ADAL" clId="{CDC5B0EF-6BEB-4658-A9FF-CB66F6FA6C1E}" dt="2025-05-22T23:46:06.214" v="4585" actId="207"/>
+        <pc:spChg chg="add mod ord">
+          <ac:chgData name="Li, Hanchen F" userId="3aee791e-6a2d-4da7-a77b-fbdf7bf15886" providerId="ADAL" clId="{CDC5B0EF-6BEB-4658-A9FF-CB66F6FA6C1E}" dt="2025-05-30T22:41:01.439" v="9077" actId="167"/>
           <ac:spMkLst>
             <pc:docMk/>
             <pc:sldMk cId="2152317508" sldId="256"/>
@@ -1031,7 +1023,7 @@
           </ac:spMkLst>
         </pc:spChg>
         <pc:spChg chg="add mod">
-          <ac:chgData name="Li, Hanchen F" userId="3aee791e-6a2d-4da7-a77b-fbdf7bf15886" providerId="ADAL" clId="{CDC5B0EF-6BEB-4658-A9FF-CB66F6FA6C1E}" dt="2025-05-22T23:46:08.041" v="4608" actId="207"/>
+          <ac:chgData name="Li, Hanchen F" userId="3aee791e-6a2d-4da7-a77b-fbdf7bf15886" providerId="ADAL" clId="{CDC5B0EF-6BEB-4658-A9FF-CB66F6FA6C1E}" dt="2025-05-30T22:45:51.745" v="9154" actId="1076"/>
           <ac:spMkLst>
             <pc:docMk/>
             <pc:sldMk cId="2152317508" sldId="256"/>
@@ -1071,7 +1063,7 @@
           </ac:spMkLst>
         </pc:spChg>
         <pc:spChg chg="add mod">
-          <ac:chgData name="Li, Hanchen F" userId="3aee791e-6a2d-4da7-a77b-fbdf7bf15886" providerId="ADAL" clId="{CDC5B0EF-6BEB-4658-A9FF-CB66F6FA6C1E}" dt="2025-05-22T23:42:42.066" v="3822" actId="1076"/>
+          <ac:chgData name="Li, Hanchen F" userId="3aee791e-6a2d-4da7-a77b-fbdf7bf15886" providerId="ADAL" clId="{CDC5B0EF-6BEB-4658-A9FF-CB66F6FA6C1E}" dt="2025-05-30T22:48:21.102" v="9171" actId="1076"/>
           <ac:spMkLst>
             <pc:docMk/>
             <pc:sldMk cId="2152317508" sldId="256"/>
@@ -1079,7 +1071,7 @@
           </ac:spMkLst>
         </pc:spChg>
         <pc:spChg chg="add mod">
-          <ac:chgData name="Li, Hanchen F" userId="3aee791e-6a2d-4da7-a77b-fbdf7bf15886" providerId="ADAL" clId="{CDC5B0EF-6BEB-4658-A9FF-CB66F6FA6C1E}" dt="2025-05-22T23:43:09.012" v="3836" actId="1076"/>
+          <ac:chgData name="Li, Hanchen F" userId="3aee791e-6a2d-4da7-a77b-fbdf7bf15886" providerId="ADAL" clId="{CDC5B0EF-6BEB-4658-A9FF-CB66F6FA6C1E}" dt="2025-05-30T22:48:14.408" v="9169" actId="1076"/>
           <ac:spMkLst>
             <pc:docMk/>
             <pc:sldMk cId="2152317508" sldId="256"/>
@@ -1087,7 +1079,7 @@
           </ac:spMkLst>
         </pc:spChg>
         <pc:spChg chg="add mod">
-          <ac:chgData name="Li, Hanchen F" userId="3aee791e-6a2d-4da7-a77b-fbdf7bf15886" providerId="ADAL" clId="{CDC5B0EF-6BEB-4658-A9FF-CB66F6FA6C1E}" dt="2025-05-24T00:53:08.040" v="8728" actId="1076"/>
+          <ac:chgData name="Li, Hanchen F" userId="3aee791e-6a2d-4da7-a77b-fbdf7bf15886" providerId="ADAL" clId="{CDC5B0EF-6BEB-4658-A9FF-CB66F6FA6C1E}" dt="2025-05-30T22:48:19.545" v="9170" actId="1076"/>
           <ac:spMkLst>
             <pc:docMk/>
             <pc:sldMk cId="2152317508" sldId="256"/>
@@ -1102,14 +1094,6 @@
             <ac:spMk id="736" creationId="{EE4076E9-DC44-CB9F-E117-46DA295CF84E}"/>
           </ac:spMkLst>
         </pc:spChg>
-        <pc:spChg chg="add del mod">
-          <ac:chgData name="Li, Hanchen F" userId="3aee791e-6a2d-4da7-a77b-fbdf7bf15886" providerId="ADAL" clId="{CDC5B0EF-6BEB-4658-A9FF-CB66F6FA6C1E}" dt="2025-05-26T23:52:14.060" v="8785" actId="478"/>
-          <ac:spMkLst>
-            <pc:docMk/>
-            <pc:sldMk cId="2152317508" sldId="256"/>
-            <ac:spMk id="737" creationId="{94D702E4-E09F-8517-606F-3C66E6865576}"/>
-          </ac:spMkLst>
-        </pc:spChg>
         <pc:spChg chg="add mod">
           <ac:chgData name="Li, Hanchen F" userId="3aee791e-6a2d-4da7-a77b-fbdf7bf15886" providerId="ADAL" clId="{CDC5B0EF-6BEB-4658-A9FF-CB66F6FA6C1E}" dt="2025-05-22T23:46:54.319" v="4873" actId="207"/>
           <ac:spMkLst>
@@ -1126,38 +1110,6 @@
             <ac:spMk id="739" creationId="{6D3DA571-6C18-4EFE-ED2A-063D2F002717}"/>
           </ac:spMkLst>
         </pc:spChg>
-        <pc:spChg chg="add del mod">
-          <ac:chgData name="Li, Hanchen F" userId="3aee791e-6a2d-4da7-a77b-fbdf7bf15886" providerId="ADAL" clId="{CDC5B0EF-6BEB-4658-A9FF-CB66F6FA6C1E}" dt="2025-05-26T23:53:32.499" v="8813" actId="478"/>
-          <ac:spMkLst>
-            <pc:docMk/>
-            <pc:sldMk cId="2152317508" sldId="256"/>
-            <ac:spMk id="740" creationId="{5C05FDFA-069A-1211-391D-6535C7B3AB3F}"/>
-          </ac:spMkLst>
-        </pc:spChg>
-        <pc:spChg chg="add del mod">
-          <ac:chgData name="Li, Hanchen F" userId="3aee791e-6a2d-4da7-a77b-fbdf7bf15886" providerId="ADAL" clId="{CDC5B0EF-6BEB-4658-A9FF-CB66F6FA6C1E}" dt="2025-05-26T23:53:18.669" v="8808" actId="478"/>
-          <ac:spMkLst>
-            <pc:docMk/>
-            <pc:sldMk cId="2152317508" sldId="256"/>
-            <ac:spMk id="741" creationId="{C3BB3AE5-380E-3C8F-7915-31796B6B7783}"/>
-          </ac:spMkLst>
-        </pc:spChg>
-        <pc:spChg chg="add del mod">
-          <ac:chgData name="Li, Hanchen F" userId="3aee791e-6a2d-4da7-a77b-fbdf7bf15886" providerId="ADAL" clId="{CDC5B0EF-6BEB-4658-A9FF-CB66F6FA6C1E}" dt="2025-05-26T23:52:49.447" v="8798" actId="478"/>
-          <ac:spMkLst>
-            <pc:docMk/>
-            <pc:sldMk cId="2152317508" sldId="256"/>
-            <ac:spMk id="742" creationId="{52B53972-AFE9-F924-2D9E-BB933025E733}"/>
-          </ac:spMkLst>
-        </pc:spChg>
-        <pc:spChg chg="add del mod">
-          <ac:chgData name="Li, Hanchen F" userId="3aee791e-6a2d-4da7-a77b-fbdf7bf15886" providerId="ADAL" clId="{CDC5B0EF-6BEB-4658-A9FF-CB66F6FA6C1E}" dt="2025-05-26T23:52:37.750" v="8793" actId="478"/>
-          <ac:spMkLst>
-            <pc:docMk/>
-            <pc:sldMk cId="2152317508" sldId="256"/>
-            <ac:spMk id="743" creationId="{4A4AA55F-5428-4951-AFB7-460E89C61A98}"/>
-          </ac:spMkLst>
-        </pc:spChg>
         <pc:spChg chg="add mod">
           <ac:chgData name="Li, Hanchen F" userId="3aee791e-6a2d-4da7-a77b-fbdf7bf15886" providerId="ADAL" clId="{CDC5B0EF-6BEB-4658-A9FF-CB66F6FA6C1E}" dt="2025-05-22T23:48:52.825" v="5002" actId="1076"/>
           <ac:spMkLst>
@@ -1214,14 +1166,6 @@
             <ac:spMk id="750" creationId="{2864E7F6-D1E7-8631-D443-4B6B887CD189}"/>
           </ac:spMkLst>
         </pc:spChg>
-        <pc:spChg chg="add del mod">
-          <ac:chgData name="Li, Hanchen F" userId="3aee791e-6a2d-4da7-a77b-fbdf7bf15886" providerId="ADAL" clId="{CDC5B0EF-6BEB-4658-A9FF-CB66F6FA6C1E}" dt="2025-05-26T23:53:54.086" v="8820" actId="478"/>
-          <ac:spMkLst>
-            <pc:docMk/>
-            <pc:sldMk cId="2152317508" sldId="256"/>
-            <ac:spMk id="751" creationId="{8681218D-9205-44F7-6506-CC2120DF707D}"/>
-          </ac:spMkLst>
-        </pc:spChg>
         <pc:spChg chg="add mod">
           <ac:chgData name="Li, Hanchen F" userId="3aee791e-6a2d-4da7-a77b-fbdf7bf15886" providerId="ADAL" clId="{CDC5B0EF-6BEB-4658-A9FF-CB66F6FA6C1E}" dt="2025-05-22T23:53:20.828" v="5588" actId="1076"/>
           <ac:spMkLst>
@@ -1239,7 +1183,7 @@
           </ac:spMkLst>
         </pc:spChg>
         <pc:spChg chg="add mod">
-          <ac:chgData name="Li, Hanchen F" userId="3aee791e-6a2d-4da7-a77b-fbdf7bf15886" providerId="ADAL" clId="{CDC5B0EF-6BEB-4658-A9FF-CB66F6FA6C1E}" dt="2025-05-22T23:54:41.828" v="5815" actId="1076"/>
+          <ac:chgData name="Li, Hanchen F" userId="3aee791e-6a2d-4da7-a77b-fbdf7bf15886" providerId="ADAL" clId="{CDC5B0EF-6BEB-4658-A9FF-CB66F6FA6C1E}" dt="2025-05-30T22:47:29.897" v="9168" actId="1076"/>
           <ac:spMkLst>
             <pc:docMk/>
             <pc:sldMk cId="2152317508" sldId="256"/>
@@ -1247,7 +1191,7 @@
           </ac:spMkLst>
         </pc:spChg>
         <pc:grpChg chg="add mod">
-          <ac:chgData name="Li, Hanchen F" userId="3aee791e-6a2d-4da7-a77b-fbdf7bf15886" providerId="ADAL" clId="{CDC5B0EF-6BEB-4658-A9FF-CB66F6FA6C1E}" dt="2025-05-26T23:53:07.061" v="8805" actId="1076"/>
+          <ac:chgData name="Li, Hanchen F" userId="3aee791e-6a2d-4da7-a77b-fbdf7bf15886" providerId="ADAL" clId="{CDC5B0EF-6BEB-4658-A9FF-CB66F6FA6C1E}" dt="2025-05-30T22:47:14.691" v="9166" actId="14826"/>
           <ac:grpSpMkLst>
             <pc:docMk/>
             <pc:sldMk cId="2152317508" sldId="256"/>
@@ -1263,7 +1207,7 @@
           </ac:grpSpMkLst>
         </pc:grpChg>
         <pc:grpChg chg="add mod">
-          <ac:chgData name="Li, Hanchen F" userId="3aee791e-6a2d-4da7-a77b-fbdf7bf15886" providerId="ADAL" clId="{CDC5B0EF-6BEB-4658-A9FF-CB66F6FA6C1E}" dt="2025-05-22T23:17:33.494" v="3248" actId="14826"/>
+          <ac:chgData name="Li, Hanchen F" userId="3aee791e-6a2d-4da7-a77b-fbdf7bf15886" providerId="ADAL" clId="{CDC5B0EF-6BEB-4658-A9FF-CB66F6FA6C1E}" dt="2025-05-30T22:35:23.784" v="8872" actId="14826"/>
           <ac:grpSpMkLst>
             <pc:docMk/>
             <pc:sldMk cId="2152317508" sldId="256"/>
@@ -1271,7 +1215,7 @@
           </ac:grpSpMkLst>
         </pc:grpChg>
         <pc:grpChg chg="add del mod ord">
-          <ac:chgData name="Li, Hanchen F" userId="3aee791e-6a2d-4da7-a77b-fbdf7bf15886" providerId="ADAL" clId="{CDC5B0EF-6BEB-4658-A9FF-CB66F6FA6C1E}" dt="2025-05-26T23:51:45.095" v="8774" actId="1076"/>
+          <ac:chgData name="Li, Hanchen F" userId="3aee791e-6a2d-4da7-a77b-fbdf7bf15886" providerId="ADAL" clId="{CDC5B0EF-6BEB-4658-A9FF-CB66F6FA6C1E}" dt="2025-05-30T22:45:11.512" v="9146" actId="167"/>
           <ac:grpSpMkLst>
             <pc:docMk/>
             <pc:sldMk cId="2152317508" sldId="256"/>
@@ -1295,7 +1239,7 @@
           </ac:grpSpMkLst>
         </pc:grpChg>
         <pc:picChg chg="add mod ord topLvl">
-          <ac:chgData name="Li, Hanchen F" userId="3aee791e-6a2d-4da7-a77b-fbdf7bf15886" providerId="ADAL" clId="{CDC5B0EF-6BEB-4658-A9FF-CB66F6FA6C1E}" dt="2025-05-22T23:17:33.494" v="3248" actId="14826"/>
+          <ac:chgData name="Li, Hanchen F" userId="3aee791e-6a2d-4da7-a77b-fbdf7bf15886" providerId="ADAL" clId="{CDC5B0EF-6BEB-4658-A9FF-CB66F6FA6C1E}" dt="2025-05-30T22:44:35.728" v="9127" actId="167"/>
           <ac:picMkLst>
             <pc:docMk/>
             <pc:sldMk cId="2152317508" sldId="256"/>
@@ -1303,7 +1247,7 @@
           </ac:picMkLst>
         </pc:picChg>
         <pc:picChg chg="add del mod ord topLvl">
-          <ac:chgData name="Li, Hanchen F" userId="3aee791e-6a2d-4da7-a77b-fbdf7bf15886" providerId="ADAL" clId="{CDC5B0EF-6BEB-4658-A9FF-CB66F6FA6C1E}" dt="2025-05-22T23:23:16.886" v="3356" actId="478"/>
+          <ac:chgData name="Li, Hanchen F" userId="3aee791e-6a2d-4da7-a77b-fbdf7bf15886" providerId="ADAL" clId="{CDC5B0EF-6BEB-4658-A9FF-CB66F6FA6C1E}" dt="2025-05-30T23:12:04.591" v="9269" actId="1076"/>
           <ac:picMkLst>
             <pc:docMk/>
             <pc:sldMk cId="2152317508" sldId="256"/>
@@ -1327,7 +1271,7 @@
           </ac:cxnSpMkLst>
         </pc:cxnChg>
         <pc:cxnChg chg="add mod">
-          <ac:chgData name="Li, Hanchen F" userId="3aee791e-6a2d-4da7-a77b-fbdf7bf15886" providerId="ADAL" clId="{CDC5B0EF-6BEB-4658-A9FF-CB66F6FA6C1E}" dt="2025-05-22T22:35:21.362" v="2531" actId="164"/>
+          <ac:chgData name="Li, Hanchen F" userId="3aee791e-6a2d-4da7-a77b-fbdf7bf15886" providerId="ADAL" clId="{CDC5B0EF-6BEB-4658-A9FF-CB66F6FA6C1E}" dt="2025-05-30T22:39:44.064" v="9060" actId="14100"/>
           <ac:cxnSpMkLst>
             <pc:docMk/>
             <pc:sldMk cId="2152317508" sldId="256"/>
@@ -1335,7 +1279,15 @@
           </ac:cxnSpMkLst>
         </pc:cxnChg>
         <pc:cxnChg chg="add mod">
-          <ac:chgData name="Li, Hanchen F" userId="3aee791e-6a2d-4da7-a77b-fbdf7bf15886" providerId="ADAL" clId="{CDC5B0EF-6BEB-4658-A9FF-CB66F6FA6C1E}" dt="2025-05-22T22:15:31.910" v="1304" actId="1035"/>
+          <ac:chgData name="Li, Hanchen F" userId="3aee791e-6a2d-4da7-a77b-fbdf7bf15886" providerId="ADAL" clId="{CDC5B0EF-6BEB-4658-A9FF-CB66F6FA6C1E}" dt="2025-05-30T23:12:23.380" v="9276" actId="1076"/>
+          <ac:cxnSpMkLst>
+            <pc:docMk/>
+            <pc:sldMk cId="2152317508" sldId="256"/>
+            <ac:cxnSpMk id="20" creationId="{A63BF9C7-983F-5C2B-2264-47912110C621}"/>
+          </ac:cxnSpMkLst>
+        </pc:cxnChg>
+        <pc:cxnChg chg="add mod">
+          <ac:chgData name="Li, Hanchen F" userId="3aee791e-6a2d-4da7-a77b-fbdf7bf15886" providerId="ADAL" clId="{CDC5B0EF-6BEB-4658-A9FF-CB66F6FA6C1E}" dt="2025-05-30T22:44:41.093" v="9136" actId="14100"/>
           <ac:cxnSpMkLst>
             <pc:docMk/>
             <pc:sldMk cId="2152317508" sldId="256"/>
@@ -1351,7 +1303,7 @@
           </ac:cxnSpMkLst>
         </pc:cxnChg>
         <pc:cxnChg chg="add mod">
-          <ac:chgData name="Li, Hanchen F" userId="3aee791e-6a2d-4da7-a77b-fbdf7bf15886" providerId="ADAL" clId="{CDC5B0EF-6BEB-4658-A9FF-CB66F6FA6C1E}" dt="2025-05-22T22:27:21.828" v="2184" actId="1038"/>
+          <ac:chgData name="Li, Hanchen F" userId="3aee791e-6a2d-4da7-a77b-fbdf7bf15886" providerId="ADAL" clId="{CDC5B0EF-6BEB-4658-A9FF-CB66F6FA6C1E}" dt="2025-05-30T22:38:48.245" v="9046" actId="1076"/>
           <ac:cxnSpMkLst>
             <pc:docMk/>
             <pc:sldMk cId="2152317508" sldId="256"/>
@@ -1359,7 +1311,7 @@
           </ac:cxnSpMkLst>
         </pc:cxnChg>
         <pc:cxnChg chg="add mod">
-          <ac:chgData name="Li, Hanchen F" userId="3aee791e-6a2d-4da7-a77b-fbdf7bf15886" providerId="ADAL" clId="{CDC5B0EF-6BEB-4658-A9FF-CB66F6FA6C1E}" dt="2025-05-22T23:38:35.462" v="3733" actId="1076"/>
+          <ac:chgData name="Li, Hanchen F" userId="3aee791e-6a2d-4da7-a77b-fbdf7bf15886" providerId="ADAL" clId="{CDC5B0EF-6BEB-4658-A9FF-CB66F6FA6C1E}" dt="2025-05-30T22:38:09.622" v="9038" actId="1076"/>
           <ac:cxnSpMkLst>
             <pc:docMk/>
             <pc:sldMk cId="2152317508" sldId="256"/>
@@ -1367,23 +1319,23 @@
           </ac:cxnSpMkLst>
         </pc:cxnChg>
         <pc:cxnChg chg="add mod">
-          <ac:chgData name="Li, Hanchen F" userId="3aee791e-6a2d-4da7-a77b-fbdf7bf15886" providerId="ADAL" clId="{CDC5B0EF-6BEB-4658-A9FF-CB66F6FA6C1E}" dt="2025-05-22T23:39:10.400" v="3753" actId="1076"/>
+          <ac:chgData name="Li, Hanchen F" userId="3aee791e-6a2d-4da7-a77b-fbdf7bf15886" providerId="ADAL" clId="{CDC5B0EF-6BEB-4658-A9FF-CB66F6FA6C1E}" dt="2025-05-30T22:37:53.372" v="9032" actId="1076"/>
           <ac:cxnSpMkLst>
             <pc:docMk/>
             <pc:sldMk cId="2152317508" sldId="256"/>
             <ac:cxnSpMk id="80" creationId="{0DF3227B-686C-F0EC-2E2F-EB029E531004}"/>
           </ac:cxnSpMkLst>
         </pc:cxnChg>
-        <pc:cxnChg chg="add mod">
-          <ac:chgData name="Li, Hanchen F" userId="3aee791e-6a2d-4da7-a77b-fbdf7bf15886" providerId="ADAL" clId="{CDC5B0EF-6BEB-4658-A9FF-CB66F6FA6C1E}" dt="2025-05-22T22:08:46.129" v="1101" actId="1076"/>
+        <pc:cxnChg chg="add del mod">
+          <ac:chgData name="Li, Hanchen F" userId="3aee791e-6a2d-4da7-a77b-fbdf7bf15886" providerId="ADAL" clId="{CDC5B0EF-6BEB-4658-A9FF-CB66F6FA6C1E}" dt="2025-05-30T22:46:06.154" v="9158" actId="478"/>
           <ac:cxnSpMkLst>
             <pc:docMk/>
             <pc:sldMk cId="2152317508" sldId="256"/>
             <ac:cxnSpMk id="84" creationId="{79D2A366-B413-8528-AC73-86E9F16DB2B7}"/>
           </ac:cxnSpMkLst>
         </pc:cxnChg>
-        <pc:cxnChg chg="add mod">
-          <ac:chgData name="Li, Hanchen F" userId="3aee791e-6a2d-4da7-a77b-fbdf7bf15886" providerId="ADAL" clId="{CDC5B0EF-6BEB-4658-A9FF-CB66F6FA6C1E}" dt="2025-05-22T23:40:57.291" v="3792" actId="1076"/>
+        <pc:cxnChg chg="add del mod">
+          <ac:chgData name="Li, Hanchen F" userId="3aee791e-6a2d-4da7-a77b-fbdf7bf15886" providerId="ADAL" clId="{CDC5B0EF-6BEB-4658-A9FF-CB66F6FA6C1E}" dt="2025-05-30T22:46:04.747" v="9157" actId="478"/>
           <ac:cxnSpMkLst>
             <pc:docMk/>
             <pc:sldMk cId="2152317508" sldId="256"/>
@@ -1391,15 +1343,15 @@
           </ac:cxnSpMkLst>
         </pc:cxnChg>
         <pc:cxnChg chg="add mod">
-          <ac:chgData name="Li, Hanchen F" userId="3aee791e-6a2d-4da7-a77b-fbdf7bf15886" providerId="ADAL" clId="{CDC5B0EF-6BEB-4658-A9FF-CB66F6FA6C1E}" dt="2025-05-22T22:34:52.852" v="2520" actId="164"/>
+          <ac:chgData name="Li, Hanchen F" userId="3aee791e-6a2d-4da7-a77b-fbdf7bf15886" providerId="ADAL" clId="{CDC5B0EF-6BEB-4658-A9FF-CB66F6FA6C1E}" dt="2025-05-30T22:41:09.377" v="9078" actId="1076"/>
           <ac:cxnSpMkLst>
             <pc:docMk/>
             <pc:sldMk cId="2152317508" sldId="256"/>
             <ac:cxnSpMk id="94" creationId="{DA2ED6A2-FE0D-9D42-8814-4B6D1D221CDC}"/>
           </ac:cxnSpMkLst>
         </pc:cxnChg>
-        <pc:cxnChg chg="add mod">
-          <ac:chgData name="Li, Hanchen F" userId="3aee791e-6a2d-4da7-a77b-fbdf7bf15886" providerId="ADAL" clId="{CDC5B0EF-6BEB-4658-A9FF-CB66F6FA6C1E}" dt="2025-05-22T23:40:47.629" v="3791" actId="1076"/>
+        <pc:cxnChg chg="add mod ord">
+          <ac:chgData name="Li, Hanchen F" userId="3aee791e-6a2d-4da7-a77b-fbdf7bf15886" providerId="ADAL" clId="{CDC5B0EF-6BEB-4658-A9FF-CB66F6FA6C1E}" dt="2025-05-30T22:45:27.302" v="9151" actId="14100"/>
           <ac:cxnSpMkLst>
             <pc:docMk/>
             <pc:sldMk cId="2152317508" sldId="256"/>
@@ -1439,7 +1391,7 @@
           </ac:cxnSpMkLst>
         </pc:cxnChg>
         <pc:cxnChg chg="add mod">
-          <ac:chgData name="Li, Hanchen F" userId="3aee791e-6a2d-4da7-a77b-fbdf7bf15886" providerId="ADAL" clId="{CDC5B0EF-6BEB-4658-A9FF-CB66F6FA6C1E}" dt="2025-05-22T22:15:28.854" v="1300" actId="14100"/>
+          <ac:chgData name="Li, Hanchen F" userId="3aee791e-6a2d-4da7-a77b-fbdf7bf15886" providerId="ADAL" clId="{CDC5B0EF-6BEB-4658-A9FF-CB66F6FA6C1E}" dt="2025-05-30T22:44:41.487" v="9137" actId="1076"/>
           <ac:cxnSpMkLst>
             <pc:docMk/>
             <pc:sldMk cId="2152317508" sldId="256"/>
@@ -1479,7 +1431,7 @@
           </ac:cxnSpMkLst>
         </pc:cxnChg>
         <pc:cxnChg chg="add mod">
-          <ac:chgData name="Li, Hanchen F" userId="3aee791e-6a2d-4da7-a77b-fbdf7bf15886" providerId="ADAL" clId="{CDC5B0EF-6BEB-4658-A9FF-CB66F6FA6C1E}" dt="2025-05-22T22:16:13.104" v="1363" actId="14100"/>
+          <ac:chgData name="Li, Hanchen F" userId="3aee791e-6a2d-4da7-a77b-fbdf7bf15886" providerId="ADAL" clId="{CDC5B0EF-6BEB-4658-A9FF-CB66F6FA6C1E}" dt="2025-05-30T22:46:35.919" v="9161" actId="1076"/>
           <ac:cxnSpMkLst>
             <pc:docMk/>
             <pc:sldMk cId="2152317508" sldId="256"/>
@@ -1487,15 +1439,15 @@
           </ac:cxnSpMkLst>
         </pc:cxnChg>
         <pc:cxnChg chg="add mod">
-          <ac:chgData name="Li, Hanchen F" userId="3aee791e-6a2d-4da7-a77b-fbdf7bf15886" providerId="ADAL" clId="{CDC5B0EF-6BEB-4658-A9FF-CB66F6FA6C1E}" dt="2025-05-22T22:17:03.109" v="1379" actId="14100"/>
+          <ac:chgData name="Li, Hanchen F" userId="3aee791e-6a2d-4da7-a77b-fbdf7bf15886" providerId="ADAL" clId="{CDC5B0EF-6BEB-4658-A9FF-CB66F6FA6C1E}" dt="2025-05-30T22:46:11.159" v="9159" actId="1076"/>
           <ac:cxnSpMkLst>
             <pc:docMk/>
             <pc:sldMk cId="2152317508" sldId="256"/>
             <ac:cxnSpMk id="207" creationId="{4C46DF6A-5C94-74EB-A688-418C8D97B29B}"/>
           </ac:cxnSpMkLst>
         </pc:cxnChg>
-        <pc:cxnChg chg="add mod">
-          <ac:chgData name="Li, Hanchen F" userId="3aee791e-6a2d-4da7-a77b-fbdf7bf15886" providerId="ADAL" clId="{CDC5B0EF-6BEB-4658-A9FF-CB66F6FA6C1E}" dt="2025-05-22T22:17:05.963" v="1380" actId="14100"/>
+        <pc:cxnChg chg="add mod ord">
+          <ac:chgData name="Li, Hanchen F" userId="3aee791e-6a2d-4da7-a77b-fbdf7bf15886" providerId="ADAL" clId="{CDC5B0EF-6BEB-4658-A9FF-CB66F6FA6C1E}" dt="2025-05-30T22:46:18.171" v="9160" actId="1076"/>
           <ac:cxnSpMkLst>
             <pc:docMk/>
             <pc:sldMk cId="2152317508" sldId="256"/>
@@ -1527,7 +1479,7 @@
           </ac:cxnSpMkLst>
         </pc:cxnChg>
         <pc:cxnChg chg="add del mod">
-          <ac:chgData name="Li, Hanchen F" userId="3aee791e-6a2d-4da7-a77b-fbdf7bf15886" providerId="ADAL" clId="{CDC5B0EF-6BEB-4658-A9FF-CB66F6FA6C1E}" dt="2025-05-22T23:36:39.847" v="3682" actId="478"/>
+          <ac:chgData name="Li, Hanchen F" userId="3aee791e-6a2d-4da7-a77b-fbdf7bf15886" providerId="ADAL" clId="{CDC5B0EF-6BEB-4658-A9FF-CB66F6FA6C1E}" dt="2025-05-30T23:12:08.002" v="9270" actId="1076"/>
           <ac:cxnSpMkLst>
             <pc:docMk/>
             <pc:sldMk cId="2152317508" sldId="256"/>
@@ -1543,7 +1495,7 @@
           </ac:cxnSpMkLst>
         </pc:cxnChg>
         <pc:cxnChg chg="add del mod">
-          <ac:chgData name="Li, Hanchen F" userId="3aee791e-6a2d-4da7-a77b-fbdf7bf15886" providerId="ADAL" clId="{CDC5B0EF-6BEB-4658-A9FF-CB66F6FA6C1E}" dt="2025-05-22T23:36:40.186" v="3683" actId="478"/>
+          <ac:chgData name="Li, Hanchen F" userId="3aee791e-6a2d-4da7-a77b-fbdf7bf15886" providerId="ADAL" clId="{CDC5B0EF-6BEB-4658-A9FF-CB66F6FA6C1E}" dt="2025-05-30T23:12:12.430" v="9273" actId="478"/>
           <ac:cxnSpMkLst>
             <pc:docMk/>
             <pc:sldMk cId="2152317508" sldId="256"/>
@@ -1575,7 +1527,7 @@
           </ac:cxnSpMkLst>
         </pc:cxnChg>
         <pc:cxnChg chg="add mod">
-          <ac:chgData name="Li, Hanchen F" userId="3aee791e-6a2d-4da7-a77b-fbdf7bf15886" providerId="ADAL" clId="{CDC5B0EF-6BEB-4658-A9FF-CB66F6FA6C1E}" dt="2025-05-22T22:24:28.680" v="2036" actId="1037"/>
+          <ac:chgData name="Li, Hanchen F" userId="3aee791e-6a2d-4da7-a77b-fbdf7bf15886" providerId="ADAL" clId="{CDC5B0EF-6BEB-4658-A9FF-CB66F6FA6C1E}" dt="2025-05-30T23:13:08.181" v="9279" actId="1076"/>
           <ac:cxnSpMkLst>
             <pc:docMk/>
             <pc:sldMk cId="2152317508" sldId="256"/>
@@ -1583,7 +1535,7 @@
           </ac:cxnSpMkLst>
         </pc:cxnChg>
         <pc:cxnChg chg="add mod">
-          <ac:chgData name="Li, Hanchen F" userId="3aee791e-6a2d-4da7-a77b-fbdf7bf15886" providerId="ADAL" clId="{CDC5B0EF-6BEB-4658-A9FF-CB66F6FA6C1E}" dt="2025-05-22T22:21:35.270" v="2019" actId="1076"/>
+          <ac:chgData name="Li, Hanchen F" userId="3aee791e-6a2d-4da7-a77b-fbdf7bf15886" providerId="ADAL" clId="{CDC5B0EF-6BEB-4658-A9FF-CB66F6FA6C1E}" dt="2025-05-30T23:13:17.345" v="9281" actId="1076"/>
           <ac:cxnSpMkLst>
             <pc:docMk/>
             <pc:sldMk cId="2152317508" sldId="256"/>
@@ -1623,7 +1575,7 @@
           </ac:cxnSpMkLst>
         </pc:cxnChg>
         <pc:cxnChg chg="add mod">
-          <ac:chgData name="Li, Hanchen F" userId="3aee791e-6a2d-4da7-a77b-fbdf7bf15886" providerId="ADAL" clId="{CDC5B0EF-6BEB-4658-A9FF-CB66F6FA6C1E}" dt="2025-05-22T22:28:24.769" v="2437" actId="1037"/>
+          <ac:chgData name="Li, Hanchen F" userId="3aee791e-6a2d-4da7-a77b-fbdf7bf15886" providerId="ADAL" clId="{CDC5B0EF-6BEB-4658-A9FF-CB66F6FA6C1E}" dt="2025-05-30T22:47:14.691" v="9166" actId="14826"/>
           <ac:cxnSpMkLst>
             <pc:docMk/>
             <pc:sldMk cId="2152317508" sldId="256"/>
@@ -1776,13 +1728,13 @@
         </pc:cxnChg>
       </pc:sldChg>
       <pc:sldChg chg="addSp delSp modSp add mod">
-        <pc:chgData name="Li, Hanchen F" userId="3aee791e-6a2d-4da7-a77b-fbdf7bf15886" providerId="ADAL" clId="{CDC5B0EF-6BEB-4658-A9FF-CB66F6FA6C1E}" dt="2025-05-24T18:02:17.886" v="8740" actId="20577"/>
+        <pc:chgData name="Li, Hanchen F" userId="3aee791e-6a2d-4da7-a77b-fbdf7bf15886" providerId="ADAL" clId="{CDC5B0EF-6BEB-4658-A9FF-CB66F6FA6C1E}" dt="2025-05-30T22:50:51.390" v="9267" actId="1076"/>
         <pc:sldMkLst>
           <pc:docMk/>
           <pc:sldMk cId="3137520481" sldId="257"/>
         </pc:sldMkLst>
         <pc:spChg chg="add mod">
-          <ac:chgData name="Li, Hanchen F" userId="3aee791e-6a2d-4da7-a77b-fbdf7bf15886" providerId="ADAL" clId="{CDC5B0EF-6BEB-4658-A9FF-CB66F6FA6C1E}" dt="2025-05-24T00:33:27.897" v="8254" actId="1076"/>
+          <ac:chgData name="Li, Hanchen F" userId="3aee791e-6a2d-4da7-a77b-fbdf7bf15886" providerId="ADAL" clId="{CDC5B0EF-6BEB-4658-A9FF-CB66F6FA6C1E}" dt="2025-05-30T22:49:36.242" v="9249" actId="1076"/>
           <ac:spMkLst>
             <pc:docMk/>
             <pc:sldMk cId="3137520481" sldId="257"/>
@@ -1790,7 +1742,7 @@
           </ac:spMkLst>
         </pc:spChg>
         <pc:spChg chg="add mod">
-          <ac:chgData name="Li, Hanchen F" userId="3aee791e-6a2d-4da7-a77b-fbdf7bf15886" providerId="ADAL" clId="{CDC5B0EF-6BEB-4658-A9FF-CB66F6FA6C1E}" dt="2025-05-24T00:35:36" v="8285" actId="1076"/>
+          <ac:chgData name="Li, Hanchen F" userId="3aee791e-6a2d-4da7-a77b-fbdf7bf15886" providerId="ADAL" clId="{CDC5B0EF-6BEB-4658-A9FF-CB66F6FA6C1E}" dt="2025-05-30T22:50:06.412" v="9263" actId="1035"/>
           <ac:spMkLst>
             <pc:docMk/>
             <pc:sldMk cId="3137520481" sldId="257"/>
@@ -1822,7 +1774,7 @@
           </ac:spMkLst>
         </pc:spChg>
         <pc:spChg chg="add mod">
-          <ac:chgData name="Li, Hanchen F" userId="3aee791e-6a2d-4da7-a77b-fbdf7bf15886" providerId="ADAL" clId="{CDC5B0EF-6BEB-4658-A9FF-CB66F6FA6C1E}" dt="2025-05-24T00:41:58.135" v="8407" actId="1076"/>
+          <ac:chgData name="Li, Hanchen F" userId="3aee791e-6a2d-4da7-a77b-fbdf7bf15886" providerId="ADAL" clId="{CDC5B0EF-6BEB-4658-A9FF-CB66F6FA6C1E}" dt="2025-05-30T22:49:23.942" v="9245" actId="1037"/>
           <ac:spMkLst>
             <pc:docMk/>
             <pc:sldMk cId="3137520481" sldId="257"/>
@@ -1886,7 +1838,7 @@
           </ac:spMkLst>
         </pc:spChg>
         <pc:spChg chg="add mod">
-          <ac:chgData name="Li, Hanchen F" userId="3aee791e-6a2d-4da7-a77b-fbdf7bf15886" providerId="ADAL" clId="{CDC5B0EF-6BEB-4658-A9FF-CB66F6FA6C1E}" dt="2025-05-24T00:41:13.792" v="8391" actId="1076"/>
+          <ac:chgData name="Li, Hanchen F" userId="3aee791e-6a2d-4da7-a77b-fbdf7bf15886" providerId="ADAL" clId="{CDC5B0EF-6BEB-4658-A9FF-CB66F6FA6C1E}" dt="2025-05-30T22:49:28.059" v="9246" actId="1076"/>
           <ac:spMkLst>
             <pc:docMk/>
             <pc:sldMk cId="3137520481" sldId="257"/>
@@ -1894,7 +1846,7 @@
           </ac:spMkLst>
         </pc:spChg>
         <pc:spChg chg="add mod">
-          <ac:chgData name="Li, Hanchen F" userId="3aee791e-6a2d-4da7-a77b-fbdf7bf15886" providerId="ADAL" clId="{CDC5B0EF-6BEB-4658-A9FF-CB66F6FA6C1E}" dt="2025-05-24T00:48:05.629" v="8668" actId="1076"/>
+          <ac:chgData name="Li, Hanchen F" userId="3aee791e-6a2d-4da7-a77b-fbdf7bf15886" providerId="ADAL" clId="{CDC5B0EF-6BEB-4658-A9FF-CB66F6FA6C1E}" dt="2025-05-30T22:50:51.390" v="9267" actId="1076"/>
           <ac:spMkLst>
             <pc:docMk/>
             <pc:sldMk cId="3137520481" sldId="257"/>
@@ -1942,7 +1894,7 @@
           </ac:spMkLst>
         </pc:spChg>
         <pc:spChg chg="add mod">
-          <ac:chgData name="Li, Hanchen F" userId="3aee791e-6a2d-4da7-a77b-fbdf7bf15886" providerId="ADAL" clId="{CDC5B0EF-6BEB-4658-A9FF-CB66F6FA6C1E}" dt="2025-05-24T00:46:35.473" v="8552" actId="1076"/>
+          <ac:chgData name="Li, Hanchen F" userId="3aee791e-6a2d-4da7-a77b-fbdf7bf15886" providerId="ADAL" clId="{CDC5B0EF-6BEB-4658-A9FF-CB66F6FA6C1E}" dt="2025-05-30T22:50:06.412" v="9263" actId="1035"/>
           <ac:spMkLst>
             <pc:docMk/>
             <pc:sldMk cId="3137520481" sldId="257"/>
@@ -1950,7 +1902,7 @@
           </ac:spMkLst>
         </pc:spChg>
         <pc:spChg chg="add mod">
-          <ac:chgData name="Li, Hanchen F" userId="3aee791e-6a2d-4da7-a77b-fbdf7bf15886" providerId="ADAL" clId="{CDC5B0EF-6BEB-4658-A9FF-CB66F6FA6C1E}" dt="2025-05-24T00:45:55.994" v="8537" actId="1076"/>
+          <ac:chgData name="Li, Hanchen F" userId="3aee791e-6a2d-4da7-a77b-fbdf7bf15886" providerId="ADAL" clId="{CDC5B0EF-6BEB-4658-A9FF-CB66F6FA6C1E}" dt="2025-05-30T22:50:06.412" v="9263" actId="1035"/>
           <ac:spMkLst>
             <pc:docMk/>
             <pc:sldMk cId="3137520481" sldId="257"/>
@@ -1958,7 +1910,7 @@
           </ac:spMkLst>
         </pc:spChg>
         <pc:spChg chg="add mod">
-          <ac:chgData name="Li, Hanchen F" userId="3aee791e-6a2d-4da7-a77b-fbdf7bf15886" providerId="ADAL" clId="{CDC5B0EF-6BEB-4658-A9FF-CB66F6FA6C1E}" dt="2025-05-24T00:46:01.551" v="8539" actId="1076"/>
+          <ac:chgData name="Li, Hanchen F" userId="3aee791e-6a2d-4da7-a77b-fbdf7bf15886" providerId="ADAL" clId="{CDC5B0EF-6BEB-4658-A9FF-CB66F6FA6C1E}" dt="2025-05-30T22:50:06.412" v="9263" actId="1035"/>
           <ac:spMkLst>
             <pc:docMk/>
             <pc:sldMk cId="3137520481" sldId="257"/>
@@ -1974,7 +1926,7 @@
           </ac:spMkLst>
         </pc:spChg>
         <pc:spChg chg="add mod">
-          <ac:chgData name="Li, Hanchen F" userId="3aee791e-6a2d-4da7-a77b-fbdf7bf15886" providerId="ADAL" clId="{CDC5B0EF-6BEB-4658-A9FF-CB66F6FA6C1E}" dt="2025-05-24T00:50:53.176" v="8718" actId="1035"/>
+          <ac:chgData name="Li, Hanchen F" userId="3aee791e-6a2d-4da7-a77b-fbdf7bf15886" providerId="ADAL" clId="{CDC5B0EF-6BEB-4658-A9FF-CB66F6FA6C1E}" dt="2025-05-30T22:49:07.993" v="9225" actId="1038"/>
           <ac:spMkLst>
             <pc:docMk/>
             <pc:sldMk cId="3137520481" sldId="257"/>
@@ -1982,7 +1934,7 @@
           </ac:spMkLst>
         </pc:spChg>
         <pc:picChg chg="add del mod">
-          <ac:chgData name="Li, Hanchen F" userId="3aee791e-6a2d-4da7-a77b-fbdf7bf15886" providerId="ADAL" clId="{CDC5B0EF-6BEB-4658-A9FF-CB66F6FA6C1E}" dt="2025-05-24T00:49:14.429" v="8678" actId="1076"/>
+          <ac:chgData name="Li, Hanchen F" userId="3aee791e-6a2d-4da7-a77b-fbdf7bf15886" providerId="ADAL" clId="{CDC5B0EF-6BEB-4658-A9FF-CB66F6FA6C1E}" dt="2025-05-30T22:48:32.803" v="9172" actId="14826"/>
           <ac:picMkLst>
             <pc:docMk/>
             <pc:sldMk cId="3137520481" sldId="257"/>
@@ -1998,7 +1950,7 @@
           </ac:cxnSpMkLst>
         </pc:cxnChg>
         <pc:cxnChg chg="add mod">
-          <ac:chgData name="Li, Hanchen F" userId="3aee791e-6a2d-4da7-a77b-fbdf7bf15886" providerId="ADAL" clId="{CDC5B0EF-6BEB-4658-A9FF-CB66F6FA6C1E}" dt="2025-05-22T23:56:07.134" v="5833" actId="1076"/>
+          <ac:chgData name="Li, Hanchen F" userId="3aee791e-6a2d-4da7-a77b-fbdf7bf15886" providerId="ADAL" clId="{CDC5B0EF-6BEB-4658-A9FF-CB66F6FA6C1E}" dt="2025-05-30T22:50:06.412" v="9263" actId="1035"/>
           <ac:cxnSpMkLst>
             <pc:docMk/>
             <pc:sldMk cId="3137520481" sldId="257"/>
@@ -2062,7 +2014,7 @@
           </ac:cxnSpMkLst>
         </pc:cxnChg>
         <pc:cxnChg chg="add mod">
-          <ac:chgData name="Li, Hanchen F" userId="3aee791e-6a2d-4da7-a77b-fbdf7bf15886" providerId="ADAL" clId="{CDC5B0EF-6BEB-4658-A9FF-CB66F6FA6C1E}" dt="2025-05-24T01:02:26.893" v="8731" actId="1076"/>
+          <ac:chgData name="Li, Hanchen F" userId="3aee791e-6a2d-4da7-a77b-fbdf7bf15886" providerId="ADAL" clId="{CDC5B0EF-6BEB-4658-A9FF-CB66F6FA6C1E}" dt="2025-05-30T22:49:46.733" v="9251" actId="14100"/>
           <ac:cxnSpMkLst>
             <pc:docMk/>
             <pc:sldMk cId="3137520481" sldId="257"/>
@@ -2110,7 +2062,7 @@
           </ac:cxnSpMkLst>
         </pc:cxnChg>
         <pc:cxnChg chg="add mod">
-          <ac:chgData name="Li, Hanchen F" userId="3aee791e-6a2d-4da7-a77b-fbdf7bf15886" providerId="ADAL" clId="{CDC5B0EF-6BEB-4658-A9FF-CB66F6FA6C1E}" dt="2025-05-24T00:45:30.413" v="8528" actId="14100"/>
+          <ac:chgData name="Li, Hanchen F" userId="3aee791e-6a2d-4da7-a77b-fbdf7bf15886" providerId="ADAL" clId="{CDC5B0EF-6BEB-4658-A9FF-CB66F6FA6C1E}" dt="2025-05-30T22:50:14.677" v="9264" actId="1035"/>
           <ac:cxnSpMkLst>
             <pc:docMk/>
             <pc:sldMk cId="3137520481" sldId="257"/>
@@ -2118,7 +2070,7 @@
           </ac:cxnSpMkLst>
         </pc:cxnChg>
         <pc:cxnChg chg="add mod">
-          <ac:chgData name="Li, Hanchen F" userId="3aee791e-6a2d-4da7-a77b-fbdf7bf15886" providerId="ADAL" clId="{CDC5B0EF-6BEB-4658-A9FF-CB66F6FA6C1E}" dt="2025-05-24T00:45:38.349" v="8531" actId="1076"/>
+          <ac:chgData name="Li, Hanchen F" userId="3aee791e-6a2d-4da7-a77b-fbdf7bf15886" providerId="ADAL" clId="{CDC5B0EF-6BEB-4658-A9FF-CB66F6FA6C1E}" dt="2025-05-30T22:50:16.239" v="9265" actId="1036"/>
           <ac:cxnSpMkLst>
             <pc:docMk/>
             <pc:sldMk cId="3137520481" sldId="257"/>
@@ -2126,7 +2078,7 @@
           </ac:cxnSpMkLst>
         </pc:cxnChg>
         <pc:cxnChg chg="add mod">
-          <ac:chgData name="Li, Hanchen F" userId="3aee791e-6a2d-4da7-a77b-fbdf7bf15886" providerId="ADAL" clId="{CDC5B0EF-6BEB-4658-A9FF-CB66F6FA6C1E}" dt="2025-05-24T00:46:23.374" v="8550" actId="14100"/>
+          <ac:chgData name="Li, Hanchen F" userId="3aee791e-6a2d-4da7-a77b-fbdf7bf15886" providerId="ADAL" clId="{CDC5B0EF-6BEB-4658-A9FF-CB66F6FA6C1E}" dt="2025-05-30T22:50:06.412" v="9263" actId="1035"/>
           <ac:cxnSpMkLst>
             <pc:docMk/>
             <pc:sldMk cId="3137520481" sldId="257"/>
@@ -2150,7 +2102,7 @@
           </ac:cxnSpMkLst>
         </pc:cxnChg>
         <pc:cxnChg chg="add mod">
-          <ac:chgData name="Li, Hanchen F" userId="3aee791e-6a2d-4da7-a77b-fbdf7bf15886" providerId="ADAL" clId="{CDC5B0EF-6BEB-4658-A9FF-CB66F6FA6C1E}" dt="2025-05-24T00:50:49.367" v="8717" actId="1035"/>
+          <ac:chgData name="Li, Hanchen F" userId="3aee791e-6a2d-4da7-a77b-fbdf7bf15886" providerId="ADAL" clId="{CDC5B0EF-6BEB-4658-A9FF-CB66F6FA6C1E}" dt="2025-05-30T22:49:07.993" v="9225" actId="1038"/>
           <ac:cxnSpMkLst>
             <pc:docMk/>
             <pc:sldMk cId="3137520481" sldId="257"/>
@@ -3263,7 +3215,7 @@
           <a:p>
             <a:fld id="{DF1088C5-931A-42D2-8AA4-FA289862AAD0}" type="datetimeFigureOut">
               <a:rPr lang="zh-CN" altLang="en-US" smtClean="0"/>
-              <a:t>2025/5/27</a:t>
+              <a:t>2025/5/31</a:t>
             </a:fld>
             <a:endParaRPr lang="zh-CN" altLang="en-US"/>
           </a:p>
@@ -4153,7 +4105,7 @@
           <a:p>
             <a:fld id="{3CAF1464-0EA4-453D-A90B-03B04D244405}" type="datetimeFigureOut">
               <a:rPr lang="zh-CN" altLang="en-US" smtClean="0"/>
-              <a:t>2025/5/27</a:t>
+              <a:t>2025/5/31</a:t>
             </a:fld>
             <a:endParaRPr lang="zh-CN" altLang="en-US"/>
           </a:p>
@@ -4323,7 +4275,7 @@
           <a:p>
             <a:fld id="{3CAF1464-0EA4-453D-A90B-03B04D244405}" type="datetimeFigureOut">
               <a:rPr lang="zh-CN" altLang="en-US" smtClean="0"/>
-              <a:t>2025/5/27</a:t>
+              <a:t>2025/5/31</a:t>
             </a:fld>
             <a:endParaRPr lang="zh-CN" altLang="en-US"/>
           </a:p>
@@ -4503,7 +4455,7 @@
           <a:p>
             <a:fld id="{3CAF1464-0EA4-453D-A90B-03B04D244405}" type="datetimeFigureOut">
               <a:rPr lang="zh-CN" altLang="en-US" smtClean="0"/>
-              <a:t>2025/5/27</a:t>
+              <a:t>2025/5/31</a:t>
             </a:fld>
             <a:endParaRPr lang="zh-CN" altLang="en-US"/>
           </a:p>
@@ -4673,7 +4625,7 @@
           <a:p>
             <a:fld id="{3CAF1464-0EA4-453D-A90B-03B04D244405}" type="datetimeFigureOut">
               <a:rPr lang="zh-CN" altLang="en-US" smtClean="0"/>
-              <a:t>2025/5/27</a:t>
+              <a:t>2025/5/31</a:t>
             </a:fld>
             <a:endParaRPr lang="zh-CN" altLang="en-US"/>
           </a:p>
@@ -4919,7 +4871,7 @@
           <a:p>
             <a:fld id="{3CAF1464-0EA4-453D-A90B-03B04D244405}" type="datetimeFigureOut">
               <a:rPr lang="zh-CN" altLang="en-US" smtClean="0"/>
-              <a:t>2025/5/27</a:t>
+              <a:t>2025/5/31</a:t>
             </a:fld>
             <a:endParaRPr lang="zh-CN" altLang="en-US"/>
           </a:p>
@@ -5151,7 +5103,7 @@
           <a:p>
             <a:fld id="{3CAF1464-0EA4-453D-A90B-03B04D244405}" type="datetimeFigureOut">
               <a:rPr lang="zh-CN" altLang="en-US" smtClean="0"/>
-              <a:t>2025/5/27</a:t>
+              <a:t>2025/5/31</a:t>
             </a:fld>
             <a:endParaRPr lang="zh-CN" altLang="en-US"/>
           </a:p>
@@ -5518,7 +5470,7 @@
           <a:p>
             <a:fld id="{3CAF1464-0EA4-453D-A90B-03B04D244405}" type="datetimeFigureOut">
               <a:rPr lang="zh-CN" altLang="en-US" smtClean="0"/>
-              <a:t>2025/5/27</a:t>
+              <a:t>2025/5/31</a:t>
             </a:fld>
             <a:endParaRPr lang="zh-CN" altLang="en-US"/>
           </a:p>
@@ -5636,7 +5588,7 @@
           <a:p>
             <a:fld id="{3CAF1464-0EA4-453D-A90B-03B04D244405}" type="datetimeFigureOut">
               <a:rPr lang="zh-CN" altLang="en-US" smtClean="0"/>
-              <a:t>2025/5/27</a:t>
+              <a:t>2025/5/31</a:t>
             </a:fld>
             <a:endParaRPr lang="zh-CN" altLang="en-US"/>
           </a:p>
@@ -5731,7 +5683,7 @@
           <a:p>
             <a:fld id="{3CAF1464-0EA4-453D-A90B-03B04D244405}" type="datetimeFigureOut">
               <a:rPr lang="zh-CN" altLang="en-US" smtClean="0"/>
-              <a:t>2025/5/27</a:t>
+              <a:t>2025/5/31</a:t>
             </a:fld>
             <a:endParaRPr lang="zh-CN" altLang="en-US"/>
           </a:p>
@@ -6008,7 +5960,7 @@
           <a:p>
             <a:fld id="{3CAF1464-0EA4-453D-A90B-03B04D244405}" type="datetimeFigureOut">
               <a:rPr lang="zh-CN" altLang="en-US" smtClean="0"/>
-              <a:t>2025/5/27</a:t>
+              <a:t>2025/5/31</a:t>
             </a:fld>
             <a:endParaRPr lang="zh-CN" altLang="en-US"/>
           </a:p>
@@ -6265,7 +6217,7 @@
           <a:p>
             <a:fld id="{3CAF1464-0EA4-453D-A90B-03B04D244405}" type="datetimeFigureOut">
               <a:rPr lang="zh-CN" altLang="en-US" smtClean="0"/>
-              <a:t>2025/5/27</a:t>
+              <a:t>2025/5/31</a:t>
             </a:fld>
             <a:endParaRPr lang="zh-CN" altLang="en-US"/>
           </a:p>
@@ -6478,7 +6430,7 @@
           <a:p>
             <a:fld id="{3CAF1464-0EA4-453D-A90B-03B04D244405}" type="datetimeFigureOut">
               <a:rPr lang="zh-CN" altLang="en-US" smtClean="0"/>
-              <a:t>2025/5/27</a:t>
+              <a:t>2025/5/31</a:t>
             </a:fld>
             <a:endParaRPr lang="zh-CN" altLang="en-US"/>
           </a:p>
@@ -11087,6 +11039,64 @@
           <a:chExt cx="0" cy="0"/>
         </a:xfrm>
       </p:grpSpPr>
+      <p:sp>
+        <p:nvSpPr>
+          <p:cNvPr id="695" name="文本框 694">
+            <a:extLst>
+              <a:ext uri="{FF2B5EF4-FFF2-40B4-BE49-F238E27FC236}">
+                <a16:creationId xmlns:a16="http://schemas.microsoft.com/office/drawing/2014/main" id="{A5C50E1A-5024-5A9F-7660-C2084EDC312F}"/>
+              </a:ext>
+            </a:extLst>
+          </p:cNvPr>
+          <p:cNvSpPr txBox="1"/>
+          <p:nvPr/>
+        </p:nvSpPr>
+        <p:spPr>
+          <a:xfrm>
+            <a:off x="5688864" y="3218032"/>
+            <a:ext cx="461986" cy="338554"/>
+          </a:xfrm>
+          <a:prstGeom prst="rect">
+            <a:avLst/>
+          </a:prstGeom>
+          <a:noFill/>
+        </p:spPr>
+        <p:txBody>
+          <a:bodyPr wrap="none" rtlCol="0">
+            <a:spAutoFit/>
+          </a:bodyPr>
+          <a:lstStyle/>
+          <a:p>
+            <a:r>
+              <a:rPr lang="en-US" altLang="zh-CN" sz="1600" i="1" dirty="0" err="1">
+                <a:solidFill>
+                  <a:srgbClr val="0000CD"/>
+                </a:solidFill>
+                <a:latin typeface="Times New Roman" panose="02020603050405020304" pitchFamily="18" charset="0"/>
+                <a:cs typeface="Times New Roman" panose="02020603050405020304" pitchFamily="18" charset="0"/>
+              </a:rPr>
+              <a:t>h</a:t>
+            </a:r>
+            <a:r>
+              <a:rPr lang="en-US" altLang="zh-CN" sz="1600" i="1" baseline="-25000" dirty="0" err="1">
+                <a:solidFill>
+                  <a:srgbClr val="0000CD"/>
+                </a:solidFill>
+                <a:latin typeface="Times New Roman" panose="02020603050405020304" pitchFamily="18" charset="0"/>
+                <a:cs typeface="Times New Roman" panose="02020603050405020304" pitchFamily="18" charset="0"/>
+              </a:rPr>
+              <a:t>HT</a:t>
+            </a:r>
+            <a:endParaRPr lang="zh-CN" altLang="en-US" sz="1600" i="1" baseline="-25000" dirty="0">
+              <a:solidFill>
+                <a:srgbClr val="0000CD"/>
+              </a:solidFill>
+              <a:latin typeface="Times New Roman" panose="02020603050405020304" pitchFamily="18" charset="0"/>
+              <a:cs typeface="Times New Roman" panose="02020603050405020304" pitchFamily="18" charset="0"/>
+            </a:endParaRPr>
+          </a:p>
+        </p:txBody>
+      </p:sp>
       <p:grpSp>
         <p:nvGrpSpPr>
           <p:cNvPr id="599" name="组合 598">
@@ -13566,9 +13576,9 @@
         </p:nvGrpSpPr>
         <p:grpSpPr>
           <a:xfrm rot="153205">
-            <a:off x="-1011769" y="719808"/>
+            <a:off x="-1011770" y="719807"/>
             <a:ext cx="8512425" cy="5043294"/>
-            <a:chOff x="-1265770" y="719808"/>
+            <a:chOff x="-1265771" y="719808"/>
             <a:chExt cx="8512425" cy="5043294"/>
           </a:xfrm>
         </p:grpSpPr>
@@ -13630,10 +13640,10 @@
           </p:nvGrpSpPr>
           <p:grpSpPr>
             <a:xfrm>
-              <a:off x="-1265770" y="719808"/>
-              <a:ext cx="8512425" cy="4864533"/>
-              <a:chOff x="-1265770" y="719808"/>
-              <a:chExt cx="8512425" cy="4864533"/>
+              <a:off x="-1265771" y="719808"/>
+              <a:ext cx="8512425" cy="4864534"/>
+              <a:chOff x="-1265771" y="719808"/>
+              <a:chExt cx="8512425" cy="4864534"/>
             </a:xfrm>
           </p:grpSpPr>
           <p:sp>
@@ -13871,8 +13881,8 @@
             </p:blipFill>
             <p:spPr>
               <a:xfrm rot="20957173">
-                <a:off x="-1265770" y="796341"/>
-                <a:ext cx="8512425" cy="4788000"/>
+                <a:off x="-1265771" y="796343"/>
+                <a:ext cx="8512425" cy="4787999"/>
               </a:xfrm>
               <a:prstGeom prst="rect">
                 <a:avLst/>
@@ -14130,9 +14140,9 @@
               <p:nvPr/>
             </p:nvCxnSpPr>
             <p:spPr>
-              <a:xfrm rot="20957173">
-                <a:off x="2252779" y="4780198"/>
-                <a:ext cx="4091093" cy="0"/>
+              <a:xfrm rot="21446795" flipV="1">
+                <a:off x="2277552" y="4672089"/>
+                <a:ext cx="3062097" cy="420382"/>
               </a:xfrm>
               <a:prstGeom prst="straightConnector1">
                 <a:avLst/>
@@ -14227,9 +14237,9 @@
               <p:nvPr/>
             </p:nvCxnSpPr>
             <p:spPr>
-              <a:xfrm rot="20957173">
-                <a:off x="2335788" y="5218927"/>
-                <a:ext cx="4091093" cy="0"/>
+              <a:xfrm rot="21446795" flipV="1">
+                <a:off x="2360308" y="5099452"/>
+                <a:ext cx="3066978" cy="431645"/>
               </a:xfrm>
               <a:prstGeom prst="straightConnector1">
                 <a:avLst/>
@@ -14273,7 +14283,7 @@
             </p:nvCxnSpPr>
             <p:spPr>
               <a:xfrm rot="20957173">
-                <a:off x="3983847" y="3592800"/>
+                <a:off x="4234552" y="3548907"/>
                 <a:ext cx="2032109" cy="0"/>
               </a:xfrm>
               <a:prstGeom prst="line">
@@ -14317,7 +14327,7 @@
             </p:nvCxnSpPr>
             <p:spPr>
               <a:xfrm rot="20957173" flipV="1">
-                <a:off x="4226308" y="2898608"/>
+                <a:off x="4354822" y="2868803"/>
                 <a:ext cx="0" cy="833166"/>
               </a:xfrm>
               <a:prstGeom prst="straightConnector1">
@@ -14393,94 +14403,6 @@
           </p:cxnSp>
           <p:cxnSp>
             <p:nvCxnSpPr>
-              <p:cNvPr id="84" name="直接连接符 83">
-                <a:extLst>
-                  <a:ext uri="{FF2B5EF4-FFF2-40B4-BE49-F238E27FC236}">
-                    <a16:creationId xmlns:a16="http://schemas.microsoft.com/office/drawing/2014/main" id="{79D2A366-B413-8528-AC73-86E9F16DB2B7}"/>
-                  </a:ext>
-                </a:extLst>
-              </p:cNvPr>
-              <p:cNvCxnSpPr>
-                <a:cxnSpLocks/>
-              </p:cNvCxnSpPr>
-              <p:nvPr/>
-            </p:nvCxnSpPr>
-            <p:spPr>
-              <a:xfrm rot="20957173">
-                <a:off x="5741823" y="3064421"/>
-                <a:ext cx="190500" cy="0"/>
-              </a:xfrm>
-              <a:prstGeom prst="line">
-                <a:avLst/>
-              </a:prstGeom>
-              <a:ln w="12700">
-                <a:solidFill>
-                  <a:srgbClr val="0000CD"/>
-                </a:solidFill>
-                <a:prstDash val="solid"/>
-              </a:ln>
-            </p:spPr>
-            <p:style>
-              <a:lnRef idx="2">
-                <a:schemeClr val="accent1"/>
-              </a:lnRef>
-              <a:fillRef idx="0">
-                <a:schemeClr val="accent1"/>
-              </a:fillRef>
-              <a:effectRef idx="1">
-                <a:schemeClr val="accent1"/>
-              </a:effectRef>
-              <a:fontRef idx="minor">
-                <a:schemeClr val="tx1"/>
-              </a:fontRef>
-            </p:style>
-          </p:cxnSp>
-          <p:cxnSp>
-            <p:nvCxnSpPr>
-              <p:cNvPr id="91" name="直接连接符 90">
-                <a:extLst>
-                  <a:ext uri="{FF2B5EF4-FFF2-40B4-BE49-F238E27FC236}">
-                    <a16:creationId xmlns:a16="http://schemas.microsoft.com/office/drawing/2014/main" id="{E7FFA589-5910-415F-51D1-A5B2F512A967}"/>
-                  </a:ext>
-                </a:extLst>
-              </p:cNvPr>
-              <p:cNvCxnSpPr>
-                <a:cxnSpLocks/>
-              </p:cNvCxnSpPr>
-              <p:nvPr/>
-            </p:nvCxnSpPr>
-            <p:spPr>
-              <a:xfrm rot="20957173">
-                <a:off x="5274367" y="3173032"/>
-                <a:ext cx="190500" cy="0"/>
-              </a:xfrm>
-              <a:prstGeom prst="line">
-                <a:avLst/>
-              </a:prstGeom>
-              <a:ln w="12700">
-                <a:solidFill>
-                  <a:srgbClr val="0000CD"/>
-                </a:solidFill>
-                <a:prstDash val="solid"/>
-              </a:ln>
-            </p:spPr>
-            <p:style>
-              <a:lnRef idx="2">
-                <a:schemeClr val="accent1"/>
-              </a:lnRef>
-              <a:fillRef idx="0">
-                <a:schemeClr val="accent1"/>
-              </a:fillRef>
-              <a:effectRef idx="1">
-                <a:schemeClr val="accent1"/>
-              </a:effectRef>
-              <a:fontRef idx="minor">
-                <a:schemeClr val="tx1"/>
-              </a:fontRef>
-            </p:style>
-          </p:cxnSp>
-          <p:cxnSp>
-            <p:nvCxnSpPr>
               <p:cNvPr id="94" name="直接箭头连接符 93">
                 <a:extLst>
                   <a:ext uri="{FF2B5EF4-FFF2-40B4-BE49-F238E27FC236}">
@@ -14495,7 +14417,7 @@
             </p:nvCxnSpPr>
             <p:spPr>
               <a:xfrm rot="20957173" flipV="1">
-                <a:off x="5870864" y="3061253"/>
+                <a:off x="6018039" y="3029448"/>
                 <a:ext cx="0" cy="363536"/>
               </a:xfrm>
               <a:prstGeom prst="straightConnector1">
@@ -14539,9 +14461,9 @@
               <p:nvPr/>
             </p:nvCxnSpPr>
             <p:spPr>
-              <a:xfrm rot="20957173" flipV="1">
-                <a:off x="5404648" y="3174878"/>
-                <a:ext cx="0" cy="328120"/>
+              <a:xfrm rot="21446795" flipH="1" flipV="1">
+                <a:off x="5438759" y="3142725"/>
+                <a:ext cx="47852" cy="351784"/>
               </a:xfrm>
               <a:prstGeom prst="straightConnector1">
                 <a:avLst/>
@@ -14674,7 +14596,7 @@
             </p:nvCxnSpPr>
             <p:spPr>
               <a:xfrm rot="20957173">
-                <a:off x="6266963" y="3332829"/>
+                <a:off x="5276236" y="3447203"/>
                 <a:ext cx="0" cy="1698132"/>
               </a:xfrm>
               <a:prstGeom prst="line">
@@ -14894,7 +14816,7 @@
             </p:nvCxnSpPr>
             <p:spPr>
               <a:xfrm rot="20957173" flipV="1">
-                <a:off x="6000706" y="2559319"/>
+                <a:off x="5026063" y="2753381"/>
                 <a:ext cx="180" cy="432524"/>
               </a:xfrm>
               <a:prstGeom prst="straightConnector1">
@@ -14938,7 +14860,7 @@
             </p:nvCxnSpPr>
             <p:spPr>
               <a:xfrm rot="20957173">
-                <a:off x="6320138" y="2950948"/>
+                <a:off x="5338656" y="3133465"/>
                 <a:ext cx="233362" cy="0"/>
               </a:xfrm>
               <a:prstGeom prst="straightConnector1">
@@ -14982,7 +14904,7 @@
             </p:nvCxnSpPr>
             <p:spPr>
               <a:xfrm rot="20957173" flipV="1">
-                <a:off x="6322990" y="2949613"/>
+                <a:off x="5558179" y="3059017"/>
                 <a:ext cx="563562" cy="1847"/>
               </a:xfrm>
               <a:prstGeom prst="straightConnector1">
@@ -15468,9 +15390,9 @@
         <p:grpSpPr>
           <a:xfrm>
             <a:off x="7478451" y="742644"/>
-            <a:ext cx="4788638" cy="4993868"/>
+            <a:ext cx="4788637" cy="4993868"/>
             <a:chOff x="6986023" y="751916"/>
-            <a:chExt cx="4788638" cy="4993868"/>
+            <a:chExt cx="4788637" cy="4993868"/>
           </a:xfrm>
         </p:grpSpPr>
         <p:sp>
@@ -15813,7 +15735,7 @@
           <p:spPr>
             <a:xfrm rot="935833">
               <a:off x="6986023" y="957785"/>
-              <a:ext cx="4788638" cy="4787999"/>
+              <a:ext cx="4788637" cy="4787999"/>
             </a:xfrm>
             <a:prstGeom prst="rect">
               <a:avLst/>
@@ -16022,7 +15944,7 @@
           </p:nvCxnSpPr>
           <p:spPr>
             <a:xfrm rot="935833">
-              <a:off x="8061322" y="3462178"/>
+              <a:off x="8080978" y="3432165"/>
               <a:ext cx="190500" cy="0"/>
             </a:xfrm>
             <a:prstGeom prst="line">
@@ -16068,51 +15990,6 @@
             <a:xfrm rot="935833" flipV="1">
               <a:off x="8458239" y="3522302"/>
               <a:ext cx="0" cy="363536"/>
-            </a:xfrm>
-            <a:prstGeom prst="straightConnector1">
-              <a:avLst/>
-            </a:prstGeom>
-            <a:ln w="12700">
-              <a:solidFill>
-                <a:srgbClr val="0000CD"/>
-              </a:solidFill>
-              <a:headEnd type="triangle"/>
-              <a:tailEnd type="triangle"/>
-            </a:ln>
-          </p:spPr>
-          <p:style>
-            <a:lnRef idx="2">
-              <a:schemeClr val="accent1"/>
-            </a:lnRef>
-            <a:fillRef idx="0">
-              <a:schemeClr val="accent1"/>
-            </a:fillRef>
-            <a:effectRef idx="1">
-              <a:schemeClr val="accent1"/>
-            </a:effectRef>
-            <a:fontRef idx="minor">
-              <a:schemeClr val="tx1"/>
-            </a:fontRef>
-          </p:style>
-        </p:cxnSp>
-        <p:cxnSp>
-          <p:nvCxnSpPr>
-            <p:cNvPr id="230" name="直接箭头连接符 229">
-              <a:extLst>
-                <a:ext uri="{FF2B5EF4-FFF2-40B4-BE49-F238E27FC236}">
-                  <a16:creationId xmlns:a16="http://schemas.microsoft.com/office/drawing/2014/main" id="{FF7C58E2-8271-6514-4188-11F6201F333C}"/>
-                </a:ext>
-              </a:extLst>
-            </p:cNvPr>
-            <p:cNvCxnSpPr>
-              <a:cxnSpLocks/>
-            </p:cNvCxnSpPr>
-            <p:nvPr/>
-          </p:nvCxnSpPr>
-          <p:spPr>
-            <a:xfrm rot="935833" flipV="1">
-              <a:off x="8110976" y="3461455"/>
-              <a:ext cx="0" cy="328120"/>
             </a:xfrm>
             <a:prstGeom prst="straightConnector1">
               <a:avLst/>
@@ -16288,7 +16165,7 @@
           </p:nvCxnSpPr>
           <p:spPr>
             <a:xfrm rot="935833">
-              <a:off x="9535861" y="938105"/>
+              <a:off x="9568843" y="823134"/>
               <a:ext cx="0" cy="4049607"/>
             </a:xfrm>
             <a:prstGeom prst="line">
@@ -18114,7 +17991,7 @@
         </p:nvSpPr>
         <p:spPr>
           <a:xfrm>
-            <a:off x="4175643" y="4480268"/>
+            <a:off x="3756659" y="4525601"/>
             <a:ext cx="417102" cy="338554"/>
           </a:xfrm>
           <a:prstGeom prst="rect">
@@ -18172,7 +18049,7 @@
         </p:nvSpPr>
         <p:spPr>
           <a:xfrm>
-            <a:off x="4298745" y="4919599"/>
+            <a:off x="3840301" y="4975269"/>
             <a:ext cx="401072" cy="338554"/>
           </a:xfrm>
           <a:prstGeom prst="rect">
@@ -18623,10 +18500,10 @@
       </p:sp>
       <p:sp>
         <p:nvSpPr>
-          <p:cNvPr id="693" name="文本框 692">
-            <a:extLst>
-              <a:ext uri="{FF2B5EF4-FFF2-40B4-BE49-F238E27FC236}">
-                <a16:creationId xmlns:a16="http://schemas.microsoft.com/office/drawing/2014/main" id="{3F9A48A1-BA63-64E8-1F9E-D38216DB2FFD}"/>
+          <p:cNvPr id="694" name="文本框 693">
+            <a:extLst>
+              <a:ext uri="{FF2B5EF4-FFF2-40B4-BE49-F238E27FC236}">
+                <a16:creationId xmlns:a16="http://schemas.microsoft.com/office/drawing/2014/main" id="{0B589E19-DFFC-1E39-CEEC-5F6428DEC4B7}"/>
               </a:ext>
             </a:extLst>
           </p:cNvPr>
@@ -18635,8 +18512,8 @@
         </p:nvSpPr>
         <p:spPr>
           <a:xfrm>
-            <a:off x="4081426" y="3280481"/>
-            <a:ext cx="445956" cy="338554"/>
+            <a:off x="4656565" y="2888676"/>
+            <a:ext cx="470000" cy="338554"/>
           </a:xfrm>
           <a:prstGeom prst="rect">
             <a:avLst/>
@@ -18667,7 +18544,7 @@
                 <a:latin typeface="Times New Roman" panose="02020603050405020304" pitchFamily="18" charset="0"/>
                 <a:cs typeface="Times New Roman" panose="02020603050405020304" pitchFamily="18" charset="0"/>
               </a:rPr>
-              <a:t>LR</a:t>
+              <a:t>UR</a:t>
             </a:r>
             <a:endParaRPr lang="zh-CN" altLang="en-US" sz="1600" i="1" baseline="-25000" dirty="0">
               <a:solidFill>
@@ -18681,10 +18558,10 @@
       </p:sp>
       <p:sp>
         <p:nvSpPr>
-          <p:cNvPr id="694" name="文本框 693">
-            <a:extLst>
-              <a:ext uri="{FF2B5EF4-FFF2-40B4-BE49-F238E27FC236}">
-                <a16:creationId xmlns:a16="http://schemas.microsoft.com/office/drawing/2014/main" id="{0B589E19-DFFC-1E39-CEEC-5F6428DEC4B7}"/>
+          <p:cNvPr id="697" name="文本框 696">
+            <a:extLst>
+              <a:ext uri="{FF2B5EF4-FFF2-40B4-BE49-F238E27FC236}">
+                <a16:creationId xmlns:a16="http://schemas.microsoft.com/office/drawing/2014/main" id="{A96771D7-2070-8EA0-BBE2-DA085813F41A}"/>
               </a:ext>
             </a:extLst>
           </p:cNvPr>
@@ -18693,8 +18570,8 @@
         </p:nvSpPr>
         <p:spPr>
           <a:xfrm>
-            <a:off x="4656565" y="2888676"/>
-            <a:ext cx="470000" cy="338554"/>
+            <a:off x="6255916" y="3133787"/>
+            <a:ext cx="461986" cy="338554"/>
           </a:xfrm>
           <a:prstGeom prst="rect">
             <a:avLst/>
@@ -18725,7 +18602,7 @@
                 <a:latin typeface="Times New Roman" panose="02020603050405020304" pitchFamily="18" charset="0"/>
                 <a:cs typeface="Times New Roman" panose="02020603050405020304" pitchFamily="18" charset="0"/>
               </a:rPr>
-              <a:t>UR</a:t>
+              <a:t>VT</a:t>
             </a:r>
             <a:endParaRPr lang="zh-CN" altLang="en-US" sz="1600" i="1" baseline="-25000" dirty="0">
               <a:solidFill>
@@ -18739,10 +18616,10 @@
       </p:sp>
       <p:sp>
         <p:nvSpPr>
-          <p:cNvPr id="695" name="文本框 694">
-            <a:extLst>
-              <a:ext uri="{FF2B5EF4-FFF2-40B4-BE49-F238E27FC236}">
-                <a16:creationId xmlns:a16="http://schemas.microsoft.com/office/drawing/2014/main" id="{A5C50E1A-5024-5A9F-7660-C2084EDC312F}"/>
+          <p:cNvPr id="698" name="文本框 697">
+            <a:extLst>
+              <a:ext uri="{FF2B5EF4-FFF2-40B4-BE49-F238E27FC236}">
+                <a16:creationId xmlns:a16="http://schemas.microsoft.com/office/drawing/2014/main" id="{2DF3CB69-63A2-B3DC-0144-99AB9254180D}"/>
               </a:ext>
             </a:extLst>
           </p:cNvPr>
@@ -18751,28 +18628,13 @@
         </p:nvSpPr>
         <p:spPr>
           <a:xfrm>
-            <a:off x="5189508" y="3258701"/>
-            <a:ext cx="461986" cy="338554"/>
+            <a:off x="11415488" y="1960212"/>
+            <a:ext cx="731290" cy="338554"/>
           </a:xfrm>
           <a:prstGeom prst="rect">
             <a:avLst/>
           </a:prstGeom>
-          <a:gradFill flip="none" rotWithShape="1">
-            <a:gsLst>
-              <a:gs pos="22000">
-                <a:schemeClr val="bg1"/>
-              </a:gs>
-              <a:gs pos="100000">
-                <a:schemeClr val="bg1">
-                  <a:alpha val="0"/>
-                </a:schemeClr>
-              </a:gs>
-            </a:gsLst>
-            <a:path path="circle">
-              <a:fillToRect l="50000" t="50000" r="50000" b="50000"/>
-            </a:path>
-            <a:tileRect/>
-          </a:gradFill>
+          <a:noFill/>
         </p:spPr>
         <p:txBody>
           <a:bodyPr wrap="none" rtlCol="0">
@@ -18781,29 +18643,20 @@
           <a:lstStyle/>
           <a:p>
             <a:r>
-              <a:rPr lang="en-US" altLang="zh-CN" sz="1600" i="1" dirty="0" err="1">
-                <a:solidFill>
-                  <a:srgbClr val="0000CD"/>
-                </a:solidFill>
-                <a:latin typeface="Times New Roman" panose="02020603050405020304" pitchFamily="18" charset="0"/>
-                <a:cs typeface="Times New Roman" panose="02020603050405020304" pitchFamily="18" charset="0"/>
-              </a:rPr>
-              <a:t>h</a:t>
-            </a:r>
-            <a:r>
-              <a:rPr lang="en-US" altLang="zh-CN" sz="1600" i="1" baseline="-25000" dirty="0" err="1">
-                <a:solidFill>
-                  <a:srgbClr val="0000CD"/>
-                </a:solidFill>
-                <a:latin typeface="Times New Roman" panose="02020603050405020304" pitchFamily="18" charset="0"/>
-                <a:cs typeface="Times New Roman" panose="02020603050405020304" pitchFamily="18" charset="0"/>
-              </a:rPr>
-              <a:t>HT</a:t>
+              <a:rPr lang="en-US" altLang="zh-CN" sz="1600" i="1" dirty="0">
+                <a:latin typeface="Times New Roman" panose="02020603050405020304" pitchFamily="18" charset="0"/>
+                <a:cs typeface="Times New Roman" panose="02020603050405020304" pitchFamily="18" charset="0"/>
+              </a:rPr>
+              <a:t>TPP</a:t>
+            </a:r>
+            <a:r>
+              <a:rPr lang="en-US" altLang="zh-CN" sz="1600" i="1" baseline="-25000" dirty="0">
+                <a:latin typeface="Times New Roman" panose="02020603050405020304" pitchFamily="18" charset="0"/>
+                <a:cs typeface="Times New Roman" panose="02020603050405020304" pitchFamily="18" charset="0"/>
+              </a:rPr>
+              <a:t>UR</a:t>
             </a:r>
             <a:endParaRPr lang="zh-CN" altLang="en-US" sz="1600" i="1" baseline="-25000" dirty="0">
-              <a:solidFill>
-                <a:srgbClr val="0000CD"/>
-              </a:solidFill>
               <a:latin typeface="Times New Roman" panose="02020603050405020304" pitchFamily="18" charset="0"/>
               <a:cs typeface="Times New Roman" panose="02020603050405020304" pitchFamily="18" charset="0"/>
             </a:endParaRPr>
@@ -18812,10 +18665,10 @@
       </p:sp>
       <p:sp>
         <p:nvSpPr>
-          <p:cNvPr id="697" name="文本框 696">
-            <a:extLst>
-              <a:ext uri="{FF2B5EF4-FFF2-40B4-BE49-F238E27FC236}">
-                <a16:creationId xmlns:a16="http://schemas.microsoft.com/office/drawing/2014/main" id="{A96771D7-2070-8EA0-BBE2-DA085813F41A}"/>
+          <p:cNvPr id="699" name="文本框 698">
+            <a:extLst>
+              <a:ext uri="{FF2B5EF4-FFF2-40B4-BE49-F238E27FC236}">
+                <a16:creationId xmlns:a16="http://schemas.microsoft.com/office/drawing/2014/main" id="{01DB1B03-FD95-A5DD-B402-50BD9002E032}"/>
               </a:ext>
             </a:extLst>
           </p:cNvPr>
@@ -18824,27 +18677,13 @@
         </p:nvSpPr>
         <p:spPr>
           <a:xfrm>
-            <a:off x="5703416" y="3202793"/>
-            <a:ext cx="461986" cy="338554"/>
+            <a:off x="11335585" y="2481635"/>
+            <a:ext cx="707245" cy="338554"/>
           </a:xfrm>
           <a:prstGeom prst="rect">
             <a:avLst/>
           </a:prstGeom>
-          <a:gradFill>
-            <a:gsLst>
-              <a:gs pos="24000">
-                <a:schemeClr val="bg1"/>
-              </a:gs>
-              <a:gs pos="100000">
-                <a:schemeClr val="bg1">
-                  <a:alpha val="0"/>
-                </a:schemeClr>
-              </a:gs>
-            </a:gsLst>
-            <a:path path="circle">
-              <a:fillToRect l="50000" t="50000" r="50000" b="50000"/>
-            </a:path>
-          </a:gradFill>
+          <a:noFill/>
         </p:spPr>
         <p:txBody>
           <a:bodyPr wrap="none" rtlCol="0">
@@ -18853,29 +18692,20 @@
           <a:lstStyle/>
           <a:p>
             <a:r>
-              <a:rPr lang="en-US" altLang="zh-CN" sz="1600" i="1" dirty="0" err="1">
-                <a:solidFill>
-                  <a:srgbClr val="0000CD"/>
-                </a:solidFill>
-                <a:latin typeface="Times New Roman" panose="02020603050405020304" pitchFamily="18" charset="0"/>
-                <a:cs typeface="Times New Roman" panose="02020603050405020304" pitchFamily="18" charset="0"/>
-              </a:rPr>
-              <a:t>h</a:t>
-            </a:r>
-            <a:r>
-              <a:rPr lang="en-US" altLang="zh-CN" sz="1600" i="1" baseline="-25000" dirty="0" err="1">
-                <a:solidFill>
-                  <a:srgbClr val="0000CD"/>
-                </a:solidFill>
-                <a:latin typeface="Times New Roman" panose="02020603050405020304" pitchFamily="18" charset="0"/>
-                <a:cs typeface="Times New Roman" panose="02020603050405020304" pitchFamily="18" charset="0"/>
-              </a:rPr>
-              <a:t>VT</a:t>
+              <a:rPr lang="en-US" altLang="zh-CN" sz="1600" i="1" dirty="0">
+                <a:latin typeface="Times New Roman" panose="02020603050405020304" pitchFamily="18" charset="0"/>
+                <a:cs typeface="Times New Roman" panose="02020603050405020304" pitchFamily="18" charset="0"/>
+              </a:rPr>
+              <a:t>TPP</a:t>
+            </a:r>
+            <a:r>
+              <a:rPr lang="en-US" altLang="zh-CN" sz="1600" i="1" baseline="-25000" dirty="0">
+                <a:latin typeface="Times New Roman" panose="02020603050405020304" pitchFamily="18" charset="0"/>
+                <a:cs typeface="Times New Roman" panose="02020603050405020304" pitchFamily="18" charset="0"/>
+              </a:rPr>
+              <a:t>LR</a:t>
             </a:r>
             <a:endParaRPr lang="zh-CN" altLang="en-US" sz="1600" i="1" baseline="-25000" dirty="0">
-              <a:solidFill>
-                <a:srgbClr val="0000CD"/>
-              </a:solidFill>
               <a:latin typeface="Times New Roman" panose="02020603050405020304" pitchFamily="18" charset="0"/>
               <a:cs typeface="Times New Roman" panose="02020603050405020304" pitchFamily="18" charset="0"/>
             </a:endParaRPr>
@@ -18884,10 +18714,10 @@
       </p:sp>
       <p:sp>
         <p:nvSpPr>
-          <p:cNvPr id="698" name="文本框 697">
-            <a:extLst>
-              <a:ext uri="{FF2B5EF4-FFF2-40B4-BE49-F238E27FC236}">
-                <a16:creationId xmlns:a16="http://schemas.microsoft.com/office/drawing/2014/main" id="{2DF3CB69-63A2-B3DC-0144-99AB9254180D}"/>
+          <p:cNvPr id="700" name="文本框 699">
+            <a:extLst>
+              <a:ext uri="{FF2B5EF4-FFF2-40B4-BE49-F238E27FC236}">
+                <a16:creationId xmlns:a16="http://schemas.microsoft.com/office/drawing/2014/main" id="{52A8ADF1-E2DB-6492-1D11-D53EB8815883}"/>
               </a:ext>
             </a:extLst>
           </p:cNvPr>
@@ -18896,8 +18726,8 @@
         </p:nvSpPr>
         <p:spPr>
           <a:xfrm>
-            <a:off x="11415488" y="1960212"/>
-            <a:ext cx="731290" cy="338554"/>
+            <a:off x="7564913" y="1918194"/>
+            <a:ext cx="639919" cy="338554"/>
           </a:xfrm>
           <a:prstGeom prst="rect">
             <a:avLst/>
@@ -18915,7 +18745,7 @@
                 <a:latin typeface="Times New Roman" panose="02020603050405020304" pitchFamily="18" charset="0"/>
                 <a:cs typeface="Times New Roman" panose="02020603050405020304" pitchFamily="18" charset="0"/>
               </a:rPr>
-              <a:t>TPP</a:t>
+              <a:t>HP</a:t>
             </a:r>
             <a:r>
               <a:rPr lang="en-US" altLang="zh-CN" sz="1600" i="1" baseline="-25000" dirty="0">
@@ -18933,10 +18763,10 @@
       </p:sp>
       <p:sp>
         <p:nvSpPr>
-          <p:cNvPr id="699" name="文本框 698">
-            <a:extLst>
-              <a:ext uri="{FF2B5EF4-FFF2-40B4-BE49-F238E27FC236}">
-                <a16:creationId xmlns:a16="http://schemas.microsoft.com/office/drawing/2014/main" id="{01DB1B03-FD95-A5DD-B402-50BD9002E032}"/>
+          <p:cNvPr id="701" name="文本框 700">
+            <a:extLst>
+              <a:ext uri="{FF2B5EF4-FFF2-40B4-BE49-F238E27FC236}">
+                <a16:creationId xmlns:a16="http://schemas.microsoft.com/office/drawing/2014/main" id="{0E0344B6-55C6-DA8D-C738-0A0E7B1E1CDB}"/>
               </a:ext>
             </a:extLst>
           </p:cNvPr>
@@ -18945,8 +18775,8 @@
         </p:nvSpPr>
         <p:spPr>
           <a:xfrm>
-            <a:off x="11335585" y="2481635"/>
-            <a:ext cx="707245" cy="338554"/>
+            <a:off x="7425612" y="2392333"/>
+            <a:ext cx="615874" cy="338554"/>
           </a:xfrm>
           <a:prstGeom prst="rect">
             <a:avLst/>
@@ -18964,7 +18794,7 @@
                 <a:latin typeface="Times New Roman" panose="02020603050405020304" pitchFamily="18" charset="0"/>
                 <a:cs typeface="Times New Roman" panose="02020603050405020304" pitchFamily="18" charset="0"/>
               </a:rPr>
-              <a:t>TPP</a:t>
+              <a:t>HP</a:t>
             </a:r>
             <a:r>
               <a:rPr lang="en-US" altLang="zh-CN" sz="1600" i="1" baseline="-25000" dirty="0">
@@ -18982,10 +18812,10 @@
       </p:sp>
       <p:sp>
         <p:nvSpPr>
-          <p:cNvPr id="700" name="文本框 699">
-            <a:extLst>
-              <a:ext uri="{FF2B5EF4-FFF2-40B4-BE49-F238E27FC236}">
-                <a16:creationId xmlns:a16="http://schemas.microsoft.com/office/drawing/2014/main" id="{52A8ADF1-E2DB-6492-1D11-D53EB8815883}"/>
+          <p:cNvPr id="733" name="文本框 732">
+            <a:extLst>
+              <a:ext uri="{FF2B5EF4-FFF2-40B4-BE49-F238E27FC236}">
+                <a16:creationId xmlns:a16="http://schemas.microsoft.com/office/drawing/2014/main" id="{2A2896AD-C315-E106-F81F-9121EA723B13}"/>
               </a:ext>
             </a:extLst>
           </p:cNvPr>
@@ -18994,105 +18824,7 @@
         </p:nvSpPr>
         <p:spPr>
           <a:xfrm>
-            <a:off x="7564913" y="1918194"/>
-            <a:ext cx="639919" cy="338554"/>
-          </a:xfrm>
-          <a:prstGeom prst="rect">
-            <a:avLst/>
-          </a:prstGeom>
-          <a:noFill/>
-        </p:spPr>
-        <p:txBody>
-          <a:bodyPr wrap="none" rtlCol="0">
-            <a:spAutoFit/>
-          </a:bodyPr>
-          <a:lstStyle/>
-          <a:p>
-            <a:r>
-              <a:rPr lang="en-US" altLang="zh-CN" sz="1600" i="1" dirty="0">
-                <a:latin typeface="Times New Roman" panose="02020603050405020304" pitchFamily="18" charset="0"/>
-                <a:cs typeface="Times New Roman" panose="02020603050405020304" pitchFamily="18" charset="0"/>
-              </a:rPr>
-              <a:t>HP</a:t>
-            </a:r>
-            <a:r>
-              <a:rPr lang="en-US" altLang="zh-CN" sz="1600" i="1" baseline="-25000" dirty="0">
-                <a:latin typeface="Times New Roman" panose="02020603050405020304" pitchFamily="18" charset="0"/>
-                <a:cs typeface="Times New Roman" panose="02020603050405020304" pitchFamily="18" charset="0"/>
-              </a:rPr>
-              <a:t>UR</a:t>
-            </a:r>
-            <a:endParaRPr lang="zh-CN" altLang="en-US" sz="1600" i="1" baseline="-25000" dirty="0">
-              <a:latin typeface="Times New Roman" panose="02020603050405020304" pitchFamily="18" charset="0"/>
-              <a:cs typeface="Times New Roman" panose="02020603050405020304" pitchFamily="18" charset="0"/>
-            </a:endParaRPr>
-          </a:p>
-        </p:txBody>
-      </p:sp>
-      <p:sp>
-        <p:nvSpPr>
-          <p:cNvPr id="701" name="文本框 700">
-            <a:extLst>
-              <a:ext uri="{FF2B5EF4-FFF2-40B4-BE49-F238E27FC236}">
-                <a16:creationId xmlns:a16="http://schemas.microsoft.com/office/drawing/2014/main" id="{0E0344B6-55C6-DA8D-C738-0A0E7B1E1CDB}"/>
-              </a:ext>
-            </a:extLst>
-          </p:cNvPr>
-          <p:cNvSpPr txBox="1"/>
-          <p:nvPr/>
-        </p:nvSpPr>
-        <p:spPr>
-          <a:xfrm>
-            <a:off x="7425612" y="2392333"/>
-            <a:ext cx="615874" cy="338554"/>
-          </a:xfrm>
-          <a:prstGeom prst="rect">
-            <a:avLst/>
-          </a:prstGeom>
-          <a:noFill/>
-        </p:spPr>
-        <p:txBody>
-          <a:bodyPr wrap="none" rtlCol="0">
-            <a:spAutoFit/>
-          </a:bodyPr>
-          <a:lstStyle/>
-          <a:p>
-            <a:r>
-              <a:rPr lang="en-US" altLang="zh-CN" sz="1600" i="1" dirty="0">
-                <a:latin typeface="Times New Roman" panose="02020603050405020304" pitchFamily="18" charset="0"/>
-                <a:cs typeface="Times New Roman" panose="02020603050405020304" pitchFamily="18" charset="0"/>
-              </a:rPr>
-              <a:t>HP</a:t>
-            </a:r>
-            <a:r>
-              <a:rPr lang="en-US" altLang="zh-CN" sz="1600" i="1" baseline="-25000" dirty="0">
-                <a:latin typeface="Times New Roman" panose="02020603050405020304" pitchFamily="18" charset="0"/>
-                <a:cs typeface="Times New Roman" panose="02020603050405020304" pitchFamily="18" charset="0"/>
-              </a:rPr>
-              <a:t>LR</a:t>
-            </a:r>
-            <a:endParaRPr lang="zh-CN" altLang="en-US" sz="1600" i="1" baseline="-25000" dirty="0">
-              <a:latin typeface="Times New Roman" panose="02020603050405020304" pitchFamily="18" charset="0"/>
-              <a:cs typeface="Times New Roman" panose="02020603050405020304" pitchFamily="18" charset="0"/>
-            </a:endParaRPr>
-          </a:p>
-        </p:txBody>
-      </p:sp>
-      <p:sp>
-        <p:nvSpPr>
-          <p:cNvPr id="733" name="文本框 732">
-            <a:extLst>
-              <a:ext uri="{FF2B5EF4-FFF2-40B4-BE49-F238E27FC236}">
-                <a16:creationId xmlns:a16="http://schemas.microsoft.com/office/drawing/2014/main" id="{2A2896AD-C315-E106-F81F-9121EA723B13}"/>
-              </a:ext>
-            </a:extLst>
-          </p:cNvPr>
-          <p:cNvSpPr txBox="1"/>
-          <p:nvPr/>
-        </p:nvSpPr>
-        <p:spPr>
-          <a:xfrm>
-            <a:off x="5982856" y="2339198"/>
+            <a:off x="5100831" y="2499831"/>
             <a:ext cx="473206" cy="338554"/>
           </a:xfrm>
           <a:prstGeom prst="rect">
@@ -19150,7 +18882,7 @@
         </p:nvSpPr>
         <p:spPr>
           <a:xfrm>
-            <a:off x="6550947" y="2725323"/>
+            <a:off x="5589130" y="2836295"/>
             <a:ext cx="506870" cy="338554"/>
           </a:xfrm>
           <a:prstGeom prst="rect">
@@ -19208,7 +18940,7 @@
         </p:nvSpPr>
         <p:spPr>
           <a:xfrm>
-            <a:off x="6840000" y="3089424"/>
+            <a:off x="6239746" y="2804651"/>
             <a:ext cx="593432" cy="338554"/>
           </a:xfrm>
           <a:prstGeom prst="rect">
@@ -20078,7 +19810,7 @@
         </p:nvSpPr>
         <p:spPr>
           <a:xfrm>
-            <a:off x="9467851" y="3325689"/>
+            <a:off x="9467851" y="3278860"/>
             <a:ext cx="212230" cy="338554"/>
           </a:xfrm>
           <a:prstGeom prst="rect">
@@ -20315,7 +20047,7 @@
         </p:nvSpPr>
         <p:spPr>
           <a:xfrm>
-            <a:off x="8902686" y="3552494"/>
+            <a:off x="8918657" y="3552494"/>
             <a:ext cx="461986" cy="338554"/>
           </a:xfrm>
           <a:prstGeom prst="rect">
@@ -20792,10 +20524,10 @@
           </a:prstGeom>
           <a:gradFill>
             <a:gsLst>
-              <a:gs pos="27000">
+              <a:gs pos="17000">
                 <a:schemeClr val="bg1"/>
               </a:gs>
-              <a:gs pos="43000">
+              <a:gs pos="100000">
                 <a:schemeClr val="bg1">
                   <a:alpha val="0"/>
                 </a:schemeClr>
@@ -21073,6 +20805,109 @@
           </a:p>
         </p:txBody>
       </p:sp>
+      <p:sp>
+        <p:nvSpPr>
+          <p:cNvPr id="17" name="文本框 16">
+            <a:extLst>
+              <a:ext uri="{FF2B5EF4-FFF2-40B4-BE49-F238E27FC236}">
+                <a16:creationId xmlns:a16="http://schemas.microsoft.com/office/drawing/2014/main" id="{61D3D5D1-4304-8A52-B7F5-CDFD12DD61BD}"/>
+              </a:ext>
+            </a:extLst>
+          </p:cNvPr>
+          <p:cNvSpPr txBox="1"/>
+          <p:nvPr/>
+        </p:nvSpPr>
+        <p:spPr>
+          <a:xfrm>
+            <a:off x="4146789" y="2955645"/>
+            <a:ext cx="445956" cy="338554"/>
+          </a:xfrm>
+          <a:prstGeom prst="rect">
+            <a:avLst/>
+          </a:prstGeom>
+          <a:noFill/>
+        </p:spPr>
+        <p:txBody>
+          <a:bodyPr wrap="none" rtlCol="0">
+            <a:spAutoFit/>
+          </a:bodyPr>
+          <a:lstStyle/>
+          <a:p>
+            <a:r>
+              <a:rPr lang="en-US" altLang="zh-CN" sz="1600" i="1" dirty="0" err="1">
+                <a:solidFill>
+                  <a:srgbClr val="0000CD"/>
+                </a:solidFill>
+                <a:latin typeface="Times New Roman" panose="02020603050405020304" pitchFamily="18" charset="0"/>
+                <a:cs typeface="Times New Roman" panose="02020603050405020304" pitchFamily="18" charset="0"/>
+              </a:rPr>
+              <a:t>h</a:t>
+            </a:r>
+            <a:r>
+              <a:rPr lang="en-US" altLang="zh-CN" sz="1600" i="1" baseline="-25000" dirty="0" err="1">
+                <a:solidFill>
+                  <a:srgbClr val="0000CD"/>
+                </a:solidFill>
+                <a:latin typeface="Times New Roman" panose="02020603050405020304" pitchFamily="18" charset="0"/>
+                <a:cs typeface="Times New Roman" panose="02020603050405020304" pitchFamily="18" charset="0"/>
+              </a:rPr>
+              <a:t>LR</a:t>
+            </a:r>
+            <a:endParaRPr lang="zh-CN" altLang="en-US" sz="1600" i="1" baseline="-25000" dirty="0">
+              <a:solidFill>
+                <a:srgbClr val="0000CD"/>
+              </a:solidFill>
+              <a:latin typeface="Times New Roman" panose="02020603050405020304" pitchFamily="18" charset="0"/>
+              <a:cs typeface="Times New Roman" panose="02020603050405020304" pitchFamily="18" charset="0"/>
+            </a:endParaRPr>
+          </a:p>
+        </p:txBody>
+      </p:sp>
+      <p:cxnSp>
+        <p:nvCxnSpPr>
+          <p:cNvPr id="20" name="直接箭头连接符 19">
+            <a:extLst>
+              <a:ext uri="{FF2B5EF4-FFF2-40B4-BE49-F238E27FC236}">
+                <a16:creationId xmlns:a16="http://schemas.microsoft.com/office/drawing/2014/main" id="{A63BF9C7-983F-5C2B-2264-47912110C621}"/>
+              </a:ext>
+            </a:extLst>
+          </p:cNvPr>
+          <p:cNvCxnSpPr>
+            <a:cxnSpLocks/>
+          </p:cNvCxnSpPr>
+          <p:nvPr/>
+        </p:nvCxnSpPr>
+        <p:spPr>
+          <a:xfrm rot="935833" flipV="1">
+            <a:off x="8618199" y="3421285"/>
+            <a:ext cx="0" cy="363536"/>
+          </a:xfrm>
+          <a:prstGeom prst="straightConnector1">
+            <a:avLst/>
+          </a:prstGeom>
+          <a:ln w="12700">
+            <a:solidFill>
+              <a:srgbClr val="0000CD"/>
+            </a:solidFill>
+            <a:headEnd type="triangle"/>
+            <a:tailEnd type="triangle"/>
+          </a:ln>
+        </p:spPr>
+        <p:style>
+          <a:lnRef idx="2">
+            <a:schemeClr val="accent1"/>
+          </a:lnRef>
+          <a:fillRef idx="0">
+            <a:schemeClr val="accent1"/>
+          </a:fillRef>
+          <a:effectRef idx="1">
+            <a:schemeClr val="accent1"/>
+          </a:effectRef>
+          <a:fontRef idx="minor">
+            <a:schemeClr val="tx1"/>
+          </a:fontRef>
+        </p:style>
+      </p:cxnSp>
     </p:spTree>
     <p:extLst>
       <p:ext uri="{BB962C8B-B14F-4D97-AF65-F5344CB8AC3E}">
@@ -21319,7 +21154,7 @@
       </p:sp>
       <p:pic>
         <p:nvPicPr>
-          <p:cNvPr id="3" name="图片 2" descr="图标&#10;&#10;AI 生成的内容可能不正确。">
+          <p:cNvPr id="3" name="图片 2">
             <a:extLst>
               <a:ext uri="{FF2B5EF4-FFF2-40B4-BE49-F238E27FC236}">
                 <a16:creationId xmlns:a16="http://schemas.microsoft.com/office/drawing/2014/main" id="{4CEAE2BB-ED8C-A2AD-B6C5-083DFBB5BF78}"/>
@@ -21339,14 +21174,13 @@
               </a:ext>
             </a:extLst>
           </a:blip>
-          <a:stretch>
-            <a:fillRect/>
-          </a:stretch>
+          <a:srcRect/>
+          <a:stretch/>
         </p:blipFill>
         <p:spPr>
           <a:xfrm>
             <a:off x="712269" y="400803"/>
-            <a:ext cx="10767461" cy="6056394"/>
+            <a:ext cx="10767460" cy="6056394"/>
           </a:xfrm>
           <a:prstGeom prst="rect">
             <a:avLst/>
@@ -21369,7 +21203,7 @@
         </p:nvCxnSpPr>
         <p:spPr>
           <a:xfrm flipV="1">
-            <a:off x="9453377" y="1026160"/>
+            <a:off x="8217991" y="1034628"/>
             <a:ext cx="0" cy="1057248"/>
           </a:xfrm>
           <a:prstGeom prst="straightConnector1">
@@ -21411,7 +21245,7 @@
         </p:nvSpPr>
         <p:spPr>
           <a:xfrm>
-            <a:off x="9479550" y="856883"/>
+            <a:off x="8244164" y="865351"/>
             <a:ext cx="449547" cy="338554"/>
           </a:xfrm>
           <a:prstGeom prst="rect">
@@ -21896,7 +21730,7 @@
         <p:spPr>
           <a:xfrm>
             <a:off x="4343400" y="2105026"/>
-            <a:ext cx="5109977" cy="0"/>
+            <a:ext cx="3874591" cy="2426"/>
           </a:xfrm>
           <a:prstGeom prst="straightConnector1">
             <a:avLst/>
@@ -21981,7 +21815,7 @@
         </p:nvSpPr>
         <p:spPr>
           <a:xfrm>
-            <a:off x="6697852" y="1747311"/>
+            <a:off x="6135880" y="1734723"/>
             <a:ext cx="401072" cy="338554"/>
           </a:xfrm>
           <a:prstGeom prst="rect">
@@ -22223,7 +22057,7 @@
         </p:nvSpPr>
         <p:spPr>
           <a:xfrm>
-            <a:off x="4330004" y="2503682"/>
+            <a:off x="4319470" y="2521654"/>
             <a:ext cx="381836" cy="338554"/>
           </a:xfrm>
           <a:prstGeom prst="rect">
@@ -22281,7 +22115,7 @@
         </p:nvSpPr>
         <p:spPr>
           <a:xfrm>
-            <a:off x="5624877" y="3088881"/>
+            <a:off x="5497878" y="3088881"/>
             <a:ext cx="1043876" cy="338554"/>
           </a:xfrm>
           <a:prstGeom prst="rect">
@@ -22589,7 +22423,7 @@
         </p:nvSpPr>
         <p:spPr>
           <a:xfrm>
-            <a:off x="4181081" y="3556798"/>
+            <a:off x="4226643" y="3557272"/>
             <a:ext cx="481222" cy="338554"/>
           </a:xfrm>
           <a:prstGeom prst="rect">
@@ -23000,7 +22834,7 @@
         </p:nvCxnSpPr>
         <p:spPr>
           <a:xfrm>
-            <a:off x="9798689" y="2113360"/>
+            <a:off x="8563303" y="2117595"/>
             <a:ext cx="421636" cy="0"/>
           </a:xfrm>
           <a:prstGeom prst="straightConnector1">
@@ -23044,7 +22878,7 @@
         </p:nvCxnSpPr>
         <p:spPr>
           <a:xfrm>
-            <a:off x="9798689" y="4793063"/>
+            <a:off x="8563303" y="4805764"/>
             <a:ext cx="421636" cy="0"/>
           </a:xfrm>
           <a:prstGeom prst="straightConnector1">
@@ -23086,7 +22920,7 @@
         </p:nvSpPr>
         <p:spPr>
           <a:xfrm>
-            <a:off x="10329908" y="3274589"/>
+            <a:off x="9094522" y="3283057"/>
             <a:ext cx="506870" cy="338554"/>
           </a:xfrm>
           <a:prstGeom prst="rect">
@@ -23144,7 +22978,7 @@
         </p:nvSpPr>
         <p:spPr>
           <a:xfrm>
-            <a:off x="10204433" y="1944083"/>
+            <a:off x="8969047" y="1952551"/>
             <a:ext cx="506870" cy="338554"/>
           </a:xfrm>
           <a:prstGeom prst="rect">
@@ -23202,7 +23036,7 @@
         </p:nvSpPr>
         <p:spPr>
           <a:xfrm>
-            <a:off x="10204433" y="4609748"/>
+            <a:off x="8969047" y="4618216"/>
             <a:ext cx="506870" cy="338554"/>
           </a:xfrm>
           <a:prstGeom prst="rect">
@@ -23262,7 +23096,7 @@
         </p:nvCxnSpPr>
         <p:spPr>
           <a:xfrm>
-            <a:off x="9798689" y="3443866"/>
+            <a:off x="8563303" y="3452334"/>
             <a:ext cx="551917" cy="0"/>
           </a:xfrm>
           <a:prstGeom prst="straightConnector1">
@@ -23441,7 +23275,7 @@
         </p:nvCxnSpPr>
         <p:spPr>
           <a:xfrm flipV="1">
-            <a:off x="9453377" y="3715915"/>
+            <a:off x="8217991" y="3715915"/>
             <a:ext cx="0" cy="1057248"/>
           </a:xfrm>
           <a:prstGeom prst="straightConnector1">
@@ -23483,7 +23317,7 @@
         </p:nvSpPr>
         <p:spPr>
           <a:xfrm>
-            <a:off x="9479550" y="3550448"/>
+            <a:off x="8244164" y="3550448"/>
             <a:ext cx="449547" cy="338554"/>
           </a:xfrm>
           <a:prstGeom prst="rect">

</xml_diff>

<commit_message>
Force & Moment Function v3.2
- Force and Monet isolated rotor and tail aerodynamics model for hover finished
- Force and Monet isolated rotor and tail aerodynamics model for forward flight finished
- Still need force and moment dynamics model update to run the entire code for forward flight
</commit_message>
<xml_diff>
--- a/HER05/01 - Mathematical Modeling/Sketch/Forces and Moments Sketch.pptx
+++ b/HER05/01 - Mathematical Modeling/Sketch/Forces and Moments Sketch.pptx
@@ -122,7 +122,7 @@
 <file path=ppt/revisionInfo.xml><?xml version="1.0" encoding="utf-8"?>
 <p1510:revInfo xmlns:a="http://schemas.openxmlformats.org/drawingml/2006/main" xmlns:r="http://schemas.openxmlformats.org/officeDocument/2006/relationships" xmlns:p1510="http://schemas.microsoft.com/office/powerpoint/2015/10/main">
   <p1510:revLst>
-    <p1510:client id="{CDC5B0EF-6BEB-4658-A9FF-CB66F6FA6C1E}" v="427" dt="2025-05-30T23:12:18.535"/>
+    <p1510:client id="{CDC5B0EF-6BEB-4658-A9FF-CB66F6FA6C1E}" v="433" dt="2025-06-02T21:21:55.276"/>
   </p1510:revLst>
 </p1510:revInfo>
 </file>
@@ -132,12 +132,12 @@
   <pc:docChgLst>
     <pc:chgData name="Li, Hanchen F" userId="3aee791e-6a2d-4da7-a77b-fbdf7bf15886" providerId="ADAL" clId="{CDC5B0EF-6BEB-4658-A9FF-CB66F6FA6C1E}"/>
     <pc:docChg chg="undo redo custSel addSld delSld modSld modMainMaster modNotesMaster">
-      <pc:chgData name="Li, Hanchen F" userId="3aee791e-6a2d-4da7-a77b-fbdf7bf15886" providerId="ADAL" clId="{CDC5B0EF-6BEB-4658-A9FF-CB66F6FA6C1E}" dt="2025-05-30T23:13:44.554" v="9565" actId="207"/>
+      <pc:chgData name="Li, Hanchen F" userId="3aee791e-6a2d-4da7-a77b-fbdf7bf15886" providerId="ADAL" clId="{CDC5B0EF-6BEB-4658-A9FF-CB66F6FA6C1E}" dt="2025-06-02T22:09:19.571" v="9897" actId="114"/>
       <pc:docMkLst>
         <pc:docMk/>
       </pc:docMkLst>
       <pc:sldChg chg="addSp delSp modSp new mod">
-        <pc:chgData name="Li, Hanchen F" userId="3aee791e-6a2d-4da7-a77b-fbdf7bf15886" providerId="ADAL" clId="{CDC5B0EF-6BEB-4658-A9FF-CB66F6FA6C1E}" dt="2025-05-30T23:13:44.554" v="9565" actId="207"/>
+        <pc:chgData name="Li, Hanchen F" userId="3aee791e-6a2d-4da7-a77b-fbdf7bf15886" providerId="ADAL" clId="{CDC5B0EF-6BEB-4658-A9FF-CB66F6FA6C1E}" dt="2025-06-02T21:23:35.009" v="9866" actId="478"/>
         <pc:sldMkLst>
           <pc:docMk/>
           <pc:sldMk cId="2152317508" sldId="256"/>
@@ -239,7 +239,7 @@
           </ac:spMkLst>
         </pc:spChg>
         <pc:spChg chg="add mod">
-          <ac:chgData name="Li, Hanchen F" userId="3aee791e-6a2d-4da7-a77b-fbdf7bf15886" providerId="ADAL" clId="{CDC5B0EF-6BEB-4658-A9FF-CB66F6FA6C1E}" dt="2025-05-26T23:54:02.443" v="8826" actId="1076"/>
+          <ac:chgData name="Li, Hanchen F" userId="3aee791e-6a2d-4da7-a77b-fbdf7bf15886" providerId="ADAL" clId="{CDC5B0EF-6BEB-4658-A9FF-CB66F6FA6C1E}" dt="2025-06-02T21:22:19.352" v="9853" actId="1076"/>
           <ac:spMkLst>
             <pc:docMk/>
             <pc:sldMk cId="2152317508" sldId="256"/>
@@ -254,12 +254,44 @@
             <ac:spMk id="17" creationId="{61D3D5D1-4304-8A52-B7F5-CDFD12DD61BD}"/>
           </ac:spMkLst>
         </pc:spChg>
+        <pc:spChg chg="add mod">
+          <ac:chgData name="Li, Hanchen F" userId="3aee791e-6a2d-4da7-a77b-fbdf7bf15886" providerId="ADAL" clId="{CDC5B0EF-6BEB-4658-A9FF-CB66F6FA6C1E}" dt="2025-06-02T21:23:05.460" v="9863" actId="1076"/>
+          <ac:spMkLst>
+            <pc:docMk/>
+            <pc:sldMk cId="2152317508" sldId="256"/>
+            <ac:spMk id="25" creationId="{1660E916-C2FE-42A2-C6D7-9DDF07E1CD2C}"/>
+          </ac:spMkLst>
+        </pc:spChg>
+        <pc:spChg chg="add del mod">
+          <ac:chgData name="Li, Hanchen F" userId="3aee791e-6a2d-4da7-a77b-fbdf7bf15886" providerId="ADAL" clId="{CDC5B0EF-6BEB-4658-A9FF-CB66F6FA6C1E}" dt="2025-06-02T21:21:58.886" v="9848" actId="478"/>
+          <ac:spMkLst>
+            <pc:docMk/>
+            <pc:sldMk cId="2152317508" sldId="256"/>
+            <ac:spMk id="28" creationId="{59778F99-9FE1-60A0-1734-8D3358AEDEEB}"/>
+          </ac:spMkLst>
+        </pc:spChg>
+        <pc:spChg chg="add mod">
+          <ac:chgData name="Li, Hanchen F" userId="3aee791e-6a2d-4da7-a77b-fbdf7bf15886" providerId="ADAL" clId="{CDC5B0EF-6BEB-4658-A9FF-CB66F6FA6C1E}" dt="2025-06-02T21:22:22.882" v="9854" actId="1076"/>
+          <ac:spMkLst>
+            <pc:docMk/>
+            <pc:sldMk cId="2152317508" sldId="256"/>
+            <ac:spMk id="29" creationId="{054E6DA5-FF54-1C95-99AC-1044B339546B}"/>
+          </ac:spMkLst>
+        </pc:spChg>
         <pc:spChg chg="add mod topLvl">
           <ac:chgData name="Li, Hanchen F" userId="3aee791e-6a2d-4da7-a77b-fbdf7bf15886" providerId="ADAL" clId="{CDC5B0EF-6BEB-4658-A9FF-CB66F6FA6C1E}" dt="2025-05-30T22:35:23.784" v="8872" actId="14826"/>
           <ac:spMkLst>
             <pc:docMk/>
             <pc:sldMk cId="2152317508" sldId="256"/>
             <ac:spMk id="30" creationId="{03E7375E-B3C1-217F-067E-365A732738CA}"/>
+          </ac:spMkLst>
+        </pc:spChg>
+        <pc:spChg chg="add del mod">
+          <ac:chgData name="Li, Hanchen F" userId="3aee791e-6a2d-4da7-a77b-fbdf7bf15886" providerId="ADAL" clId="{CDC5B0EF-6BEB-4658-A9FF-CB66F6FA6C1E}" dt="2025-06-02T21:23:35.009" v="9866" actId="478"/>
+          <ac:spMkLst>
+            <pc:docMk/>
+            <pc:sldMk cId="2152317508" sldId="256"/>
+            <ac:spMk id="33" creationId="{2CB2C986-2354-CB99-B566-34CF59B975CB}"/>
           </ac:spMkLst>
         </pc:spChg>
         <pc:spChg chg="add mod ord topLvl">
@@ -383,7 +415,7 @@
           </ac:spMkLst>
         </pc:spChg>
         <pc:spChg chg="add mod ord">
-          <ac:chgData name="Li, Hanchen F" userId="3aee791e-6a2d-4da7-a77b-fbdf7bf15886" providerId="ADAL" clId="{CDC5B0EF-6BEB-4658-A9FF-CB66F6FA6C1E}" dt="2025-05-23T16:54:39.979" v="7719" actId="1076"/>
+          <ac:chgData name="Li, Hanchen F" userId="3aee791e-6a2d-4da7-a77b-fbdf7bf15886" providerId="ADAL" clId="{CDC5B0EF-6BEB-4658-A9FF-CB66F6FA6C1E}" dt="2025-05-30T23:27:54.734" v="9633" actId="1036"/>
           <ac:spMkLst>
             <pc:docMk/>
             <pc:sldMk cId="2152317508" sldId="256"/>
@@ -775,7 +807,7 @@
           </ac:spMkLst>
         </pc:spChg>
         <pc:spChg chg="add mod">
-          <ac:chgData name="Li, Hanchen F" userId="3aee791e-6a2d-4da7-a77b-fbdf7bf15886" providerId="ADAL" clId="{CDC5B0EF-6BEB-4658-A9FF-CB66F6FA6C1E}" dt="2025-05-23T23:40:04.556" v="8220" actId="1076"/>
+          <ac:chgData name="Li, Hanchen F" userId="3aee791e-6a2d-4da7-a77b-fbdf7bf15886" providerId="ADAL" clId="{CDC5B0EF-6BEB-4658-A9FF-CB66F6FA6C1E}" dt="2025-05-30T23:27:54.734" v="9633" actId="1036"/>
           <ac:spMkLst>
             <pc:docMk/>
             <pc:sldMk cId="2152317508" sldId="256"/>
@@ -783,7 +815,7 @@
           </ac:spMkLst>
         </pc:spChg>
         <pc:spChg chg="add mod">
-          <ac:chgData name="Li, Hanchen F" userId="3aee791e-6a2d-4da7-a77b-fbdf7bf15886" providerId="ADAL" clId="{CDC5B0EF-6BEB-4658-A9FF-CB66F6FA6C1E}" dt="2025-05-23T23:40:01.476" v="8219" actId="1076"/>
+          <ac:chgData name="Li, Hanchen F" userId="3aee791e-6a2d-4da7-a77b-fbdf7bf15886" providerId="ADAL" clId="{CDC5B0EF-6BEB-4658-A9FF-CB66F6FA6C1E}" dt="2025-05-30T23:28:03.341" v="9651" actId="1037"/>
           <ac:spMkLst>
             <pc:docMk/>
             <pc:sldMk cId="2152317508" sldId="256"/>
@@ -791,7 +823,7 @@
           </ac:spMkLst>
         </pc:spChg>
         <pc:spChg chg="add mod">
-          <ac:chgData name="Li, Hanchen F" userId="3aee791e-6a2d-4da7-a77b-fbdf7bf15886" providerId="ADAL" clId="{CDC5B0EF-6BEB-4658-A9FF-CB66F6FA6C1E}" dt="2025-05-23T16:54:39.979" v="7719" actId="1076"/>
+          <ac:chgData name="Li, Hanchen F" userId="3aee791e-6a2d-4da7-a77b-fbdf7bf15886" providerId="ADAL" clId="{CDC5B0EF-6BEB-4658-A9FF-CB66F6FA6C1E}" dt="2025-05-30T23:27:54.734" v="9633" actId="1036"/>
           <ac:spMkLst>
             <pc:docMk/>
             <pc:sldMk cId="2152317508" sldId="256"/>
@@ -799,7 +831,7 @@
           </ac:spMkLst>
         </pc:spChg>
         <pc:spChg chg="add mod">
-          <ac:chgData name="Li, Hanchen F" userId="3aee791e-6a2d-4da7-a77b-fbdf7bf15886" providerId="ADAL" clId="{CDC5B0EF-6BEB-4658-A9FF-CB66F6FA6C1E}" dt="2025-05-23T23:39:57.228" v="8217" actId="1076"/>
+          <ac:chgData name="Li, Hanchen F" userId="3aee791e-6a2d-4da7-a77b-fbdf7bf15886" providerId="ADAL" clId="{CDC5B0EF-6BEB-4658-A9FF-CB66F6FA6C1E}" dt="2025-05-30T23:28:06.107" v="9655" actId="1035"/>
           <ac:spMkLst>
             <pc:docMk/>
             <pc:sldMk cId="2152317508" sldId="256"/>
@@ -807,7 +839,7 @@
           </ac:spMkLst>
         </pc:spChg>
         <pc:spChg chg="add mod">
-          <ac:chgData name="Li, Hanchen F" userId="3aee791e-6a2d-4da7-a77b-fbdf7bf15886" providerId="ADAL" clId="{CDC5B0EF-6BEB-4658-A9FF-CB66F6FA6C1E}" dt="2025-05-23T23:39:59.387" v="8218" actId="1076"/>
+          <ac:chgData name="Li, Hanchen F" userId="3aee791e-6a2d-4da7-a77b-fbdf7bf15886" providerId="ADAL" clId="{CDC5B0EF-6BEB-4658-A9FF-CB66F6FA6C1E}" dt="2025-05-30T23:28:01.614" v="9649" actId="1036"/>
           <ac:spMkLst>
             <pc:docMk/>
             <pc:sldMk cId="2152317508" sldId="256"/>
@@ -815,7 +847,7 @@
           </ac:spMkLst>
         </pc:spChg>
         <pc:spChg chg="add mod">
-          <ac:chgData name="Li, Hanchen F" userId="3aee791e-6a2d-4da7-a77b-fbdf7bf15886" providerId="ADAL" clId="{CDC5B0EF-6BEB-4658-A9FF-CB66F6FA6C1E}" dt="2025-05-23T23:40:07.182" v="8221" actId="1076"/>
+          <ac:chgData name="Li, Hanchen F" userId="3aee791e-6a2d-4da7-a77b-fbdf7bf15886" providerId="ADAL" clId="{CDC5B0EF-6BEB-4658-A9FF-CB66F6FA6C1E}" dt="2025-05-30T23:27:59.429" v="9641" actId="1035"/>
           <ac:spMkLst>
             <pc:docMk/>
             <pc:sldMk cId="2152317508" sldId="256"/>
@@ -951,7 +983,7 @@
           </ac:spMkLst>
         </pc:spChg>
         <pc:spChg chg="add mod">
-          <ac:chgData name="Li, Hanchen F" userId="3aee791e-6a2d-4da7-a77b-fbdf7bf15886" providerId="ADAL" clId="{CDC5B0EF-6BEB-4658-A9FF-CB66F6FA6C1E}" dt="2025-05-22T23:35:09.078" v="3625" actId="1076"/>
+          <ac:chgData name="Li, Hanchen F" userId="3aee791e-6a2d-4da7-a77b-fbdf7bf15886" providerId="ADAL" clId="{CDC5B0EF-6BEB-4658-A9FF-CB66F6FA6C1E}" dt="2025-05-30T23:34:28.615" v="9798" actId="1038"/>
           <ac:spMkLst>
             <pc:docMk/>
             <pc:sldMk cId="2152317508" sldId="256"/>
@@ -998,14 +1030,6 @@
             <ac:spMk id="691" creationId="{38987C34-3EF9-7FF9-A322-6AC7EAF3701F}"/>
           </ac:spMkLst>
         </pc:spChg>
-        <pc:spChg chg="add del mod">
-          <ac:chgData name="Li, Hanchen F" userId="3aee791e-6a2d-4da7-a77b-fbdf7bf15886" providerId="ADAL" clId="{CDC5B0EF-6BEB-4658-A9FF-CB66F6FA6C1E}" dt="2025-05-30T22:37:43.005" v="9028" actId="478"/>
-          <ac:spMkLst>
-            <pc:docMk/>
-            <pc:sldMk cId="2152317508" sldId="256"/>
-            <ac:spMk id="693" creationId="{3F9A48A1-BA63-64E8-1F9E-D38216DB2FFD}"/>
-          </ac:spMkLst>
-        </pc:spChg>
         <pc:spChg chg="add mod">
           <ac:chgData name="Li, Hanchen F" userId="3aee791e-6a2d-4da7-a77b-fbdf7bf15886" providerId="ADAL" clId="{CDC5B0EF-6BEB-4658-A9FF-CB66F6FA6C1E}" dt="2025-05-30T22:37:53.628" v="9033" actId="1076"/>
           <ac:spMkLst>
@@ -1023,7 +1047,7 @@
           </ac:spMkLst>
         </pc:spChg>
         <pc:spChg chg="add mod">
-          <ac:chgData name="Li, Hanchen F" userId="3aee791e-6a2d-4da7-a77b-fbdf7bf15886" providerId="ADAL" clId="{CDC5B0EF-6BEB-4658-A9FF-CB66F6FA6C1E}" dt="2025-05-30T22:45:51.745" v="9154" actId="1076"/>
+          <ac:chgData name="Li, Hanchen F" userId="3aee791e-6a2d-4da7-a77b-fbdf7bf15886" providerId="ADAL" clId="{CDC5B0EF-6BEB-4658-A9FF-CB66F6FA6C1E}" dt="2025-05-30T23:30:44.935" v="9705" actId="1076"/>
           <ac:spMkLst>
             <pc:docMk/>
             <pc:sldMk cId="2152317508" sldId="256"/>
@@ -1071,7 +1095,7 @@
           </ac:spMkLst>
         </pc:spChg>
         <pc:spChg chg="add mod">
-          <ac:chgData name="Li, Hanchen F" userId="3aee791e-6a2d-4da7-a77b-fbdf7bf15886" providerId="ADAL" clId="{CDC5B0EF-6BEB-4658-A9FF-CB66F6FA6C1E}" dt="2025-05-30T22:48:14.408" v="9169" actId="1076"/>
+          <ac:chgData name="Li, Hanchen F" userId="3aee791e-6a2d-4da7-a77b-fbdf7bf15886" providerId="ADAL" clId="{CDC5B0EF-6BEB-4658-A9FF-CB66F6FA6C1E}" dt="2025-05-30T23:30:55.241" v="9707" actId="1076"/>
           <ac:spMkLst>
             <pc:docMk/>
             <pc:sldMk cId="2152317508" sldId="256"/>
@@ -1079,7 +1103,7 @@
           </ac:spMkLst>
         </pc:spChg>
         <pc:spChg chg="add mod">
-          <ac:chgData name="Li, Hanchen F" userId="3aee791e-6a2d-4da7-a77b-fbdf7bf15886" providerId="ADAL" clId="{CDC5B0EF-6BEB-4658-A9FF-CB66F6FA6C1E}" dt="2025-05-30T22:48:19.545" v="9170" actId="1076"/>
+          <ac:chgData name="Li, Hanchen F" userId="3aee791e-6a2d-4da7-a77b-fbdf7bf15886" providerId="ADAL" clId="{CDC5B0EF-6BEB-4658-A9FF-CB66F6FA6C1E}" dt="2025-05-30T23:31:00.530" v="9708" actId="1076"/>
           <ac:spMkLst>
             <pc:docMk/>
             <pc:sldMk cId="2152317508" sldId="256"/>
@@ -1111,7 +1135,7 @@
           </ac:spMkLst>
         </pc:spChg>
         <pc:spChg chg="add mod">
-          <ac:chgData name="Li, Hanchen F" userId="3aee791e-6a2d-4da7-a77b-fbdf7bf15886" providerId="ADAL" clId="{CDC5B0EF-6BEB-4658-A9FF-CB66F6FA6C1E}" dt="2025-05-22T23:48:52.825" v="5002" actId="1076"/>
+          <ac:chgData name="Li, Hanchen F" userId="3aee791e-6a2d-4da7-a77b-fbdf7bf15886" providerId="ADAL" clId="{CDC5B0EF-6BEB-4658-A9FF-CB66F6FA6C1E}" dt="2025-05-30T23:35:00.123" v="9812" actId="1036"/>
           <ac:spMkLst>
             <pc:docMk/>
             <pc:sldMk cId="2152317508" sldId="256"/>
@@ -1119,7 +1143,7 @@
           </ac:spMkLst>
         </pc:spChg>
         <pc:spChg chg="add mod">
-          <ac:chgData name="Li, Hanchen F" userId="3aee791e-6a2d-4da7-a77b-fbdf7bf15886" providerId="ADAL" clId="{CDC5B0EF-6BEB-4658-A9FF-CB66F6FA6C1E}" dt="2025-05-22T23:49:26.070" v="5007" actId="1076"/>
+          <ac:chgData name="Li, Hanchen F" userId="3aee791e-6a2d-4da7-a77b-fbdf7bf15886" providerId="ADAL" clId="{CDC5B0EF-6BEB-4658-A9FF-CB66F6FA6C1E}" dt="2025-05-30T23:35:21.736" v="9816" actId="1037"/>
           <ac:spMkLst>
             <pc:docMk/>
             <pc:sldMk cId="2152317508" sldId="256"/>
@@ -1127,7 +1151,7 @@
           </ac:spMkLst>
         </pc:spChg>
         <pc:spChg chg="add mod">
-          <ac:chgData name="Li, Hanchen F" userId="3aee791e-6a2d-4da7-a77b-fbdf7bf15886" providerId="ADAL" clId="{CDC5B0EF-6BEB-4658-A9FF-CB66F6FA6C1E}" dt="2025-05-22T23:49:28.342" v="5008" actId="1076"/>
+          <ac:chgData name="Li, Hanchen F" userId="3aee791e-6a2d-4da7-a77b-fbdf7bf15886" providerId="ADAL" clId="{CDC5B0EF-6BEB-4658-A9FF-CB66F6FA6C1E}" dt="2025-05-30T23:35:24.451" v="9818" actId="1037"/>
           <ac:spMkLst>
             <pc:docMk/>
             <pc:sldMk cId="2152317508" sldId="256"/>
@@ -1167,7 +1191,7 @@
           </ac:spMkLst>
         </pc:spChg>
         <pc:spChg chg="add mod">
-          <ac:chgData name="Li, Hanchen F" userId="3aee791e-6a2d-4da7-a77b-fbdf7bf15886" providerId="ADAL" clId="{CDC5B0EF-6BEB-4658-A9FF-CB66F6FA6C1E}" dt="2025-05-22T23:53:20.828" v="5588" actId="1076"/>
+          <ac:chgData name="Li, Hanchen F" userId="3aee791e-6a2d-4da7-a77b-fbdf7bf15886" providerId="ADAL" clId="{CDC5B0EF-6BEB-4658-A9FF-CB66F6FA6C1E}" dt="2025-06-02T21:21:52.226" v="9846" actId="1076"/>
           <ac:spMkLst>
             <pc:docMk/>
             <pc:sldMk cId="2152317508" sldId="256"/>
@@ -1215,7 +1239,7 @@
           </ac:grpSpMkLst>
         </pc:grpChg>
         <pc:grpChg chg="add del mod ord">
-          <ac:chgData name="Li, Hanchen F" userId="3aee791e-6a2d-4da7-a77b-fbdf7bf15886" providerId="ADAL" clId="{CDC5B0EF-6BEB-4658-A9FF-CB66F6FA6C1E}" dt="2025-05-30T22:45:11.512" v="9146" actId="167"/>
+          <ac:chgData name="Li, Hanchen F" userId="3aee791e-6a2d-4da7-a77b-fbdf7bf15886" providerId="ADAL" clId="{CDC5B0EF-6BEB-4658-A9FF-CB66F6FA6C1E}" dt="2025-06-02T21:22:46.578" v="9859" actId="1076"/>
           <ac:grpSpMkLst>
             <pc:docMk/>
             <pc:sldMk cId="2152317508" sldId="256"/>
@@ -1223,7 +1247,7 @@
           </ac:grpSpMkLst>
         </pc:grpChg>
         <pc:grpChg chg="add del mod">
-          <ac:chgData name="Li, Hanchen F" userId="3aee791e-6a2d-4da7-a77b-fbdf7bf15886" providerId="ADAL" clId="{CDC5B0EF-6BEB-4658-A9FF-CB66F6FA6C1E}" dt="2025-05-23T16:54:39.979" v="7719" actId="1076"/>
+          <ac:chgData name="Li, Hanchen F" userId="3aee791e-6a2d-4da7-a77b-fbdf7bf15886" providerId="ADAL" clId="{CDC5B0EF-6BEB-4658-A9FF-CB66F6FA6C1E}" dt="2025-05-30T23:27:54.734" v="9633" actId="1036"/>
           <ac:grpSpMkLst>
             <pc:docMk/>
             <pc:sldMk cId="2152317508" sldId="256"/>
@@ -1239,7 +1263,7 @@
           </ac:grpSpMkLst>
         </pc:grpChg>
         <pc:picChg chg="add mod ord topLvl">
-          <ac:chgData name="Li, Hanchen F" userId="3aee791e-6a2d-4da7-a77b-fbdf7bf15886" providerId="ADAL" clId="{CDC5B0EF-6BEB-4658-A9FF-CB66F6FA6C1E}" dt="2025-05-30T22:44:35.728" v="9127" actId="167"/>
+          <ac:chgData name="Li, Hanchen F" userId="3aee791e-6a2d-4da7-a77b-fbdf7bf15886" providerId="ADAL" clId="{CDC5B0EF-6BEB-4658-A9FF-CB66F6FA6C1E}" dt="2025-05-30T23:28:49.537" v="9662" actId="1076"/>
           <ac:picMkLst>
             <pc:docMk/>
             <pc:sldMk cId="2152317508" sldId="256"/>
@@ -1271,7 +1295,7 @@
           </ac:cxnSpMkLst>
         </pc:cxnChg>
         <pc:cxnChg chg="add mod">
-          <ac:chgData name="Li, Hanchen F" userId="3aee791e-6a2d-4da7-a77b-fbdf7bf15886" providerId="ADAL" clId="{CDC5B0EF-6BEB-4658-A9FF-CB66F6FA6C1E}" dt="2025-05-30T22:39:44.064" v="9060" actId="14100"/>
+          <ac:chgData name="Li, Hanchen F" userId="3aee791e-6a2d-4da7-a77b-fbdf7bf15886" providerId="ADAL" clId="{CDC5B0EF-6BEB-4658-A9FF-CB66F6FA6C1E}" dt="2025-05-30T23:26:30.387" v="9585" actId="14100"/>
           <ac:cxnSpMkLst>
             <pc:docMk/>
             <pc:sldMk cId="2152317508" sldId="256"/>
@@ -1279,11 +1303,35 @@
           </ac:cxnSpMkLst>
         </pc:cxnChg>
         <pc:cxnChg chg="add mod">
+          <ac:chgData name="Li, Hanchen F" userId="3aee791e-6a2d-4da7-a77b-fbdf7bf15886" providerId="ADAL" clId="{CDC5B0EF-6BEB-4658-A9FF-CB66F6FA6C1E}" dt="2025-06-02T21:23:01.346" v="9862" actId="14100"/>
+          <ac:cxnSpMkLst>
+            <pc:docMk/>
+            <pc:sldMk cId="2152317508" sldId="256"/>
+            <ac:cxnSpMk id="19" creationId="{C35E9231-8CE7-8406-3F9A-0909C44D5A02}"/>
+          </ac:cxnSpMkLst>
+        </pc:cxnChg>
+        <pc:cxnChg chg="add mod">
           <ac:chgData name="Li, Hanchen F" userId="3aee791e-6a2d-4da7-a77b-fbdf7bf15886" providerId="ADAL" clId="{CDC5B0EF-6BEB-4658-A9FF-CB66F6FA6C1E}" dt="2025-05-30T23:12:23.380" v="9276" actId="1076"/>
           <ac:cxnSpMkLst>
             <pc:docMk/>
             <pc:sldMk cId="2152317508" sldId="256"/>
             <ac:cxnSpMk id="20" creationId="{A63BF9C7-983F-5C2B-2264-47912110C621}"/>
+          </ac:cxnSpMkLst>
+        </pc:cxnChg>
+        <pc:cxnChg chg="add mod">
+          <ac:chgData name="Li, Hanchen F" userId="3aee791e-6a2d-4da7-a77b-fbdf7bf15886" providerId="ADAL" clId="{CDC5B0EF-6BEB-4658-A9FF-CB66F6FA6C1E}" dt="2025-05-30T23:29:34.460" v="9685" actId="1036"/>
+          <ac:cxnSpMkLst>
+            <pc:docMk/>
+            <pc:sldMk cId="2152317508" sldId="256"/>
+            <ac:cxnSpMk id="24" creationId="{50858431-51A3-4B43-1052-473383F20DC3}"/>
+          </ac:cxnSpMkLst>
+        </pc:cxnChg>
+        <pc:cxnChg chg="add mod">
+          <ac:chgData name="Li, Hanchen F" userId="3aee791e-6a2d-4da7-a77b-fbdf7bf15886" providerId="ADAL" clId="{CDC5B0EF-6BEB-4658-A9FF-CB66F6FA6C1E}" dt="2025-06-02T21:21:33.072" v="9843" actId="1076"/>
+          <ac:cxnSpMkLst>
+            <pc:docMk/>
+            <pc:sldMk cId="2152317508" sldId="256"/>
+            <ac:cxnSpMk id="26" creationId="{A2CBE254-54EC-7669-4148-C0F37BB5CA61}"/>
           </ac:cxnSpMkLst>
         </pc:cxnChg>
         <pc:cxnChg chg="add mod">
@@ -1327,23 +1375,7 @@
           </ac:cxnSpMkLst>
         </pc:cxnChg>
         <pc:cxnChg chg="add del mod">
-          <ac:chgData name="Li, Hanchen F" userId="3aee791e-6a2d-4da7-a77b-fbdf7bf15886" providerId="ADAL" clId="{CDC5B0EF-6BEB-4658-A9FF-CB66F6FA6C1E}" dt="2025-05-30T22:46:06.154" v="9158" actId="478"/>
-          <ac:cxnSpMkLst>
-            <pc:docMk/>
-            <pc:sldMk cId="2152317508" sldId="256"/>
-            <ac:cxnSpMk id="84" creationId="{79D2A366-B413-8528-AC73-86E9F16DB2B7}"/>
-          </ac:cxnSpMkLst>
-        </pc:cxnChg>
-        <pc:cxnChg chg="add del mod">
-          <ac:chgData name="Li, Hanchen F" userId="3aee791e-6a2d-4da7-a77b-fbdf7bf15886" providerId="ADAL" clId="{CDC5B0EF-6BEB-4658-A9FF-CB66F6FA6C1E}" dt="2025-05-30T22:46:04.747" v="9157" actId="478"/>
-          <ac:cxnSpMkLst>
-            <pc:docMk/>
-            <pc:sldMk cId="2152317508" sldId="256"/>
-            <ac:cxnSpMk id="91" creationId="{E7FFA589-5910-415F-51D1-A5B2F512A967}"/>
-          </ac:cxnSpMkLst>
-        </pc:cxnChg>
-        <pc:cxnChg chg="add mod">
-          <ac:chgData name="Li, Hanchen F" userId="3aee791e-6a2d-4da7-a77b-fbdf7bf15886" providerId="ADAL" clId="{CDC5B0EF-6BEB-4658-A9FF-CB66F6FA6C1E}" dt="2025-05-30T22:41:09.377" v="9078" actId="1076"/>
+          <ac:chgData name="Li, Hanchen F" userId="3aee791e-6a2d-4da7-a77b-fbdf7bf15886" providerId="ADAL" clId="{CDC5B0EF-6BEB-4658-A9FF-CB66F6FA6C1E}" dt="2025-05-30T23:30:41.453" v="9704" actId="1076"/>
           <ac:cxnSpMkLst>
             <pc:docMk/>
             <pc:sldMk cId="2152317508" sldId="256"/>
@@ -1391,14 +1423,6 @@
           </ac:cxnSpMkLst>
         </pc:cxnChg>
         <pc:cxnChg chg="add mod">
-          <ac:chgData name="Li, Hanchen F" userId="3aee791e-6a2d-4da7-a77b-fbdf7bf15886" providerId="ADAL" clId="{CDC5B0EF-6BEB-4658-A9FF-CB66F6FA6C1E}" dt="2025-05-30T22:44:41.487" v="9137" actId="1076"/>
-          <ac:cxnSpMkLst>
-            <pc:docMk/>
-            <pc:sldMk cId="2152317508" sldId="256"/>
-            <ac:cxnSpMk id="170" creationId="{DD6DD07B-470A-D2AF-3CC6-4334B7C92FD7}"/>
-          </ac:cxnSpMkLst>
-        </pc:cxnChg>
-        <pc:cxnChg chg="add mod">
           <ac:chgData name="Li, Hanchen F" userId="3aee791e-6a2d-4da7-a77b-fbdf7bf15886" providerId="ADAL" clId="{CDC5B0EF-6BEB-4658-A9FF-CB66F6FA6C1E}" dt="2025-05-22T22:34:51.982" v="2519" actId="164"/>
           <ac:cxnSpMkLst>
             <pc:docMk/>
@@ -1447,7 +1471,7 @@
           </ac:cxnSpMkLst>
         </pc:cxnChg>
         <pc:cxnChg chg="add mod ord">
-          <ac:chgData name="Li, Hanchen F" userId="3aee791e-6a2d-4da7-a77b-fbdf7bf15886" providerId="ADAL" clId="{CDC5B0EF-6BEB-4658-A9FF-CB66F6FA6C1E}" dt="2025-05-30T22:46:18.171" v="9160" actId="1076"/>
+          <ac:chgData name="Li, Hanchen F" userId="3aee791e-6a2d-4da7-a77b-fbdf7bf15886" providerId="ADAL" clId="{CDC5B0EF-6BEB-4658-A9FF-CB66F6FA6C1E}" dt="2025-05-30T23:30:17.983" v="9695" actId="1076"/>
           <ac:cxnSpMkLst>
             <pc:docMk/>
             <pc:sldMk cId="2152317508" sldId="256"/>
@@ -1494,14 +1518,6 @@
             <ac:cxnSpMk id="229" creationId="{C103E752-214C-7665-E5F1-11F50DE47006}"/>
           </ac:cxnSpMkLst>
         </pc:cxnChg>
-        <pc:cxnChg chg="add del mod">
-          <ac:chgData name="Li, Hanchen F" userId="3aee791e-6a2d-4da7-a77b-fbdf7bf15886" providerId="ADAL" clId="{CDC5B0EF-6BEB-4658-A9FF-CB66F6FA6C1E}" dt="2025-05-30T23:12:12.430" v="9273" actId="478"/>
-          <ac:cxnSpMkLst>
-            <pc:docMk/>
-            <pc:sldMk cId="2152317508" sldId="256"/>
-            <ac:cxnSpMk id="230" creationId="{FF7C58E2-8271-6514-4188-11F6201F333C}"/>
-          </ac:cxnSpMkLst>
-        </pc:cxnChg>
         <pc:cxnChg chg="add mod">
           <ac:chgData name="Li, Hanchen F" userId="3aee791e-6a2d-4da7-a77b-fbdf7bf15886" providerId="ADAL" clId="{CDC5B0EF-6BEB-4658-A9FF-CB66F6FA6C1E}" dt="2025-05-22T22:27:01.095" v="2133" actId="1037"/>
           <ac:cxnSpMkLst>
@@ -1631,7 +1647,7 @@
           </ac:cxnSpMkLst>
         </pc:cxnChg>
         <pc:cxnChg chg="add mod ord">
-          <ac:chgData name="Li, Hanchen F" userId="3aee791e-6a2d-4da7-a77b-fbdf7bf15886" providerId="ADAL" clId="{CDC5B0EF-6BEB-4658-A9FF-CB66F6FA6C1E}" dt="2025-05-23T16:54:39.979" v="7719" actId="1076"/>
+          <ac:chgData name="Li, Hanchen F" userId="3aee791e-6a2d-4da7-a77b-fbdf7bf15886" providerId="ADAL" clId="{CDC5B0EF-6BEB-4658-A9FF-CB66F6FA6C1E}" dt="2025-05-30T23:27:54.734" v="9633" actId="1036"/>
           <ac:cxnSpMkLst>
             <pc:docMk/>
             <pc:sldMk cId="2152317508" sldId="256"/>
@@ -1639,7 +1655,7 @@
           </ac:cxnSpMkLst>
         </pc:cxnChg>
         <pc:cxnChg chg="add mod ord">
-          <ac:chgData name="Li, Hanchen F" userId="3aee791e-6a2d-4da7-a77b-fbdf7bf15886" providerId="ADAL" clId="{CDC5B0EF-6BEB-4658-A9FF-CB66F6FA6C1E}" dt="2025-05-23T16:54:39.979" v="7719" actId="1076"/>
+          <ac:chgData name="Li, Hanchen F" userId="3aee791e-6a2d-4da7-a77b-fbdf7bf15886" providerId="ADAL" clId="{CDC5B0EF-6BEB-4658-A9FF-CB66F6FA6C1E}" dt="2025-05-30T23:27:54.734" v="9633" actId="1036"/>
           <ac:cxnSpMkLst>
             <pc:docMk/>
             <pc:sldMk cId="2152317508" sldId="256"/>
@@ -2764,7 +2780,7 @@
         </pc:cxnChg>
       </pc:sldChg>
       <pc:sldChg chg="addSp delSp modSp add mod">
-        <pc:chgData name="Li, Hanchen F" userId="3aee791e-6a2d-4da7-a77b-fbdf7bf15886" providerId="ADAL" clId="{CDC5B0EF-6BEB-4658-A9FF-CB66F6FA6C1E}" dt="2025-05-26T23:57:00.737" v="8871" actId="20577"/>
+        <pc:chgData name="Li, Hanchen F" userId="3aee791e-6a2d-4da7-a77b-fbdf7bf15886" providerId="ADAL" clId="{CDC5B0EF-6BEB-4658-A9FF-CB66F6FA6C1E}" dt="2025-06-02T22:09:19.571" v="9897" actId="114"/>
         <pc:sldMkLst>
           <pc:docMk/>
           <pc:sldMk cId="1584463432" sldId="260"/>
@@ -2777,6 +2793,14 @@
             <ac:spMk id="2" creationId="{AAF2876B-BAD6-F898-5EFF-FA8340A43036}"/>
           </ac:spMkLst>
         </pc:spChg>
+        <pc:spChg chg="add del">
+          <ac:chgData name="Li, Hanchen F" userId="3aee791e-6a2d-4da7-a77b-fbdf7bf15886" providerId="ADAL" clId="{CDC5B0EF-6BEB-4658-A9FF-CB66F6FA6C1E}" dt="2025-06-02T22:08:45.728" v="9893" actId="22"/>
+          <ac:spMkLst>
+            <pc:docMk/>
+            <pc:sldMk cId="1584463432" sldId="260"/>
+            <ac:spMk id="4" creationId="{6476E9A5-09DD-C3D1-4156-04EAE3539BD6}"/>
+          </ac:spMkLst>
+        </pc:spChg>
         <pc:spChg chg="add mod">
           <ac:chgData name="Li, Hanchen F" userId="3aee791e-6a2d-4da7-a77b-fbdf7bf15886" providerId="ADAL" clId="{CDC5B0EF-6BEB-4658-A9FF-CB66F6FA6C1E}" dt="2025-05-26T23:54:59.802" v="8837" actId="948"/>
           <ac:spMkLst>
@@ -2794,7 +2818,7 @@
           </ac:spMkLst>
         </pc:spChg>
         <pc:spChg chg="add mod">
-          <ac:chgData name="Li, Hanchen F" userId="3aee791e-6a2d-4da7-a77b-fbdf7bf15886" providerId="ADAL" clId="{CDC5B0EF-6BEB-4658-A9FF-CB66F6FA6C1E}" dt="2025-05-23T20:12:59.891" v="8141" actId="1038"/>
+          <ac:chgData name="Li, Hanchen F" userId="3aee791e-6a2d-4da7-a77b-fbdf7bf15886" providerId="ADAL" clId="{CDC5B0EF-6BEB-4658-A9FF-CB66F6FA6C1E}" dt="2025-06-02T22:05:05.792" v="9868" actId="20577"/>
           <ac:spMkLst>
             <pc:docMk/>
             <pc:sldMk cId="1584463432" sldId="260"/>
@@ -2802,7 +2826,7 @@
           </ac:spMkLst>
         </pc:spChg>
         <pc:spChg chg="add mod">
-          <ac:chgData name="Li, Hanchen F" userId="3aee791e-6a2d-4da7-a77b-fbdf7bf15886" providerId="ADAL" clId="{CDC5B0EF-6BEB-4658-A9FF-CB66F6FA6C1E}" dt="2025-05-26T23:55:55.225" v="8852" actId="948"/>
+          <ac:chgData name="Li, Hanchen F" userId="3aee791e-6a2d-4da7-a77b-fbdf7bf15886" providerId="ADAL" clId="{CDC5B0EF-6BEB-4658-A9FF-CB66F6FA6C1E}" dt="2025-06-02T22:09:19.571" v="9897" actId="114"/>
           <ac:spMkLst>
             <pc:docMk/>
             <pc:sldMk cId="1584463432" sldId="260"/>
@@ -2810,7 +2834,7 @@
           </ac:spMkLst>
         </pc:spChg>
         <pc:spChg chg="add mod">
-          <ac:chgData name="Li, Hanchen F" userId="3aee791e-6a2d-4da7-a77b-fbdf7bf15886" providerId="ADAL" clId="{CDC5B0EF-6BEB-4658-A9FF-CB66F6FA6C1E}" dt="2025-05-26T23:57:00.737" v="8871" actId="20577"/>
+          <ac:chgData name="Li, Hanchen F" userId="3aee791e-6a2d-4da7-a77b-fbdf7bf15886" providerId="ADAL" clId="{CDC5B0EF-6BEB-4658-A9FF-CB66F6FA6C1E}" dt="2025-06-02T22:09:12.305" v="9895" actId="114"/>
           <ac:spMkLst>
             <pc:docMk/>
             <pc:sldMk cId="1584463432" sldId="260"/>
@@ -2818,7 +2842,7 @@
           </ac:spMkLst>
         </pc:spChg>
         <pc:spChg chg="add mod">
-          <ac:chgData name="Li, Hanchen F" userId="3aee791e-6a2d-4da7-a77b-fbdf7bf15886" providerId="ADAL" clId="{CDC5B0EF-6BEB-4658-A9FF-CB66F6FA6C1E}" dt="2025-05-23T22:14:33.522" v="8186" actId="20577"/>
+          <ac:chgData name="Li, Hanchen F" userId="3aee791e-6a2d-4da7-a77b-fbdf7bf15886" providerId="ADAL" clId="{CDC5B0EF-6BEB-4658-A9FF-CB66F6FA6C1E}" dt="2025-06-02T22:06:13.077" v="9891" actId="1076"/>
           <ac:spMkLst>
             <pc:docMk/>
             <pc:sldMk cId="1584463432" sldId="260"/>
@@ -2834,7 +2858,7 @@
           </ac:spMkLst>
         </pc:spChg>
         <pc:spChg chg="add mod">
-          <ac:chgData name="Li, Hanchen F" userId="3aee791e-6a2d-4da7-a77b-fbdf7bf15886" providerId="ADAL" clId="{CDC5B0EF-6BEB-4658-A9FF-CB66F6FA6C1E}" dt="2025-05-23T20:12:59.891" v="8141" actId="1038"/>
+          <ac:chgData name="Li, Hanchen F" userId="3aee791e-6a2d-4da7-a77b-fbdf7bf15886" providerId="ADAL" clId="{CDC5B0EF-6BEB-4658-A9FF-CB66F6FA6C1E}" dt="2025-06-02T22:05:10.271" v="9870" actId="20577"/>
           <ac:spMkLst>
             <pc:docMk/>
             <pc:sldMk cId="1584463432" sldId="260"/>
@@ -3215,7 +3239,7 @@
           <a:p>
             <a:fld id="{DF1088C5-931A-42D2-8AA4-FA289862AAD0}" type="datetimeFigureOut">
               <a:rPr lang="zh-CN" altLang="en-US" smtClean="0"/>
-              <a:t>2025/5/31</a:t>
+              <a:t>2025/6/2</a:t>
             </a:fld>
             <a:endParaRPr lang="zh-CN" altLang="en-US"/>
           </a:p>
@@ -4105,7 +4129,7 @@
           <a:p>
             <a:fld id="{3CAF1464-0EA4-453D-A90B-03B04D244405}" type="datetimeFigureOut">
               <a:rPr lang="zh-CN" altLang="en-US" smtClean="0"/>
-              <a:t>2025/5/31</a:t>
+              <a:t>2025/6/2</a:t>
             </a:fld>
             <a:endParaRPr lang="zh-CN" altLang="en-US"/>
           </a:p>
@@ -4275,7 +4299,7 @@
           <a:p>
             <a:fld id="{3CAF1464-0EA4-453D-A90B-03B04D244405}" type="datetimeFigureOut">
               <a:rPr lang="zh-CN" altLang="en-US" smtClean="0"/>
-              <a:t>2025/5/31</a:t>
+              <a:t>2025/6/2</a:t>
             </a:fld>
             <a:endParaRPr lang="zh-CN" altLang="en-US"/>
           </a:p>
@@ -4455,7 +4479,7 @@
           <a:p>
             <a:fld id="{3CAF1464-0EA4-453D-A90B-03B04D244405}" type="datetimeFigureOut">
               <a:rPr lang="zh-CN" altLang="en-US" smtClean="0"/>
-              <a:t>2025/5/31</a:t>
+              <a:t>2025/6/2</a:t>
             </a:fld>
             <a:endParaRPr lang="zh-CN" altLang="en-US"/>
           </a:p>
@@ -4625,7 +4649,7 @@
           <a:p>
             <a:fld id="{3CAF1464-0EA4-453D-A90B-03B04D244405}" type="datetimeFigureOut">
               <a:rPr lang="zh-CN" altLang="en-US" smtClean="0"/>
-              <a:t>2025/5/31</a:t>
+              <a:t>2025/6/2</a:t>
             </a:fld>
             <a:endParaRPr lang="zh-CN" altLang="en-US"/>
           </a:p>
@@ -4871,7 +4895,7 @@
           <a:p>
             <a:fld id="{3CAF1464-0EA4-453D-A90B-03B04D244405}" type="datetimeFigureOut">
               <a:rPr lang="zh-CN" altLang="en-US" smtClean="0"/>
-              <a:t>2025/5/31</a:t>
+              <a:t>2025/6/2</a:t>
             </a:fld>
             <a:endParaRPr lang="zh-CN" altLang="en-US"/>
           </a:p>
@@ -5103,7 +5127,7 @@
           <a:p>
             <a:fld id="{3CAF1464-0EA4-453D-A90B-03B04D244405}" type="datetimeFigureOut">
               <a:rPr lang="zh-CN" altLang="en-US" smtClean="0"/>
-              <a:t>2025/5/31</a:t>
+              <a:t>2025/6/2</a:t>
             </a:fld>
             <a:endParaRPr lang="zh-CN" altLang="en-US"/>
           </a:p>
@@ -5470,7 +5494,7 @@
           <a:p>
             <a:fld id="{3CAF1464-0EA4-453D-A90B-03B04D244405}" type="datetimeFigureOut">
               <a:rPr lang="zh-CN" altLang="en-US" smtClean="0"/>
-              <a:t>2025/5/31</a:t>
+              <a:t>2025/6/2</a:t>
             </a:fld>
             <a:endParaRPr lang="zh-CN" altLang="en-US"/>
           </a:p>
@@ -5588,7 +5612,7 @@
           <a:p>
             <a:fld id="{3CAF1464-0EA4-453D-A90B-03B04D244405}" type="datetimeFigureOut">
               <a:rPr lang="zh-CN" altLang="en-US" smtClean="0"/>
-              <a:t>2025/5/31</a:t>
+              <a:t>2025/6/2</a:t>
             </a:fld>
             <a:endParaRPr lang="zh-CN" altLang="en-US"/>
           </a:p>
@@ -5683,7 +5707,7 @@
           <a:p>
             <a:fld id="{3CAF1464-0EA4-453D-A90B-03B04D244405}" type="datetimeFigureOut">
               <a:rPr lang="zh-CN" altLang="en-US" smtClean="0"/>
-              <a:t>2025/5/31</a:t>
+              <a:t>2025/6/2</a:t>
             </a:fld>
             <a:endParaRPr lang="zh-CN" altLang="en-US"/>
           </a:p>
@@ -5960,7 +5984,7 @@
           <a:p>
             <a:fld id="{3CAF1464-0EA4-453D-A90B-03B04D244405}" type="datetimeFigureOut">
               <a:rPr lang="zh-CN" altLang="en-US" smtClean="0"/>
-              <a:t>2025/5/31</a:t>
+              <a:t>2025/6/2</a:t>
             </a:fld>
             <a:endParaRPr lang="zh-CN" altLang="en-US"/>
           </a:p>
@@ -6217,7 +6241,7 @@
           <a:p>
             <a:fld id="{3CAF1464-0EA4-453D-A90B-03B04D244405}" type="datetimeFigureOut">
               <a:rPr lang="zh-CN" altLang="en-US" smtClean="0"/>
-              <a:t>2025/5/31</a:t>
+              <a:t>2025/6/2</a:t>
             </a:fld>
             <a:endParaRPr lang="zh-CN" altLang="en-US"/>
           </a:p>
@@ -6430,7 +6454,7 @@
           <a:p>
             <a:fld id="{3CAF1464-0EA4-453D-A90B-03B04D244405}" type="datetimeFigureOut">
               <a:rPr lang="zh-CN" altLang="en-US" smtClean="0"/>
-              <a:t>2025/5/31</a:t>
+              <a:t>2025/6/2</a:t>
             </a:fld>
             <a:endParaRPr lang="zh-CN" altLang="en-US"/>
           </a:p>
@@ -14141,8 +14165,8 @@
             </p:nvCxnSpPr>
             <p:spPr>
               <a:xfrm rot="21446795" flipV="1">
-                <a:off x="2277552" y="4672089"/>
-                <a:ext cx="3062097" cy="420382"/>
+                <a:off x="2277281" y="4659923"/>
+                <a:ext cx="3068447" cy="432413"/>
               </a:xfrm>
               <a:prstGeom prst="straightConnector1">
                 <a:avLst/>
@@ -14417,7 +14441,7 @@
             </p:nvCxnSpPr>
             <p:spPr>
               <a:xfrm rot="20957173" flipV="1">
-                <a:off x="6018039" y="3029448"/>
+                <a:off x="5953122" y="3042316"/>
                 <a:ext cx="0" cy="363536"/>
               </a:xfrm>
               <a:prstGeom prst="straightConnector1">
@@ -14582,50 +14606,6 @@
           </p:cxnSp>
           <p:cxnSp>
             <p:nvCxnSpPr>
-              <p:cNvPr id="170" name="直接连接符 169">
-                <a:extLst>
-                  <a:ext uri="{FF2B5EF4-FFF2-40B4-BE49-F238E27FC236}">
-                    <a16:creationId xmlns:a16="http://schemas.microsoft.com/office/drawing/2014/main" id="{DD6DD07B-470A-D2AF-3CC6-4334B7C92FD7}"/>
-                  </a:ext>
-                </a:extLst>
-              </p:cNvPr>
-              <p:cNvCxnSpPr>
-                <a:cxnSpLocks/>
-              </p:cNvCxnSpPr>
-              <p:nvPr/>
-            </p:nvCxnSpPr>
-            <p:spPr>
-              <a:xfrm rot="20957173">
-                <a:off x="5276236" y="3447203"/>
-                <a:ext cx="0" cy="1698132"/>
-              </a:xfrm>
-              <a:prstGeom prst="line">
-                <a:avLst/>
-              </a:prstGeom>
-              <a:ln w="12700">
-                <a:solidFill>
-                  <a:srgbClr val="0000CD"/>
-                </a:solidFill>
-                <a:prstDash val="solid"/>
-              </a:ln>
-            </p:spPr>
-            <p:style>
-              <a:lnRef idx="2">
-                <a:schemeClr val="accent1"/>
-              </a:lnRef>
-              <a:fillRef idx="0">
-                <a:schemeClr val="accent1"/>
-              </a:fillRef>
-              <a:effectRef idx="1">
-                <a:schemeClr val="accent1"/>
-              </a:effectRef>
-              <a:fontRef idx="minor">
-                <a:schemeClr val="tx1"/>
-              </a:fontRef>
-            </p:style>
-          </p:cxnSp>
-          <p:cxnSp>
-            <p:nvCxnSpPr>
               <p:cNvPr id="191" name="直接箭头连接符 190">
                 <a:extLst>
                   <a:ext uri="{FF2B5EF4-FFF2-40B4-BE49-F238E27FC236}">
@@ -14904,7 +14884,7 @@
             </p:nvCxnSpPr>
             <p:spPr>
               <a:xfrm rot="20957173" flipV="1">
-                <a:off x="5558179" y="3059017"/>
+                <a:off x="5554963" y="3059161"/>
                 <a:ext cx="563562" cy="1847"/>
               </a:xfrm>
               <a:prstGeom prst="straightConnector1">
@@ -15088,7 +15068,7 @@
         </p:nvSpPr>
         <p:spPr>
           <a:xfrm>
-            <a:off x="928131" y="4911380"/>
+            <a:off x="928131" y="4911382"/>
             <a:ext cx="124085" cy="124085"/>
           </a:xfrm>
           <a:prstGeom prst="flowChartSummingJunction">
@@ -15142,7 +15122,7 @@
         </p:nvCxnSpPr>
         <p:spPr>
           <a:xfrm flipH="1">
-            <a:off x="380225" y="4975269"/>
+            <a:off x="380225" y="4975271"/>
             <a:ext cx="547906" cy="0"/>
           </a:xfrm>
           <a:prstGeom prst="straightConnector1">
@@ -15186,7 +15166,7 @@
         </p:nvCxnSpPr>
         <p:spPr>
           <a:xfrm>
-            <a:off x="990173" y="5035465"/>
+            <a:off x="990173" y="5035467"/>
             <a:ext cx="0" cy="542901"/>
           </a:xfrm>
           <a:prstGeom prst="straightConnector1">
@@ -15228,7 +15208,7 @@
         </p:nvGrpSpPr>
         <p:grpSpPr>
           <a:xfrm rot="153205">
-            <a:off x="372029" y="4902691"/>
+            <a:off x="372029" y="4902693"/>
             <a:ext cx="665791" cy="661173"/>
             <a:chOff x="746098" y="5323114"/>
             <a:chExt cx="665791" cy="661173"/>
@@ -16987,7 +16967,7 @@
         </p:nvSpPr>
         <p:spPr>
           <a:xfrm>
-            <a:off x="157807" y="4968361"/>
+            <a:off x="157807" y="4968363"/>
             <a:ext cx="276038" cy="338554"/>
           </a:xfrm>
           <a:prstGeom prst="rect">
@@ -17035,7 +17015,7 @@
         </p:nvSpPr>
         <p:spPr>
           <a:xfrm>
-            <a:off x="1039324" y="4773304"/>
+            <a:off x="1032974" y="4773306"/>
             <a:ext cx="359394" cy="338554"/>
           </a:xfrm>
           <a:prstGeom prst="rect">
@@ -17084,7 +17064,7 @@
         </p:nvSpPr>
         <p:spPr>
           <a:xfrm>
-            <a:off x="694674" y="5444823"/>
+            <a:off x="694674" y="5444825"/>
             <a:ext cx="348172" cy="338554"/>
           </a:xfrm>
           <a:prstGeom prst="rect">
@@ -17133,7 +17113,7 @@
         </p:nvSpPr>
         <p:spPr>
           <a:xfrm>
-            <a:off x="1024272" y="5455894"/>
+            <a:off x="1027447" y="5446371"/>
             <a:ext cx="264816" cy="338554"/>
           </a:xfrm>
           <a:prstGeom prst="rect">
@@ -17181,7 +17161,7 @@
         </p:nvSpPr>
         <p:spPr>
           <a:xfrm>
-            <a:off x="852154" y="4553860"/>
+            <a:off x="852154" y="4541162"/>
             <a:ext cx="276038" cy="338554"/>
           </a:xfrm>
           <a:prstGeom prst="rect">
@@ -17229,7 +17209,7 @@
         </p:nvSpPr>
         <p:spPr>
           <a:xfrm>
-            <a:off x="51488" y="4696911"/>
+            <a:off x="51488" y="4703263"/>
             <a:ext cx="359394" cy="338554"/>
           </a:xfrm>
           <a:prstGeom prst="rect">
@@ -18156,7 +18136,7 @@
         </p:nvSpPr>
         <p:spPr>
           <a:xfrm>
-            <a:off x="1721182" y="363139"/>
+            <a:off x="1690702" y="525699"/>
             <a:ext cx="481222" cy="338554"/>
           </a:xfrm>
           <a:prstGeom prst="rect">
@@ -18570,7 +18550,7 @@
         </p:nvSpPr>
         <p:spPr>
           <a:xfrm>
-            <a:off x="6255916" y="3133787"/>
+            <a:off x="6187497" y="3146158"/>
             <a:ext cx="461986" cy="338554"/>
           </a:xfrm>
           <a:prstGeom prst="rect">
@@ -18882,7 +18862,7 @@
         </p:nvSpPr>
         <p:spPr>
           <a:xfrm>
-            <a:off x="5589130" y="2836295"/>
+            <a:off x="5606599" y="2836295"/>
             <a:ext cx="506870" cy="338554"/>
           </a:xfrm>
           <a:prstGeom prst="rect">
@@ -18940,7 +18920,7 @@
         </p:nvSpPr>
         <p:spPr>
           <a:xfrm>
-            <a:off x="6239746" y="2804651"/>
+            <a:off x="6158747" y="2786368"/>
             <a:ext cx="593432" cy="338554"/>
           </a:xfrm>
           <a:prstGeom prst="rect">
@@ -19237,7 +19217,7 @@
         </p:nvSpPr>
         <p:spPr>
           <a:xfrm>
-            <a:off x="9782678" y="5455894"/>
+            <a:off x="9782678" y="5434123"/>
             <a:ext cx="356188" cy="338554"/>
           </a:xfrm>
           <a:prstGeom prst="rect">
@@ -19285,7 +19265,7 @@
         </p:nvSpPr>
         <p:spPr>
           <a:xfrm>
-            <a:off x="9773570" y="418770"/>
+            <a:off x="9768179" y="525770"/>
             <a:ext cx="481222" cy="338554"/>
           </a:xfrm>
           <a:prstGeom prst="rect">
@@ -19343,7 +19323,7 @@
         </p:nvSpPr>
         <p:spPr>
           <a:xfrm>
-            <a:off x="9658881" y="1001547"/>
+            <a:off x="9679927" y="1032027"/>
             <a:ext cx="457176" cy="338554"/>
           </a:xfrm>
           <a:prstGeom prst="rect">
@@ -19661,7 +19641,7 @@
         </p:nvSpPr>
         <p:spPr>
           <a:xfrm>
-            <a:off x="9830890" y="3382582"/>
+            <a:off x="9866795" y="3270679"/>
             <a:ext cx="473206" cy="338554"/>
           </a:xfrm>
           <a:prstGeom prst="rect">
@@ -20751,7 +20731,7 @@
         </p:nvSpPr>
         <p:spPr>
           <a:xfrm>
-            <a:off x="10037442" y="3857956"/>
+            <a:off x="10019530" y="3862716"/>
             <a:ext cx="500458" cy="338554"/>
           </a:xfrm>
           <a:prstGeom prst="rect">
@@ -20908,6 +20888,248 @@
           </a:fontRef>
         </p:style>
       </p:cxnSp>
+      <p:cxnSp>
+        <p:nvCxnSpPr>
+          <p:cNvPr id="24" name="直接连接符 23">
+            <a:extLst>
+              <a:ext uri="{FF2B5EF4-FFF2-40B4-BE49-F238E27FC236}">
+                <a16:creationId xmlns:a16="http://schemas.microsoft.com/office/drawing/2014/main" id="{50858431-51A3-4B43-1052-473383F20DC3}"/>
+              </a:ext>
+            </a:extLst>
+          </p:cNvPr>
+          <p:cNvCxnSpPr>
+            <a:cxnSpLocks/>
+          </p:cNvCxnSpPr>
+          <p:nvPr/>
+        </p:nvCxnSpPr>
+        <p:spPr>
+          <a:xfrm>
+            <a:off x="5392092" y="3774113"/>
+            <a:ext cx="222889" cy="1516099"/>
+          </a:xfrm>
+          <a:prstGeom prst="line">
+            <a:avLst/>
+          </a:prstGeom>
+          <a:ln w="12700">
+            <a:solidFill>
+              <a:srgbClr val="0000CD"/>
+            </a:solidFill>
+            <a:prstDash val="solid"/>
+          </a:ln>
+        </p:spPr>
+        <p:style>
+          <a:lnRef idx="2">
+            <a:schemeClr val="accent1"/>
+          </a:lnRef>
+          <a:fillRef idx="0">
+            <a:schemeClr val="accent1"/>
+          </a:fillRef>
+          <a:effectRef idx="1">
+            <a:schemeClr val="accent1"/>
+          </a:effectRef>
+          <a:fontRef idx="minor">
+            <a:schemeClr val="tx1"/>
+          </a:fontRef>
+        </p:style>
+      </p:cxnSp>
+      <p:cxnSp>
+        <p:nvCxnSpPr>
+          <p:cNvPr id="19" name="直接箭头连接符 18">
+            <a:extLst>
+              <a:ext uri="{FF2B5EF4-FFF2-40B4-BE49-F238E27FC236}">
+                <a16:creationId xmlns:a16="http://schemas.microsoft.com/office/drawing/2014/main" id="{C35E9231-8CE7-8406-3F9A-0909C44D5A02}"/>
+              </a:ext>
+            </a:extLst>
+          </p:cNvPr>
+          <p:cNvCxnSpPr>
+            <a:cxnSpLocks/>
+          </p:cNvCxnSpPr>
+          <p:nvPr/>
+        </p:nvCxnSpPr>
+        <p:spPr>
+          <a:xfrm flipV="1">
+            <a:off x="2335026" y="3715989"/>
+            <a:ext cx="120712" cy="327787"/>
+          </a:xfrm>
+          <a:prstGeom prst="straightConnector1">
+            <a:avLst/>
+          </a:prstGeom>
+          <a:ln w="12700">
+            <a:solidFill>
+              <a:srgbClr val="DC143C"/>
+            </a:solidFill>
+            <a:tailEnd type="triangle"/>
+          </a:ln>
+        </p:spPr>
+        <p:style>
+          <a:lnRef idx="2">
+            <a:schemeClr val="accent1"/>
+          </a:lnRef>
+          <a:fillRef idx="0">
+            <a:schemeClr val="accent1"/>
+          </a:fillRef>
+          <a:effectRef idx="1">
+            <a:schemeClr val="accent1"/>
+          </a:effectRef>
+          <a:fontRef idx="minor">
+            <a:schemeClr val="tx1"/>
+          </a:fontRef>
+        </p:style>
+      </p:cxnSp>
+      <p:sp>
+        <p:nvSpPr>
+          <p:cNvPr id="25" name="文本框 24">
+            <a:extLst>
+              <a:ext uri="{FF2B5EF4-FFF2-40B4-BE49-F238E27FC236}">
+                <a16:creationId xmlns:a16="http://schemas.microsoft.com/office/drawing/2014/main" id="{1660E916-C2FE-42A2-C6D7-9DDF07E1CD2C}"/>
+              </a:ext>
+            </a:extLst>
+          </p:cNvPr>
+          <p:cNvSpPr txBox="1"/>
+          <p:nvPr/>
+        </p:nvSpPr>
+        <p:spPr>
+          <a:xfrm>
+            <a:off x="2350272" y="3410644"/>
+            <a:ext cx="298480" cy="338554"/>
+          </a:xfrm>
+          <a:prstGeom prst="rect">
+            <a:avLst/>
+          </a:prstGeom>
+          <a:noFill/>
+        </p:spPr>
+        <p:txBody>
+          <a:bodyPr wrap="none" rtlCol="0">
+            <a:spAutoFit/>
+          </a:bodyPr>
+          <a:lstStyle/>
+          <a:p>
+            <a:r>
+              <a:rPr lang="en-US" altLang="zh-CN" sz="1600" i="1" dirty="0">
+                <a:solidFill>
+                  <a:srgbClr val="DC143C"/>
+                </a:solidFill>
+                <a:latin typeface="Times New Roman" panose="02020603050405020304" pitchFamily="18" charset="0"/>
+                <a:cs typeface="Times New Roman" panose="02020603050405020304" pitchFamily="18" charset="0"/>
+              </a:rPr>
+              <a:t>L</a:t>
+            </a:r>
+            <a:endParaRPr lang="zh-CN" altLang="en-US" sz="1600" i="1" baseline="-25000" dirty="0">
+              <a:solidFill>
+                <a:srgbClr val="DC143C"/>
+              </a:solidFill>
+              <a:latin typeface="Times New Roman" panose="02020603050405020304" pitchFamily="18" charset="0"/>
+              <a:cs typeface="Times New Roman" panose="02020603050405020304" pitchFamily="18" charset="0"/>
+            </a:endParaRPr>
+          </a:p>
+        </p:txBody>
+      </p:sp>
+      <p:cxnSp>
+        <p:nvCxnSpPr>
+          <p:cNvPr id="26" name="直接箭头连接符 25">
+            <a:extLst>
+              <a:ext uri="{FF2B5EF4-FFF2-40B4-BE49-F238E27FC236}">
+                <a16:creationId xmlns:a16="http://schemas.microsoft.com/office/drawing/2014/main" id="{A2CBE254-54EC-7669-4148-C0F37BB5CA61}"/>
+              </a:ext>
+            </a:extLst>
+          </p:cNvPr>
+          <p:cNvCxnSpPr>
+            <a:cxnSpLocks/>
+          </p:cNvCxnSpPr>
+          <p:nvPr/>
+        </p:nvCxnSpPr>
+        <p:spPr>
+          <a:xfrm flipV="1">
+            <a:off x="9989669" y="3791214"/>
+            <a:ext cx="92563" cy="319395"/>
+          </a:xfrm>
+          <a:prstGeom prst="straightConnector1">
+            <a:avLst/>
+          </a:prstGeom>
+          <a:ln w="12700">
+            <a:solidFill>
+              <a:srgbClr val="DC143C"/>
+            </a:solidFill>
+            <a:tailEnd type="triangle"/>
+          </a:ln>
+        </p:spPr>
+        <p:style>
+          <a:lnRef idx="2">
+            <a:schemeClr val="accent1"/>
+          </a:lnRef>
+          <a:fillRef idx="0">
+            <a:schemeClr val="accent1"/>
+          </a:fillRef>
+          <a:effectRef idx="1">
+            <a:schemeClr val="accent1"/>
+          </a:effectRef>
+          <a:fontRef idx="minor">
+            <a:schemeClr val="tx1"/>
+          </a:fontRef>
+        </p:style>
+      </p:cxnSp>
+      <p:sp>
+        <p:nvSpPr>
+          <p:cNvPr id="29" name="文本框 28">
+            <a:extLst>
+              <a:ext uri="{FF2B5EF4-FFF2-40B4-BE49-F238E27FC236}">
+                <a16:creationId xmlns:a16="http://schemas.microsoft.com/office/drawing/2014/main" id="{054E6DA5-FF54-1C95-99AC-1044B339546B}"/>
+              </a:ext>
+            </a:extLst>
+          </p:cNvPr>
+          <p:cNvSpPr txBox="1"/>
+          <p:nvPr/>
+        </p:nvSpPr>
+        <p:spPr>
+          <a:xfrm>
+            <a:off x="10053805" y="3593874"/>
+            <a:ext cx="298480" cy="338554"/>
+          </a:xfrm>
+          <a:prstGeom prst="rect">
+            <a:avLst/>
+          </a:prstGeom>
+          <a:gradFill>
+            <a:gsLst>
+              <a:gs pos="30000">
+                <a:schemeClr val="bg1"/>
+              </a:gs>
+              <a:gs pos="68000">
+                <a:schemeClr val="bg1">
+                  <a:alpha val="0"/>
+                </a:schemeClr>
+              </a:gs>
+            </a:gsLst>
+            <a:path path="circle">
+              <a:fillToRect l="50000" t="50000" r="50000" b="50000"/>
+            </a:path>
+          </a:gradFill>
+        </p:spPr>
+        <p:txBody>
+          <a:bodyPr wrap="none" rtlCol="0">
+            <a:spAutoFit/>
+          </a:bodyPr>
+          <a:lstStyle/>
+          <a:p>
+            <a:r>
+              <a:rPr lang="en-US" altLang="zh-CN" sz="1600" i="1" dirty="0">
+                <a:solidFill>
+                  <a:srgbClr val="DC143C"/>
+                </a:solidFill>
+                <a:latin typeface="Times New Roman" panose="02020603050405020304" pitchFamily="18" charset="0"/>
+                <a:cs typeface="Times New Roman" panose="02020603050405020304" pitchFamily="18" charset="0"/>
+              </a:rPr>
+              <a:t>L</a:t>
+            </a:r>
+            <a:endParaRPr lang="zh-CN" altLang="en-US" sz="1600" i="1" baseline="-25000" dirty="0">
+              <a:solidFill>
+                <a:srgbClr val="DC143C"/>
+              </a:solidFill>
+              <a:latin typeface="Times New Roman" panose="02020603050405020304" pitchFamily="18" charset="0"/>
+              <a:cs typeface="Times New Roman" panose="02020603050405020304" pitchFamily="18" charset="0"/>
+            </a:endParaRPr>
+          </a:p>
+        </p:txBody>
+      </p:sp>
     </p:spTree>
     <p:extLst>
       <p:ext uri="{BB962C8B-B14F-4D97-AF65-F5344CB8AC3E}">
@@ -24119,7 +24341,7 @@
                 <a:latin typeface="Times New Roman" panose="02020603050405020304" pitchFamily="18" charset="0"/>
                 <a:cs typeface="Times New Roman" panose="02020603050405020304" pitchFamily="18" charset="0"/>
               </a:rPr>
-              <a:t>Fuselage aerodynamic model</a:t>
+              <a:t>Fuselage aerodynamics model</a:t>
             </a:r>
             <a:endParaRPr lang="en-GB" sz="1400" noProof="0" dirty="0">
               <a:solidFill>
@@ -24145,10 +24367,10 @@
         </p:nvGrpSpPr>
         <p:grpSpPr>
           <a:xfrm>
-            <a:off x="3270296" y="2893430"/>
-            <a:ext cx="3507204" cy="1632542"/>
-            <a:chOff x="4372071" y="2005742"/>
-            <a:chExt cx="3453491" cy="1632542"/>
+            <a:off x="3270296" y="2905902"/>
+            <a:ext cx="3507204" cy="1620070"/>
+            <a:chOff x="4372071" y="2018214"/>
+            <a:chExt cx="3453491" cy="1620070"/>
           </a:xfrm>
         </p:grpSpPr>
         <p:sp>
@@ -24285,7 +24507,7 @@
           </p:nvSpPr>
           <p:spPr>
             <a:xfrm>
-              <a:off x="4504978" y="2323034"/>
+              <a:off x="4504977" y="2346778"/>
               <a:ext cx="3235524" cy="560250"/>
             </a:xfrm>
             <a:prstGeom prst="rect">
@@ -24346,7 +24568,7 @@
                 <a:t>x</a:t>
               </a:r>
               <a:r>
-                <a:rPr lang="en-US" altLang="zh-CN" sz="1600" b="1" i="1" baseline="-25000" dirty="0" err="1">
+                <a:rPr lang="en-US" altLang="zh-CN" sz="1600" b="1" baseline="-25000" dirty="0" err="1">
                   <a:solidFill>
                     <a:schemeClr val="tx1"/>
                   </a:solidFill>
@@ -24748,7 +24970,7 @@
                 <a:t>x</a:t>
               </a:r>
               <a:r>
-                <a:rPr lang="en-US" altLang="zh-CN" sz="1600" b="1" i="1" baseline="-25000" dirty="0">
+                <a:rPr lang="en-US" altLang="zh-CN" sz="1600" b="1" baseline="-25000" dirty="0">
                   <a:solidFill>
                     <a:schemeClr val="tx1"/>
                   </a:solidFill>
@@ -25089,8 +25311,8 @@
           </p:nvSpPr>
           <p:spPr>
             <a:xfrm>
-              <a:off x="4764589" y="2005742"/>
-              <a:ext cx="2716300" cy="355832"/>
+              <a:off x="4564123" y="2018214"/>
+              <a:ext cx="3060971" cy="355832"/>
             </a:xfrm>
             <a:prstGeom prst="rect">
               <a:avLst/>
@@ -25139,7 +25361,7 @@
                   <a:latin typeface="Times New Roman" panose="02020603050405020304" pitchFamily="18" charset="0"/>
                   <a:cs typeface="Times New Roman" panose="02020603050405020304" pitchFamily="18" charset="0"/>
                 </a:rPr>
-                <a:t>Rotor aerodynamic model</a:t>
+                <a:t>Rotor aerodynamics &amp; dynamics model</a:t>
               </a:r>
               <a:endParaRPr lang="en-US" sz="1400" dirty="0">
                 <a:solidFill>
@@ -25290,7 +25512,7 @@
                 <a:latin typeface="Times New Roman" panose="02020603050405020304" pitchFamily="18" charset="0"/>
                 <a:cs typeface="Times New Roman" panose="02020603050405020304" pitchFamily="18" charset="0"/>
               </a:rPr>
-              <a:t>Empennage aerodynamic model</a:t>
+              <a:t>Empennage aerodynamics model</a:t>
             </a:r>
             <a:endParaRPr lang="en-GB" altLang="zh-CN" sz="1400" noProof="0" dirty="0">
               <a:solidFill>

</xml_diff>

<commit_message>
Force & Moment Function v5.2
- Hopefully, this is the final version of the force-and-moment function
- After a week of debugging and rewriting, all 18 sub-functions are complete and can handle general flight conditions
- The verification code is in 3 folders (rotor aerodynamic, rotor dynamic and fuselage & empennage), you could verified them by input and run the live scripts inside folders
- Caution: the function will produce abnormal results for angles of attack above 20 degrees, because stall effects are not yet modelled (no boundary has been implemented, please take this into account in your calculations)
- More specific boundaries will be added later
</commit_message>
<xml_diff>
--- a/HER05/01 - Mathematical Modeling/Sketch/Forces and Moments Sketch.pptx
+++ b/HER05/01 - Mathematical Modeling/Sketch/Forces and Moments Sketch.pptx
@@ -132,12 +132,12 @@
   <pc:docChgLst>
     <pc:chgData name="Li, Hanchen F" userId="3aee791e-6a2d-4da7-a77b-fbdf7bf15886" providerId="ADAL" clId="{CDC5B0EF-6BEB-4658-A9FF-CB66F6FA6C1E}"/>
     <pc:docChg chg="undo redo custSel addSld delSld modSld modMainMaster modNotesMaster">
-      <pc:chgData name="Li, Hanchen F" userId="3aee791e-6a2d-4da7-a77b-fbdf7bf15886" providerId="ADAL" clId="{CDC5B0EF-6BEB-4658-A9FF-CB66F6FA6C1E}" dt="2025-06-02T22:09:19.571" v="9897" actId="114"/>
+      <pc:chgData name="Li, Hanchen F" userId="3aee791e-6a2d-4da7-a77b-fbdf7bf15886" providerId="ADAL" clId="{CDC5B0EF-6BEB-4658-A9FF-CB66F6FA6C1E}" dt="2025-06-06T21:31:38.610" v="10067" actId="1037"/>
       <pc:docMkLst>
         <pc:docMk/>
       </pc:docMkLst>
       <pc:sldChg chg="addSp delSp modSp new mod">
-        <pc:chgData name="Li, Hanchen F" userId="3aee791e-6a2d-4da7-a77b-fbdf7bf15886" providerId="ADAL" clId="{CDC5B0EF-6BEB-4658-A9FF-CB66F6FA6C1E}" dt="2025-06-02T21:23:35.009" v="9866" actId="478"/>
+        <pc:chgData name="Li, Hanchen F" userId="3aee791e-6a2d-4da7-a77b-fbdf7bf15886" providerId="ADAL" clId="{CDC5B0EF-6BEB-4658-A9FF-CB66F6FA6C1E}" dt="2025-06-06T21:31:38.610" v="10067" actId="1037"/>
         <pc:sldMkLst>
           <pc:docMk/>
           <pc:sldMk cId="2152317508" sldId="256"/>
@@ -255,23 +255,15 @@
           </ac:spMkLst>
         </pc:spChg>
         <pc:spChg chg="add mod">
-          <ac:chgData name="Li, Hanchen F" userId="3aee791e-6a2d-4da7-a77b-fbdf7bf15886" providerId="ADAL" clId="{CDC5B0EF-6BEB-4658-A9FF-CB66F6FA6C1E}" dt="2025-06-02T21:23:05.460" v="9863" actId="1076"/>
+          <ac:chgData name="Li, Hanchen F" userId="3aee791e-6a2d-4da7-a77b-fbdf7bf15886" providerId="ADAL" clId="{CDC5B0EF-6BEB-4658-A9FF-CB66F6FA6C1E}" dt="2025-06-06T21:24:22.994" v="9900" actId="947"/>
           <ac:spMkLst>
             <pc:docMk/>
             <pc:sldMk cId="2152317508" sldId="256"/>
             <ac:spMk id="25" creationId="{1660E916-C2FE-42A2-C6D7-9DDF07E1CD2C}"/>
           </ac:spMkLst>
         </pc:spChg>
-        <pc:spChg chg="add del mod">
-          <ac:chgData name="Li, Hanchen F" userId="3aee791e-6a2d-4da7-a77b-fbdf7bf15886" providerId="ADAL" clId="{CDC5B0EF-6BEB-4658-A9FF-CB66F6FA6C1E}" dt="2025-06-02T21:21:58.886" v="9848" actId="478"/>
-          <ac:spMkLst>
-            <pc:docMk/>
-            <pc:sldMk cId="2152317508" sldId="256"/>
-            <ac:spMk id="28" creationId="{59778F99-9FE1-60A0-1734-8D3358AEDEEB}"/>
-          </ac:spMkLst>
-        </pc:spChg>
         <pc:spChg chg="add mod">
-          <ac:chgData name="Li, Hanchen F" userId="3aee791e-6a2d-4da7-a77b-fbdf7bf15886" providerId="ADAL" clId="{CDC5B0EF-6BEB-4658-A9FF-CB66F6FA6C1E}" dt="2025-06-02T21:22:22.882" v="9854" actId="1076"/>
+          <ac:chgData name="Li, Hanchen F" userId="3aee791e-6a2d-4da7-a77b-fbdf7bf15886" providerId="ADAL" clId="{CDC5B0EF-6BEB-4658-A9FF-CB66F6FA6C1E}" dt="2025-06-06T21:24:52.181" v="9905" actId="1076"/>
           <ac:spMkLst>
             <pc:docMk/>
             <pc:sldMk cId="2152317508" sldId="256"/>
@@ -286,14 +278,6 @@
             <ac:spMk id="30" creationId="{03E7375E-B3C1-217F-067E-365A732738CA}"/>
           </ac:spMkLst>
         </pc:spChg>
-        <pc:spChg chg="add del mod">
-          <ac:chgData name="Li, Hanchen F" userId="3aee791e-6a2d-4da7-a77b-fbdf7bf15886" providerId="ADAL" clId="{CDC5B0EF-6BEB-4658-A9FF-CB66F6FA6C1E}" dt="2025-06-02T21:23:35.009" v="9866" actId="478"/>
-          <ac:spMkLst>
-            <pc:docMk/>
-            <pc:sldMk cId="2152317508" sldId="256"/>
-            <ac:spMk id="33" creationId="{2CB2C986-2354-CB99-B566-34CF59B975CB}"/>
-          </ac:spMkLst>
-        </pc:spChg>
         <pc:spChg chg="add mod ord topLvl">
           <ac:chgData name="Li, Hanchen F" userId="3aee791e-6a2d-4da7-a77b-fbdf7bf15886" providerId="ADAL" clId="{CDC5B0EF-6BEB-4658-A9FF-CB66F6FA6C1E}" dt="2025-05-30T22:35:23.784" v="8872" actId="14826"/>
           <ac:spMkLst>
@@ -911,7 +895,7 @@
           </ac:spMkLst>
         </pc:spChg>
         <pc:spChg chg="add mod">
-          <ac:chgData name="Li, Hanchen F" userId="3aee791e-6a2d-4da7-a77b-fbdf7bf15886" providerId="ADAL" clId="{CDC5B0EF-6BEB-4658-A9FF-CB66F6FA6C1E}" dt="2025-05-22T23:34:17.088" v="3611" actId="1037"/>
+          <ac:chgData name="Li, Hanchen F" userId="3aee791e-6a2d-4da7-a77b-fbdf7bf15886" providerId="ADAL" clId="{CDC5B0EF-6BEB-4658-A9FF-CB66F6FA6C1E}" dt="2025-06-06T21:31:38.610" v="10067" actId="1037"/>
           <ac:spMkLst>
             <pc:docMk/>
             <pc:sldMk cId="2152317508" sldId="256"/>
@@ -1239,7 +1223,7 @@
           </ac:grpSpMkLst>
         </pc:grpChg>
         <pc:grpChg chg="add del mod ord">
-          <ac:chgData name="Li, Hanchen F" userId="3aee791e-6a2d-4da7-a77b-fbdf7bf15886" providerId="ADAL" clId="{CDC5B0EF-6BEB-4658-A9FF-CB66F6FA6C1E}" dt="2025-06-02T21:22:46.578" v="9859" actId="1076"/>
+          <ac:chgData name="Li, Hanchen F" userId="3aee791e-6a2d-4da7-a77b-fbdf7bf15886" providerId="ADAL" clId="{CDC5B0EF-6BEB-4658-A9FF-CB66F6FA6C1E}" dt="2025-06-06T21:31:20.624" v="10053" actId="1076"/>
           <ac:grpSpMkLst>
             <pc:docMk/>
             <pc:sldMk cId="2152317508" sldId="256"/>
@@ -1678,8 +1662,8 @@
             <ac:cxnSpMk id="304" creationId="{A6EE3A5B-5AE9-D053-02A8-3899EAD21351}"/>
           </ac:cxnSpMkLst>
         </pc:cxnChg>
-        <pc:cxnChg chg="add mod topLvl">
-          <ac:chgData name="Li, Hanchen F" userId="3aee791e-6a2d-4da7-a77b-fbdf7bf15886" providerId="ADAL" clId="{CDC5B0EF-6BEB-4658-A9FF-CB66F6FA6C1E}" dt="2025-05-22T22:43:53.687" v="2661" actId="1076"/>
+        <pc:cxnChg chg="add mod ord topLvl">
+          <ac:chgData name="Li, Hanchen F" userId="3aee791e-6a2d-4da7-a77b-fbdf7bf15886" providerId="ADAL" clId="{CDC5B0EF-6BEB-4658-A9FF-CB66F6FA6C1E}" dt="2025-06-06T21:31:28.548" v="10056" actId="166"/>
           <ac:cxnSpMkLst>
             <pc:docMk/>
             <pc:sldMk cId="2152317508" sldId="256"/>
@@ -1744,7 +1728,7 @@
         </pc:cxnChg>
       </pc:sldChg>
       <pc:sldChg chg="addSp delSp modSp add mod">
-        <pc:chgData name="Li, Hanchen F" userId="3aee791e-6a2d-4da7-a77b-fbdf7bf15886" providerId="ADAL" clId="{CDC5B0EF-6BEB-4658-A9FF-CB66F6FA6C1E}" dt="2025-05-30T22:50:51.390" v="9267" actId="1076"/>
+        <pc:chgData name="Li, Hanchen F" userId="3aee791e-6a2d-4da7-a77b-fbdf7bf15886" providerId="ADAL" clId="{CDC5B0EF-6BEB-4658-A9FF-CB66F6FA6C1E}" dt="2025-06-06T21:30:07.280" v="9907" actId="947"/>
         <pc:sldMkLst>
           <pc:docMk/>
           <pc:sldMk cId="3137520481" sldId="257"/>
@@ -1934,7 +1918,7 @@
           </ac:spMkLst>
         </pc:spChg>
         <pc:spChg chg="add mod">
-          <ac:chgData name="Li, Hanchen F" userId="3aee791e-6a2d-4da7-a77b-fbdf7bf15886" providerId="ADAL" clId="{CDC5B0EF-6BEB-4658-A9FF-CB66F6FA6C1E}" dt="2025-05-24T00:49:23.872" v="8680" actId="1076"/>
+          <ac:chgData name="Li, Hanchen F" userId="3aee791e-6a2d-4da7-a77b-fbdf7bf15886" providerId="ADAL" clId="{CDC5B0EF-6BEB-4658-A9FF-CB66F6FA6C1E}" dt="2025-06-06T21:30:07.280" v="9907" actId="947"/>
           <ac:spMkLst>
             <pc:docMk/>
             <pc:sldMk cId="3137520481" sldId="257"/>
@@ -2791,14 +2775,6 @@
             <pc:docMk/>
             <pc:sldMk cId="1584463432" sldId="260"/>
             <ac:spMk id="2" creationId="{AAF2876B-BAD6-F898-5EFF-FA8340A43036}"/>
-          </ac:spMkLst>
-        </pc:spChg>
-        <pc:spChg chg="add del">
-          <ac:chgData name="Li, Hanchen F" userId="3aee791e-6a2d-4da7-a77b-fbdf7bf15886" providerId="ADAL" clId="{CDC5B0EF-6BEB-4658-A9FF-CB66F6FA6C1E}" dt="2025-06-02T22:08:45.728" v="9893" actId="22"/>
-          <ac:spMkLst>
-            <pc:docMk/>
-            <pc:sldMk cId="1584463432" sldId="260"/>
-            <ac:spMk id="4" creationId="{6476E9A5-09DD-C3D1-4156-04EAE3539BD6}"/>
           </ac:spMkLst>
         </pc:spChg>
         <pc:spChg chg="add mod">
@@ -3239,7 +3215,7 @@
           <a:p>
             <a:fld id="{DF1088C5-931A-42D2-8AA4-FA289862AAD0}" type="datetimeFigureOut">
               <a:rPr lang="zh-CN" altLang="en-US" smtClean="0"/>
-              <a:t>2025/6/2</a:t>
+              <a:t>2025/6/6</a:t>
             </a:fld>
             <a:endParaRPr lang="zh-CN" altLang="en-US"/>
           </a:p>
@@ -4129,7 +4105,7 @@
           <a:p>
             <a:fld id="{3CAF1464-0EA4-453D-A90B-03B04D244405}" type="datetimeFigureOut">
               <a:rPr lang="zh-CN" altLang="en-US" smtClean="0"/>
-              <a:t>2025/6/2</a:t>
+              <a:t>2025/6/6</a:t>
             </a:fld>
             <a:endParaRPr lang="zh-CN" altLang="en-US"/>
           </a:p>
@@ -4299,7 +4275,7 @@
           <a:p>
             <a:fld id="{3CAF1464-0EA4-453D-A90B-03B04D244405}" type="datetimeFigureOut">
               <a:rPr lang="zh-CN" altLang="en-US" smtClean="0"/>
-              <a:t>2025/6/2</a:t>
+              <a:t>2025/6/6</a:t>
             </a:fld>
             <a:endParaRPr lang="zh-CN" altLang="en-US"/>
           </a:p>
@@ -4479,7 +4455,7 @@
           <a:p>
             <a:fld id="{3CAF1464-0EA4-453D-A90B-03B04D244405}" type="datetimeFigureOut">
               <a:rPr lang="zh-CN" altLang="en-US" smtClean="0"/>
-              <a:t>2025/6/2</a:t>
+              <a:t>2025/6/6</a:t>
             </a:fld>
             <a:endParaRPr lang="zh-CN" altLang="en-US"/>
           </a:p>
@@ -4649,7 +4625,7 @@
           <a:p>
             <a:fld id="{3CAF1464-0EA4-453D-A90B-03B04D244405}" type="datetimeFigureOut">
               <a:rPr lang="zh-CN" altLang="en-US" smtClean="0"/>
-              <a:t>2025/6/2</a:t>
+              <a:t>2025/6/6</a:t>
             </a:fld>
             <a:endParaRPr lang="zh-CN" altLang="en-US"/>
           </a:p>
@@ -4895,7 +4871,7 @@
           <a:p>
             <a:fld id="{3CAF1464-0EA4-453D-A90B-03B04D244405}" type="datetimeFigureOut">
               <a:rPr lang="zh-CN" altLang="en-US" smtClean="0"/>
-              <a:t>2025/6/2</a:t>
+              <a:t>2025/6/6</a:t>
             </a:fld>
             <a:endParaRPr lang="zh-CN" altLang="en-US"/>
           </a:p>
@@ -5127,7 +5103,7 @@
           <a:p>
             <a:fld id="{3CAF1464-0EA4-453D-A90B-03B04D244405}" type="datetimeFigureOut">
               <a:rPr lang="zh-CN" altLang="en-US" smtClean="0"/>
-              <a:t>2025/6/2</a:t>
+              <a:t>2025/6/6</a:t>
             </a:fld>
             <a:endParaRPr lang="zh-CN" altLang="en-US"/>
           </a:p>
@@ -5494,7 +5470,7 @@
           <a:p>
             <a:fld id="{3CAF1464-0EA4-453D-A90B-03B04D244405}" type="datetimeFigureOut">
               <a:rPr lang="zh-CN" altLang="en-US" smtClean="0"/>
-              <a:t>2025/6/2</a:t>
+              <a:t>2025/6/6</a:t>
             </a:fld>
             <a:endParaRPr lang="zh-CN" altLang="en-US"/>
           </a:p>
@@ -5612,7 +5588,7 @@
           <a:p>
             <a:fld id="{3CAF1464-0EA4-453D-A90B-03B04D244405}" type="datetimeFigureOut">
               <a:rPr lang="zh-CN" altLang="en-US" smtClean="0"/>
-              <a:t>2025/6/2</a:t>
+              <a:t>2025/6/6</a:t>
             </a:fld>
             <a:endParaRPr lang="zh-CN" altLang="en-US"/>
           </a:p>
@@ -5707,7 +5683,7 @@
           <a:p>
             <a:fld id="{3CAF1464-0EA4-453D-A90B-03B04D244405}" type="datetimeFigureOut">
               <a:rPr lang="zh-CN" altLang="en-US" smtClean="0"/>
-              <a:t>2025/6/2</a:t>
+              <a:t>2025/6/6</a:t>
             </a:fld>
             <a:endParaRPr lang="zh-CN" altLang="en-US"/>
           </a:p>
@@ -5984,7 +5960,7 @@
           <a:p>
             <a:fld id="{3CAF1464-0EA4-453D-A90B-03B04D244405}" type="datetimeFigureOut">
               <a:rPr lang="zh-CN" altLang="en-US" smtClean="0"/>
-              <a:t>2025/6/2</a:t>
+              <a:t>2025/6/6</a:t>
             </a:fld>
             <a:endParaRPr lang="zh-CN" altLang="en-US"/>
           </a:p>
@@ -6241,7 +6217,7 @@
           <a:p>
             <a:fld id="{3CAF1464-0EA4-453D-A90B-03B04D244405}" type="datetimeFigureOut">
               <a:rPr lang="zh-CN" altLang="en-US" smtClean="0"/>
-              <a:t>2025/6/2</a:t>
+              <a:t>2025/6/6</a:t>
             </a:fld>
             <a:endParaRPr lang="zh-CN" altLang="en-US"/>
           </a:p>
@@ -6454,7 +6430,7 @@
           <a:p>
             <a:fld id="{3CAF1464-0EA4-453D-A90B-03B04D244405}" type="datetimeFigureOut">
               <a:rPr lang="zh-CN" altLang="en-US" smtClean="0"/>
-              <a:t>2025/6/2</a:t>
+              <a:t>2025/6/6</a:t>
             </a:fld>
             <a:endParaRPr lang="zh-CN" altLang="en-US"/>
           </a:p>
@@ -16691,50 +16667,6 @@
       </p:grpSp>
       <p:cxnSp>
         <p:nvCxnSpPr>
-          <p:cNvPr id="463" name="直接箭头连接符 462">
-            <a:extLst>
-              <a:ext uri="{FF2B5EF4-FFF2-40B4-BE49-F238E27FC236}">
-                <a16:creationId xmlns:a16="http://schemas.microsoft.com/office/drawing/2014/main" id="{10451E52-E204-D840-CB8B-B13B2966A110}"/>
-              </a:ext>
-            </a:extLst>
-          </p:cNvPr>
-          <p:cNvCxnSpPr>
-            <a:cxnSpLocks/>
-          </p:cNvCxnSpPr>
-          <p:nvPr/>
-        </p:nvCxnSpPr>
-        <p:spPr>
-          <a:xfrm rot="1149310">
-            <a:off x="2346997" y="4217298"/>
-            <a:ext cx="459198" cy="0"/>
-          </a:xfrm>
-          <a:prstGeom prst="straightConnector1">
-            <a:avLst/>
-          </a:prstGeom>
-          <a:ln w="12700">
-            <a:solidFill>
-              <a:srgbClr val="DC143C"/>
-            </a:solidFill>
-            <a:tailEnd type="triangle"/>
-          </a:ln>
-        </p:spPr>
-        <p:style>
-          <a:lnRef idx="2">
-            <a:schemeClr val="accent1"/>
-          </a:lnRef>
-          <a:fillRef idx="0">
-            <a:schemeClr val="accent1"/>
-          </a:fillRef>
-          <a:effectRef idx="1">
-            <a:schemeClr val="accent1"/>
-          </a:effectRef>
-          <a:fontRef idx="minor">
-            <a:schemeClr val="tx1"/>
-          </a:fontRef>
-        </p:style>
-      </p:cxnSp>
-      <p:cxnSp>
-        <p:nvCxnSpPr>
           <p:cNvPr id="483" name="直接连接符 482">
             <a:extLst>
               <a:ext uri="{FF2B5EF4-FFF2-40B4-BE49-F238E27FC236}">
@@ -17597,16 +17529,31 @@
         </p:nvSpPr>
         <p:spPr>
           <a:xfrm>
-            <a:off x="2739311" y="4138053"/>
-            <a:ext cx="332142" cy="338554"/>
+            <a:off x="2739332" y="4112608"/>
+            <a:ext cx="415498" cy="338554"/>
           </a:xfrm>
           <a:prstGeom prst="rect">
             <a:avLst/>
           </a:prstGeom>
-          <a:noFill/>
-        </p:spPr>
-        <p:txBody>
-          <a:bodyPr wrap="none" rtlCol="0">
+          <a:gradFill flip="none" rotWithShape="1">
+            <a:gsLst>
+              <a:gs pos="40000">
+                <a:schemeClr val="bg1"/>
+              </a:gs>
+              <a:gs pos="100000">
+                <a:schemeClr val="bg1">
+                  <a:alpha val="0"/>
+                </a:schemeClr>
+              </a:gs>
+            </a:gsLst>
+            <a:path path="circle">
+              <a:fillToRect l="50000" t="50000" r="50000" b="50000"/>
+            </a:path>
+            <a:tileRect/>
+          </a:gradFill>
+        </p:spPr>
+        <p:txBody>
+          <a:bodyPr wrap="square" rtlCol="0">
             <a:spAutoFit/>
           </a:bodyPr>
           <a:lstStyle/>
@@ -17620,6 +17567,16 @@
                 <a:cs typeface="Times New Roman" panose="02020603050405020304" pitchFamily="18" charset="0"/>
               </a:rPr>
               <a:t>D</a:t>
+            </a:r>
+            <a:r>
+              <a:rPr lang="en-US" altLang="zh-CN" sz="1600" i="1" baseline="-25000" dirty="0">
+                <a:solidFill>
+                  <a:srgbClr val="DC143C"/>
+                </a:solidFill>
+                <a:latin typeface="Times New Roman" panose="02020603050405020304" pitchFamily="18" charset="0"/>
+                <a:cs typeface="Times New Roman" panose="02020603050405020304" pitchFamily="18" charset="0"/>
+              </a:rPr>
+              <a:t>F</a:t>
             </a:r>
             <a:endParaRPr lang="zh-CN" altLang="en-US" sz="1600" i="1" baseline="-25000" dirty="0">
               <a:solidFill>
@@ -20991,7 +20948,7 @@
         <p:spPr>
           <a:xfrm>
             <a:off x="2350272" y="3410644"/>
-            <a:ext cx="298480" cy="338554"/>
+            <a:ext cx="381836" cy="338554"/>
           </a:xfrm>
           <a:prstGeom prst="rect">
             <a:avLst/>
@@ -21013,6 +20970,16 @@
                 <a:cs typeface="Times New Roman" panose="02020603050405020304" pitchFamily="18" charset="0"/>
               </a:rPr>
               <a:t>L</a:t>
+            </a:r>
+            <a:r>
+              <a:rPr lang="en-US" altLang="zh-CN" sz="1600" i="1" baseline="-25000" dirty="0">
+                <a:solidFill>
+                  <a:srgbClr val="DC143C"/>
+                </a:solidFill>
+                <a:latin typeface="Times New Roman" panose="02020603050405020304" pitchFamily="18" charset="0"/>
+                <a:cs typeface="Times New Roman" panose="02020603050405020304" pitchFamily="18" charset="0"/>
+              </a:rPr>
+              <a:t>F</a:t>
             </a:r>
             <a:endParaRPr lang="zh-CN" altLang="en-US" sz="1600" i="1" baseline="-25000" dirty="0">
               <a:solidFill>
@@ -21082,8 +21049,8 @@
         </p:nvSpPr>
         <p:spPr>
           <a:xfrm>
-            <a:off x="10053805" y="3593874"/>
-            <a:ext cx="298480" cy="338554"/>
+            <a:off x="10061686" y="3562163"/>
+            <a:ext cx="381836" cy="338554"/>
           </a:xfrm>
           <a:prstGeom prst="rect">
             <a:avLst/>
@@ -21120,6 +21087,16 @@
               </a:rPr>
               <a:t>L</a:t>
             </a:r>
+            <a:r>
+              <a:rPr lang="en-US" altLang="zh-CN" sz="1600" i="1" baseline="-25000" dirty="0">
+                <a:solidFill>
+                  <a:srgbClr val="DC143C"/>
+                </a:solidFill>
+                <a:latin typeface="Times New Roman" panose="02020603050405020304" pitchFamily="18" charset="0"/>
+                <a:cs typeface="Times New Roman" panose="02020603050405020304" pitchFamily="18" charset="0"/>
+              </a:rPr>
+              <a:t>F</a:t>
+            </a:r>
             <a:endParaRPr lang="zh-CN" altLang="en-US" sz="1600" i="1" baseline="-25000" dirty="0">
               <a:solidFill>
                 <a:srgbClr val="DC143C"/>
@@ -21130,6 +21107,50 @@
           </a:p>
         </p:txBody>
       </p:sp>
+      <p:cxnSp>
+        <p:nvCxnSpPr>
+          <p:cNvPr id="463" name="直接箭头连接符 462">
+            <a:extLst>
+              <a:ext uri="{FF2B5EF4-FFF2-40B4-BE49-F238E27FC236}">
+                <a16:creationId xmlns:a16="http://schemas.microsoft.com/office/drawing/2014/main" id="{10451E52-E204-D840-CB8B-B13B2966A110}"/>
+              </a:ext>
+            </a:extLst>
+          </p:cNvPr>
+          <p:cNvCxnSpPr>
+            <a:cxnSpLocks/>
+          </p:cNvCxnSpPr>
+          <p:nvPr/>
+        </p:nvCxnSpPr>
+        <p:spPr>
+          <a:xfrm rot="1149310">
+            <a:off x="2346997" y="4217298"/>
+            <a:ext cx="459198" cy="0"/>
+          </a:xfrm>
+          <a:prstGeom prst="straightConnector1">
+            <a:avLst/>
+          </a:prstGeom>
+          <a:ln w="12700">
+            <a:solidFill>
+              <a:srgbClr val="DC143C"/>
+            </a:solidFill>
+            <a:tailEnd type="triangle"/>
+          </a:ln>
+        </p:spPr>
+        <p:style>
+          <a:lnRef idx="2">
+            <a:schemeClr val="accent1"/>
+          </a:lnRef>
+          <a:fillRef idx="0">
+            <a:schemeClr val="accent1"/>
+          </a:fillRef>
+          <a:effectRef idx="1">
+            <a:schemeClr val="accent1"/>
+          </a:effectRef>
+          <a:fontRef idx="minor">
+            <a:schemeClr val="tx1"/>
+          </a:fontRef>
+        </p:style>
+      </p:cxnSp>
     </p:spTree>
     <p:extLst>
       <p:ext uri="{BB962C8B-B14F-4D97-AF65-F5344CB8AC3E}">
@@ -23448,7 +23469,7 @@
         <p:spPr>
           <a:xfrm>
             <a:off x="4768784" y="3002497"/>
-            <a:ext cx="332142" cy="338554"/>
+            <a:ext cx="415498" cy="338554"/>
           </a:xfrm>
           <a:prstGeom prst="rect">
             <a:avLst/>
@@ -23470,6 +23491,16 @@
                 <a:cs typeface="Times New Roman" panose="02020603050405020304" pitchFamily="18" charset="0"/>
               </a:rPr>
               <a:t>D</a:t>
+            </a:r>
+            <a:r>
+              <a:rPr lang="en-US" altLang="zh-CN" sz="1600" i="1" baseline="-25000" dirty="0">
+                <a:solidFill>
+                  <a:srgbClr val="DC143C"/>
+                </a:solidFill>
+                <a:latin typeface="Times New Roman" panose="02020603050405020304" pitchFamily="18" charset="0"/>
+                <a:cs typeface="Times New Roman" panose="02020603050405020304" pitchFamily="18" charset="0"/>
+              </a:rPr>
+              <a:t>F</a:t>
             </a:r>
             <a:endParaRPr lang="zh-CN" altLang="en-US" sz="1600" i="1" baseline="-25000" dirty="0">
               <a:solidFill>

</xml_diff>

<commit_message>
Force & Moment Function v5.3
- Small updates
</commit_message>
<xml_diff>
--- a/HER05/01 - Mathematical Modeling/Sketch/Forces and Moments Sketch.pptx
+++ b/HER05/01 - Mathematical Modeling/Sketch/Forces and Moments Sketch.pptx
@@ -122,7 +122,7 @@
 <file path=ppt/revisionInfo.xml><?xml version="1.0" encoding="utf-8"?>
 <p1510:revInfo xmlns:a="http://schemas.openxmlformats.org/drawingml/2006/main" xmlns:r="http://schemas.openxmlformats.org/officeDocument/2006/relationships" xmlns:p1510="http://schemas.microsoft.com/office/powerpoint/2015/10/main">
   <p1510:revLst>
-    <p1510:client id="{CDC5B0EF-6BEB-4658-A9FF-CB66F6FA6C1E}" v="433" dt="2025-06-02T21:21:55.276"/>
+    <p1510:client id="{CDC5B0EF-6BEB-4658-A9FF-CB66F6FA6C1E}" v="447" dt="2025-06-08T22:03:37.248"/>
   </p1510:revLst>
 </p1510:revInfo>
 </file>
@@ -132,7 +132,7 @@
   <pc:docChgLst>
     <pc:chgData name="Li, Hanchen F" userId="3aee791e-6a2d-4da7-a77b-fbdf7bf15886" providerId="ADAL" clId="{CDC5B0EF-6BEB-4658-A9FF-CB66F6FA6C1E}"/>
     <pc:docChg chg="undo redo custSel addSld delSld modSld modMainMaster modNotesMaster">
-      <pc:chgData name="Li, Hanchen F" userId="3aee791e-6a2d-4da7-a77b-fbdf7bf15886" providerId="ADAL" clId="{CDC5B0EF-6BEB-4658-A9FF-CB66F6FA6C1E}" dt="2025-06-06T21:31:38.610" v="10067" actId="1037"/>
+      <pc:chgData name="Li, Hanchen F" userId="3aee791e-6a2d-4da7-a77b-fbdf7bf15886" providerId="ADAL" clId="{CDC5B0EF-6BEB-4658-A9FF-CB66F6FA6C1E}" dt="2025-06-08T22:03:58.072" v="10257" actId="1076"/>
       <pc:docMkLst>
         <pc:docMk/>
       </pc:docMkLst>
@@ -2764,21 +2764,29 @@
         </pc:cxnChg>
       </pc:sldChg>
       <pc:sldChg chg="addSp delSp modSp add mod">
-        <pc:chgData name="Li, Hanchen F" userId="3aee791e-6a2d-4da7-a77b-fbdf7bf15886" providerId="ADAL" clId="{CDC5B0EF-6BEB-4658-A9FF-CB66F6FA6C1E}" dt="2025-06-02T22:09:19.571" v="9897" actId="114"/>
+        <pc:chgData name="Li, Hanchen F" userId="3aee791e-6a2d-4da7-a77b-fbdf7bf15886" providerId="ADAL" clId="{CDC5B0EF-6BEB-4658-A9FF-CB66F6FA6C1E}" dt="2025-06-08T22:03:58.072" v="10257" actId="1076"/>
         <pc:sldMkLst>
           <pc:docMk/>
           <pc:sldMk cId="1584463432" sldId="260"/>
         </pc:sldMkLst>
         <pc:spChg chg="add mod">
-          <ac:chgData name="Li, Hanchen F" userId="3aee791e-6a2d-4da7-a77b-fbdf7bf15886" providerId="ADAL" clId="{CDC5B0EF-6BEB-4658-A9FF-CB66F6FA6C1E}" dt="2025-05-23T22:14:27.977" v="8181" actId="403"/>
+          <ac:chgData name="Li, Hanchen F" userId="3aee791e-6a2d-4da7-a77b-fbdf7bf15886" providerId="ADAL" clId="{CDC5B0EF-6BEB-4658-A9FF-CB66F6FA6C1E}" dt="2025-06-08T22:03:51.338" v="10256" actId="1076"/>
           <ac:spMkLst>
             <pc:docMk/>
             <pc:sldMk cId="1584463432" sldId="260"/>
             <ac:spMk id="2" creationId="{AAF2876B-BAD6-F898-5EFF-FA8340A43036}"/>
           </ac:spMkLst>
         </pc:spChg>
+        <pc:spChg chg="add del mod">
+          <ac:chgData name="Li, Hanchen F" userId="3aee791e-6a2d-4da7-a77b-fbdf7bf15886" providerId="ADAL" clId="{CDC5B0EF-6BEB-4658-A9FF-CB66F6FA6C1E}" dt="2025-06-08T21:57:36.244" v="10146" actId="478"/>
+          <ac:spMkLst>
+            <pc:docMk/>
+            <pc:sldMk cId="1584463432" sldId="260"/>
+            <ac:spMk id="3" creationId="{1B937753-0BDE-F60D-339F-D81BBBE7EBAB}"/>
+          </ac:spMkLst>
+        </pc:spChg>
         <pc:spChg chg="add mod">
-          <ac:chgData name="Li, Hanchen F" userId="3aee791e-6a2d-4da7-a77b-fbdf7bf15886" providerId="ADAL" clId="{CDC5B0EF-6BEB-4658-A9FF-CB66F6FA6C1E}" dt="2025-05-26T23:54:59.802" v="8837" actId="948"/>
+          <ac:chgData name="Li, Hanchen F" userId="3aee791e-6a2d-4da7-a77b-fbdf7bf15886" providerId="ADAL" clId="{CDC5B0EF-6BEB-4658-A9FF-CB66F6FA6C1E}" dt="2025-06-08T22:03:58.072" v="10257" actId="1076"/>
           <ac:spMkLst>
             <pc:docMk/>
             <pc:sldMk cId="1584463432" sldId="260"/>
@@ -2802,6 +2810,30 @@
           </ac:spMkLst>
         </pc:spChg>
         <pc:spChg chg="add mod">
+          <ac:chgData name="Li, Hanchen F" userId="3aee791e-6a2d-4da7-a77b-fbdf7bf15886" providerId="ADAL" clId="{CDC5B0EF-6BEB-4658-A9FF-CB66F6FA6C1E}" dt="2025-06-08T21:57:13.214" v="10080" actId="571"/>
+          <ac:spMkLst>
+            <pc:docMk/>
+            <pc:sldMk cId="1584463432" sldId="260"/>
+            <ac:spMk id="16" creationId="{B141FC4A-9E16-2DA4-0B50-3B1EE6A7CECD}"/>
+          </ac:spMkLst>
+        </pc:spChg>
+        <pc:spChg chg="add mod">
+          <ac:chgData name="Li, Hanchen F" userId="3aee791e-6a2d-4da7-a77b-fbdf7bf15886" providerId="ADAL" clId="{CDC5B0EF-6BEB-4658-A9FF-CB66F6FA6C1E}" dt="2025-06-08T21:57:22.284" v="10086" actId="571"/>
+          <ac:spMkLst>
+            <pc:docMk/>
+            <pc:sldMk cId="1584463432" sldId="260"/>
+            <ac:spMk id="21" creationId="{9AF54E53-9E8F-D545-98F3-EE0AB3A980B5}"/>
+          </ac:spMkLst>
+        </pc:spChg>
+        <pc:spChg chg="add mod">
+          <ac:chgData name="Li, Hanchen F" userId="3aee791e-6a2d-4da7-a77b-fbdf7bf15886" providerId="ADAL" clId="{CDC5B0EF-6BEB-4658-A9FF-CB66F6FA6C1E}" dt="2025-06-08T22:03:41.721" v="10255" actId="20577"/>
+          <ac:spMkLst>
+            <pc:docMk/>
+            <pc:sldMk cId="1584463432" sldId="260"/>
+            <ac:spMk id="25" creationId="{2692B16A-D6BB-9683-C102-1C280F04577D}"/>
+          </ac:spMkLst>
+        </pc:spChg>
+        <pc:spChg chg="add mod">
           <ac:chgData name="Li, Hanchen F" userId="3aee791e-6a2d-4da7-a77b-fbdf7bf15886" providerId="ADAL" clId="{CDC5B0EF-6BEB-4658-A9FF-CB66F6FA6C1E}" dt="2025-06-02T22:09:19.571" v="9897" actId="114"/>
           <ac:spMkLst>
             <pc:docMk/>
@@ -2914,6 +2946,14 @@
           </ac:grpSpMkLst>
         </pc:grpChg>
         <pc:cxnChg chg="add mod">
+          <ac:chgData name="Li, Hanchen F" userId="3aee791e-6a2d-4da7-a77b-fbdf7bf15886" providerId="ADAL" clId="{CDC5B0EF-6BEB-4658-A9FF-CB66F6FA6C1E}" dt="2025-06-08T21:59:53.482" v="10245" actId="14100"/>
+          <ac:cxnSpMkLst>
+            <pc:docMk/>
+            <pc:sldMk cId="1584463432" sldId="260"/>
+            <ac:cxnSpMk id="26" creationId="{9851B9C7-BFB3-04FB-8FA2-EAB5DE072A63}"/>
+          </ac:cxnSpMkLst>
+        </pc:cxnChg>
+        <pc:cxnChg chg="add mod">
           <ac:chgData name="Li, Hanchen F" userId="3aee791e-6a2d-4da7-a77b-fbdf7bf15886" providerId="ADAL" clId="{CDC5B0EF-6BEB-4658-A9FF-CB66F6FA6C1E}" dt="2025-05-23T20:12:59.891" v="8141" actId="1038"/>
           <ac:cxnSpMkLst>
             <pc:docMk/>
@@ -2922,7 +2962,7 @@
           </ac:cxnSpMkLst>
         </pc:cxnChg>
         <pc:cxnChg chg="add mod">
-          <ac:chgData name="Li, Hanchen F" userId="3aee791e-6a2d-4da7-a77b-fbdf7bf15886" providerId="ADAL" clId="{CDC5B0EF-6BEB-4658-A9FF-CB66F6FA6C1E}" dt="2025-05-23T20:12:59.891" v="8141" actId="1038"/>
+          <ac:chgData name="Li, Hanchen F" userId="3aee791e-6a2d-4da7-a77b-fbdf7bf15886" providerId="ADAL" clId="{CDC5B0EF-6BEB-4658-A9FF-CB66F6FA6C1E}" dt="2025-06-08T22:03:58.072" v="10257" actId="1076"/>
           <ac:cxnSpMkLst>
             <pc:docMk/>
             <pc:sldMk cId="1584463432" sldId="260"/>
@@ -2930,7 +2970,7 @@
           </ac:cxnSpMkLst>
         </pc:cxnChg>
         <pc:cxnChg chg="add mod">
-          <ac:chgData name="Li, Hanchen F" userId="3aee791e-6a2d-4da7-a77b-fbdf7bf15886" providerId="ADAL" clId="{CDC5B0EF-6BEB-4658-A9FF-CB66F6FA6C1E}" dt="2025-05-23T20:12:59.891" v="8141" actId="1038"/>
+          <ac:chgData name="Li, Hanchen F" userId="3aee791e-6a2d-4da7-a77b-fbdf7bf15886" providerId="ADAL" clId="{CDC5B0EF-6BEB-4658-A9FF-CB66F6FA6C1E}" dt="2025-06-08T22:03:51.338" v="10256" actId="1076"/>
           <ac:cxnSpMkLst>
             <pc:docMk/>
             <pc:sldMk cId="1584463432" sldId="260"/>
@@ -2938,7 +2978,7 @@
           </ac:cxnSpMkLst>
         </pc:cxnChg>
         <pc:cxnChg chg="add mod">
-          <ac:chgData name="Li, Hanchen F" userId="3aee791e-6a2d-4da7-a77b-fbdf7bf15886" providerId="ADAL" clId="{CDC5B0EF-6BEB-4658-A9FF-CB66F6FA6C1E}" dt="2025-05-23T20:12:59.891" v="8141" actId="1038"/>
+          <ac:chgData name="Li, Hanchen F" userId="3aee791e-6a2d-4da7-a77b-fbdf7bf15886" providerId="ADAL" clId="{CDC5B0EF-6BEB-4658-A9FF-CB66F6FA6C1E}" dt="2025-06-08T22:03:58.072" v="10257" actId="1076"/>
           <ac:cxnSpMkLst>
             <pc:docMk/>
             <pc:sldMk cId="1584463432" sldId="260"/>
@@ -2946,7 +2986,7 @@
           </ac:cxnSpMkLst>
         </pc:cxnChg>
         <pc:cxnChg chg="add mod">
-          <ac:chgData name="Li, Hanchen F" userId="3aee791e-6a2d-4da7-a77b-fbdf7bf15886" providerId="ADAL" clId="{CDC5B0EF-6BEB-4658-A9FF-CB66F6FA6C1E}" dt="2025-05-23T20:12:59.891" v="8141" actId="1038"/>
+          <ac:chgData name="Li, Hanchen F" userId="3aee791e-6a2d-4da7-a77b-fbdf7bf15886" providerId="ADAL" clId="{CDC5B0EF-6BEB-4658-A9FF-CB66F6FA6C1E}" dt="2025-06-08T22:03:58.072" v="10257" actId="1076"/>
           <ac:cxnSpMkLst>
             <pc:docMk/>
             <pc:sldMk cId="1584463432" sldId="260"/>
@@ -3215,7 +3255,7 @@
           <a:p>
             <a:fld id="{DF1088C5-931A-42D2-8AA4-FA289862AAD0}" type="datetimeFigureOut">
               <a:rPr lang="zh-CN" altLang="en-US" smtClean="0"/>
-              <a:t>2025/6/6</a:t>
+              <a:t>2025/6/8</a:t>
             </a:fld>
             <a:endParaRPr lang="zh-CN" altLang="en-US"/>
           </a:p>
@@ -4105,7 +4145,7 @@
           <a:p>
             <a:fld id="{3CAF1464-0EA4-453D-A90B-03B04D244405}" type="datetimeFigureOut">
               <a:rPr lang="zh-CN" altLang="en-US" smtClean="0"/>
-              <a:t>2025/6/6</a:t>
+              <a:t>2025/6/8</a:t>
             </a:fld>
             <a:endParaRPr lang="zh-CN" altLang="en-US"/>
           </a:p>
@@ -4275,7 +4315,7 @@
           <a:p>
             <a:fld id="{3CAF1464-0EA4-453D-A90B-03B04D244405}" type="datetimeFigureOut">
               <a:rPr lang="zh-CN" altLang="en-US" smtClean="0"/>
-              <a:t>2025/6/6</a:t>
+              <a:t>2025/6/8</a:t>
             </a:fld>
             <a:endParaRPr lang="zh-CN" altLang="en-US"/>
           </a:p>
@@ -4455,7 +4495,7 @@
           <a:p>
             <a:fld id="{3CAF1464-0EA4-453D-A90B-03B04D244405}" type="datetimeFigureOut">
               <a:rPr lang="zh-CN" altLang="en-US" smtClean="0"/>
-              <a:t>2025/6/6</a:t>
+              <a:t>2025/6/8</a:t>
             </a:fld>
             <a:endParaRPr lang="zh-CN" altLang="en-US"/>
           </a:p>
@@ -4625,7 +4665,7 @@
           <a:p>
             <a:fld id="{3CAF1464-0EA4-453D-A90B-03B04D244405}" type="datetimeFigureOut">
               <a:rPr lang="zh-CN" altLang="en-US" smtClean="0"/>
-              <a:t>2025/6/6</a:t>
+              <a:t>2025/6/8</a:t>
             </a:fld>
             <a:endParaRPr lang="zh-CN" altLang="en-US"/>
           </a:p>
@@ -4871,7 +4911,7 @@
           <a:p>
             <a:fld id="{3CAF1464-0EA4-453D-A90B-03B04D244405}" type="datetimeFigureOut">
               <a:rPr lang="zh-CN" altLang="en-US" smtClean="0"/>
-              <a:t>2025/6/6</a:t>
+              <a:t>2025/6/8</a:t>
             </a:fld>
             <a:endParaRPr lang="zh-CN" altLang="en-US"/>
           </a:p>
@@ -5103,7 +5143,7 @@
           <a:p>
             <a:fld id="{3CAF1464-0EA4-453D-A90B-03B04D244405}" type="datetimeFigureOut">
               <a:rPr lang="zh-CN" altLang="en-US" smtClean="0"/>
-              <a:t>2025/6/6</a:t>
+              <a:t>2025/6/8</a:t>
             </a:fld>
             <a:endParaRPr lang="zh-CN" altLang="en-US"/>
           </a:p>
@@ -5470,7 +5510,7 @@
           <a:p>
             <a:fld id="{3CAF1464-0EA4-453D-A90B-03B04D244405}" type="datetimeFigureOut">
               <a:rPr lang="zh-CN" altLang="en-US" smtClean="0"/>
-              <a:t>2025/6/6</a:t>
+              <a:t>2025/6/8</a:t>
             </a:fld>
             <a:endParaRPr lang="zh-CN" altLang="en-US"/>
           </a:p>
@@ -5588,7 +5628,7 @@
           <a:p>
             <a:fld id="{3CAF1464-0EA4-453D-A90B-03B04D244405}" type="datetimeFigureOut">
               <a:rPr lang="zh-CN" altLang="en-US" smtClean="0"/>
-              <a:t>2025/6/6</a:t>
+              <a:t>2025/6/8</a:t>
             </a:fld>
             <a:endParaRPr lang="zh-CN" altLang="en-US"/>
           </a:p>
@@ -5683,7 +5723,7 @@
           <a:p>
             <a:fld id="{3CAF1464-0EA4-453D-A90B-03B04D244405}" type="datetimeFigureOut">
               <a:rPr lang="zh-CN" altLang="en-US" smtClean="0"/>
-              <a:t>2025/6/6</a:t>
+              <a:t>2025/6/8</a:t>
             </a:fld>
             <a:endParaRPr lang="zh-CN" altLang="en-US"/>
           </a:p>
@@ -5960,7 +6000,7 @@
           <a:p>
             <a:fld id="{3CAF1464-0EA4-453D-A90B-03B04D244405}" type="datetimeFigureOut">
               <a:rPr lang="zh-CN" altLang="en-US" smtClean="0"/>
-              <a:t>2025/6/6</a:t>
+              <a:t>2025/6/8</a:t>
             </a:fld>
             <a:endParaRPr lang="zh-CN" altLang="en-US"/>
           </a:p>
@@ -6217,7 +6257,7 @@
           <a:p>
             <a:fld id="{3CAF1464-0EA4-453D-A90B-03B04D244405}" type="datetimeFigureOut">
               <a:rPr lang="zh-CN" altLang="en-US" smtClean="0"/>
-              <a:t>2025/6/6</a:t>
+              <a:t>2025/6/8</a:t>
             </a:fld>
             <a:endParaRPr lang="zh-CN" altLang="en-US"/>
           </a:p>
@@ -6430,7 +6470,7 @@
           <a:p>
             <a:fld id="{3CAF1464-0EA4-453D-A90B-03B04D244405}" type="datetimeFigureOut">
               <a:rPr lang="zh-CN" altLang="en-US" smtClean="0"/>
-              <a:t>2025/6/6</a:t>
+              <a:t>2025/6/8</a:t>
             </a:fld>
             <a:endParaRPr lang="zh-CN" altLang="en-US"/>
           </a:p>
@@ -23678,7 +23718,7 @@
         </p:nvSpPr>
         <p:spPr>
           <a:xfrm>
-            <a:off x="123576" y="3105414"/>
+            <a:off x="123576" y="3409018"/>
             <a:ext cx="2450486" cy="647171"/>
           </a:xfrm>
           <a:prstGeom prst="rect">
@@ -23984,7 +24024,7 @@
         </p:nvSpPr>
         <p:spPr>
           <a:xfrm>
-            <a:off x="123576" y="4013084"/>
+            <a:off x="123576" y="4282113"/>
             <a:ext cx="2450486" cy="647171"/>
           </a:xfrm>
           <a:prstGeom prst="rect">
@@ -25928,7 +25968,7 @@
         <p:spPr>
           <a:xfrm flipV="1">
             <a:off x="2574062" y="3732603"/>
-            <a:ext cx="696234" cy="604067"/>
+            <a:ext cx="696234" cy="873096"/>
           </a:xfrm>
           <a:prstGeom prst="bentConnector3">
             <a:avLst>
@@ -25976,7 +26016,7 @@
         <p:spPr>
           <a:xfrm flipV="1">
             <a:off x="2574062" y="2612949"/>
-            <a:ext cx="691961" cy="816051"/>
+            <a:ext cx="691961" cy="1119655"/>
           </a:xfrm>
           <a:prstGeom prst="bentConnector3">
             <a:avLst>
@@ -26023,8 +26063,8 @@
         </p:nvCxnSpPr>
         <p:spPr>
           <a:xfrm>
-            <a:off x="2574062" y="4336670"/>
-            <a:ext cx="691961" cy="537291"/>
+            <a:off x="2574062" y="4605699"/>
+            <a:ext cx="691961" cy="268262"/>
           </a:xfrm>
           <a:prstGeom prst="bentConnector3">
             <a:avLst>
@@ -26072,7 +26112,7 @@
         <p:spPr>
           <a:xfrm flipV="1">
             <a:off x="2574062" y="2612949"/>
-            <a:ext cx="691961" cy="1723721"/>
+            <a:ext cx="691961" cy="1992750"/>
           </a:xfrm>
           <a:prstGeom prst="bentConnector3">
             <a:avLst>
@@ -27016,6 +27056,216 @@
           </a:p>
         </p:txBody>
       </p:sp>
+      <p:sp>
+        <p:nvSpPr>
+          <p:cNvPr id="25" name="矩形 24">
+            <a:extLst>
+              <a:ext uri="{FF2B5EF4-FFF2-40B4-BE49-F238E27FC236}">
+                <a16:creationId xmlns:a16="http://schemas.microsoft.com/office/drawing/2014/main" id="{2692B16A-D6BB-9683-C102-1C280F04577D}"/>
+              </a:ext>
+            </a:extLst>
+          </p:cNvPr>
+          <p:cNvSpPr/>
+          <p:nvPr/>
+        </p:nvSpPr>
+        <p:spPr>
+          <a:xfrm>
+            <a:off x="123576" y="2535923"/>
+            <a:ext cx="2450486" cy="647171"/>
+          </a:xfrm>
+          <a:prstGeom prst="rect">
+            <a:avLst/>
+          </a:prstGeom>
+          <a:solidFill>
+            <a:schemeClr val="bg1"/>
+          </a:solidFill>
+          <a:ln w="19050">
+            <a:solidFill>
+              <a:schemeClr val="tx1"/>
+            </a:solidFill>
+          </a:ln>
+        </p:spPr>
+        <p:style>
+          <a:lnRef idx="2">
+            <a:schemeClr val="accent1">
+              <a:shade val="50000"/>
+            </a:schemeClr>
+          </a:lnRef>
+          <a:fillRef idx="1">
+            <a:schemeClr val="accent1"/>
+          </a:fillRef>
+          <a:effectRef idx="0">
+            <a:schemeClr val="accent1"/>
+          </a:effectRef>
+          <a:fontRef idx="minor">
+            <a:schemeClr val="lt1"/>
+          </a:fontRef>
+        </p:style>
+        <p:txBody>
+          <a:bodyPr rtlCol="0" anchor="ctr"/>
+          <a:lstStyle/>
+          <a:p>
+            <a:pPr algn="ctr"/>
+            <a:r>
+              <a:rPr lang="en-US" altLang="zh-CN" sz="1400" dirty="0">
+                <a:solidFill>
+                  <a:schemeClr val="tx1"/>
+                </a:solidFill>
+                <a:latin typeface="Times New Roman" panose="02020603050405020304" pitchFamily="18" charset="0"/>
+                <a:cs typeface="Times New Roman" panose="02020603050405020304" pitchFamily="18" charset="0"/>
+              </a:rPr>
+              <a:t>Atmosphere</a:t>
+            </a:r>
+            <a:endParaRPr lang="en-GB" sz="1400" i="1" noProof="0" dirty="0">
+              <a:solidFill>
+                <a:schemeClr val="tx1"/>
+              </a:solidFill>
+              <a:latin typeface="Times New Roman" panose="02020603050405020304" pitchFamily="18" charset="0"/>
+              <a:cs typeface="Times New Roman" panose="02020603050405020304" pitchFamily="18" charset="0"/>
+            </a:endParaRPr>
+          </a:p>
+          <a:p>
+            <a:pPr algn="ctr"/>
+            <a:r>
+              <a:rPr lang="en-GB" sz="1600" dirty="0">
+                <a:solidFill>
+                  <a:schemeClr val="tx1"/>
+                </a:solidFill>
+                <a:latin typeface="Times New Roman" panose="02020603050405020304" pitchFamily="18" charset="0"/>
+                <a:cs typeface="Times New Roman" panose="02020603050405020304" pitchFamily="18" charset="0"/>
+              </a:rPr>
+              <a:t>[</a:t>
+            </a:r>
+            <a:r>
+              <a:rPr lang="el-GR" sz="1600" i="1" dirty="0">
+                <a:solidFill>
+                  <a:schemeClr val="tx1"/>
+                </a:solidFill>
+                <a:latin typeface="Times New Roman" panose="02020603050405020304" pitchFamily="18" charset="0"/>
+                <a:ea typeface="等线" panose="02010600030101010101" pitchFamily="2" charset="-122"/>
+                <a:cs typeface="Times New Roman" panose="02020603050405020304" pitchFamily="18" charset="0"/>
+              </a:rPr>
+              <a:t>ρ</a:t>
+            </a:r>
+            <a:r>
+              <a:rPr lang="en-GB" sz="1600" dirty="0">
+                <a:solidFill>
+                  <a:schemeClr val="tx1"/>
+                </a:solidFill>
+                <a:latin typeface="Times New Roman" panose="02020603050405020304" pitchFamily="18" charset="0"/>
+                <a:cs typeface="Times New Roman" panose="02020603050405020304" pitchFamily="18" charset="0"/>
+              </a:rPr>
+              <a:t>, </a:t>
+            </a:r>
+            <a:r>
+              <a:rPr lang="en-GB" sz="1600" i="1" dirty="0">
+                <a:solidFill>
+                  <a:schemeClr val="tx1"/>
+                </a:solidFill>
+                <a:latin typeface="Times New Roman" panose="02020603050405020304" pitchFamily="18" charset="0"/>
+                <a:cs typeface="Times New Roman" panose="02020603050405020304" pitchFamily="18" charset="0"/>
+              </a:rPr>
+              <a:t>a</a:t>
+            </a:r>
+            <a:r>
+              <a:rPr lang="en-GB" sz="1600" dirty="0">
+                <a:solidFill>
+                  <a:schemeClr val="tx1"/>
+                </a:solidFill>
+                <a:latin typeface="Times New Roman" panose="02020603050405020304" pitchFamily="18" charset="0"/>
+                <a:cs typeface="Times New Roman" panose="02020603050405020304" pitchFamily="18" charset="0"/>
+              </a:rPr>
+              <a:t>, </a:t>
+            </a:r>
+            <a:r>
+              <a:rPr lang="el-GR" sz="1600" i="1" dirty="0">
+                <a:solidFill>
+                  <a:schemeClr val="tx1"/>
+                </a:solidFill>
+                <a:latin typeface="Times New Roman" panose="02020603050405020304" pitchFamily="18" charset="0"/>
+                <a:cs typeface="Times New Roman" panose="02020603050405020304" pitchFamily="18" charset="0"/>
+              </a:rPr>
+              <a:t>μ</a:t>
+            </a:r>
+            <a:r>
+              <a:rPr lang="en-US" sz="1600" dirty="0">
+                <a:solidFill>
+                  <a:schemeClr val="tx1"/>
+                </a:solidFill>
+                <a:latin typeface="Times New Roman" panose="02020603050405020304" pitchFamily="18" charset="0"/>
+                <a:ea typeface="等线" panose="02010600030101010101" pitchFamily="2" charset="-122"/>
+                <a:cs typeface="Times New Roman" panose="02020603050405020304" pitchFamily="18" charset="0"/>
+              </a:rPr>
+              <a:t>]</a:t>
+            </a:r>
+            <a:r>
+              <a:rPr lang="en-GB" sz="1600" dirty="0">
+                <a:solidFill>
+                  <a:schemeClr val="tx1"/>
+                </a:solidFill>
+                <a:latin typeface="Times New Roman" panose="02020603050405020304" pitchFamily="18" charset="0"/>
+                <a:cs typeface="Times New Roman" panose="02020603050405020304" pitchFamily="18" charset="0"/>
+              </a:rPr>
+              <a:t> </a:t>
+            </a:r>
+            <a:endParaRPr lang="en-GB" sz="1600" noProof="0" dirty="0">
+              <a:solidFill>
+                <a:schemeClr val="tx1"/>
+              </a:solidFill>
+              <a:latin typeface="Times New Roman" panose="02020603050405020304" pitchFamily="18" charset="0"/>
+              <a:cs typeface="Times New Roman" panose="02020603050405020304" pitchFamily="18" charset="0"/>
+            </a:endParaRPr>
+          </a:p>
+        </p:txBody>
+      </p:sp>
+      <p:cxnSp>
+        <p:nvCxnSpPr>
+          <p:cNvPr id="26" name="连接符: 肘形 25">
+            <a:extLst>
+              <a:ext uri="{FF2B5EF4-FFF2-40B4-BE49-F238E27FC236}">
+                <a16:creationId xmlns:a16="http://schemas.microsoft.com/office/drawing/2014/main" id="{9851B9C7-BFB3-04FB-8FA2-EAB5DE072A63}"/>
+              </a:ext>
+            </a:extLst>
+          </p:cNvPr>
+          <p:cNvCxnSpPr>
+            <a:cxnSpLocks/>
+            <a:stCxn id="25" idx="3"/>
+            <a:endCxn id="15" idx="1"/>
+          </p:cNvCxnSpPr>
+          <p:nvPr/>
+        </p:nvCxnSpPr>
+        <p:spPr>
+          <a:xfrm flipV="1">
+            <a:off x="2574062" y="2612949"/>
+            <a:ext cx="691961" cy="246560"/>
+          </a:xfrm>
+          <a:prstGeom prst="bentConnector3">
+            <a:avLst>
+              <a:gd name="adj1" fmla="val 50000"/>
+            </a:avLst>
+          </a:prstGeom>
+          <a:ln w="12700">
+            <a:solidFill>
+              <a:schemeClr val="tx1"/>
+            </a:solidFill>
+            <a:tailEnd type="triangle"/>
+          </a:ln>
+        </p:spPr>
+        <p:style>
+          <a:lnRef idx="2">
+            <a:schemeClr val="accent1"/>
+          </a:lnRef>
+          <a:fillRef idx="0">
+            <a:schemeClr val="accent1"/>
+          </a:fillRef>
+          <a:effectRef idx="1">
+            <a:schemeClr val="accent1"/>
+          </a:effectRef>
+          <a:fontRef idx="minor">
+            <a:schemeClr val="tx1"/>
+          </a:fontRef>
+        </p:style>
+      </p:cxnSp>
     </p:spTree>
     <p:extLst>
       <p:ext uri="{BB962C8B-B14F-4D97-AF65-F5344CB8AC3E}">

</xml_diff>